<commit_message>
docs: scope the serving claim, qualify the Ridge recommendation, lead with observed-day alarm rates
- README: the fusion model serves recorded-data replays; synthetic replays keep their separate,
  fixed dynamic-only demonstration model
- research review / model card / README / deck: the Ridge recommendation belongs to the nested
  protocol; the candidate reads CGM only, so it is not eligible under the two-stream serving
  requirement and is not the submission demo model (generated from the registry's serving protocol)
- narration, README, jury notes and slide 16 lead with false alarms per observed patient-day
  (1.49; persistence 2.61); the per-eligible-day rate stays alongside and in the detailed tables
</commit_message>
<xml_diff>
--- a/docs/submission/GlucoTwin_Presentation.pptx
+++ b/docs/submission/GlucoTwin_Presentation.pptx
@@ -4632,7 +4632,7 @@
                 </a:solidFill>
                 <a:latin typeface="Arial"/>
               </a:rPr>
-              <a:t>•  60-min warning (test, margin threshold -10 mg/dL chosen on validation by F1): 61/64 new onsets detected, precision 0.60, 40 false alarms (2.28 per eligible patient-day); forecast lead median 30 min (episode start 30 min).</a:t>
+              <a:t>•  60-min warning (test, margin threshold -10 mg/dL chosen on validation by F1): 61/64 new onsets detected, precision 0.60, 40 false alarms (1.49 per observed patient-day; 2.28 per eligible day); forecast lead median 30 min (episode start 30 min).</a:t>
             </a:r>
           </a:p>
           <a:p>
@@ -4648,7 +4648,7 @@
                 </a:solidFill>
                 <a:latin typeface="Arial"/>
               </a:rPr>
-              <a:t>•  Same procedure on persistence (fires at glucose ≥ 150): 63/64 detected, 70 false alarms (4.00 per eligible day).</a:t>
+              <a:t>•  Same procedure on persistence (fires at glucose ≥ 150): 63/64 detected, 70 false alarms (2.61 per observed patient-day; 4.00 per eligible day).</a:t>
             </a:r>
           </a:p>
           <a:p>
@@ -4928,7 +4928,7 @@
                 </a:solidFill>
                 <a:latin typeface="Arial"/>
               </a:rPr>
-              <a:t>•  Not promoted. CGMacros was already inspected, so its folds are internal validation; the next protocol also bounds high-glucose error, missed onsets and false warnings (declared, not run).</a:t>
+              <a:t>•  Not promoted, and not eligible as the demo model: the Ridge candidate reads CGM only. CGMacros was already inspected, so its folds are internal validation; the next protocol also bounds high-glucose error, missed onsets and false warnings (declared, not run).</a:t>
             </a:r>
           </a:p>
         </p:txBody>

</xml_diff>

<commit_message>
docs: require a minimum 20-minute video per the challenge page; state that the final test holds later recordings of the same 14 participants
Rechecked the challenge page on 14 Oct 2026 (D-040): target 20:15 so neither the
rendered file nor YouTube's displayed duration falls below 20:00. Evidence wording
and slides now say the test is over time, not on new patients, and report
per-participant range coverage and persistence false-alarm rates.
</commit_message>
<xml_diff>
--- a/docs/submission/GlucoTwin_Presentation.pptx
+++ b/docs/submission/GlucoTwin_Presentation.pptx
@@ -3716,7 +3716,7 @@
                 </a:solidFill>
                 <a:latin typeface="Arial"/>
               </a:rPr>
-              <a:t>Recorded-data replay in the held-out test period: current glucose, 30/60-minute forecasts with prediction ranges (target coverage 80 %), saved earlier forecasts, research warnings with outcomes, review status and data quality.</a:t>
+              <a:t>Recorded-data replay in the final test period (later recordings of participants the model was trained on): current glucose, 30/60-minute forecasts with prediction ranges (target coverage 80 %), saved earlier forecasts, research warnings with outcomes, review status and data quality.</a:t>
             </a:r>
           </a:p>
         </p:txBody>
@@ -3998,7 +3998,7 @@
                 </a:solidFill>
                 <a:latin typeface="Arial"/>
               </a:rPr>
-              <a:t>Measured evaluation: forecast accuracy (held-out test)</a:t>
+              <a:t>Measured evaluation: forecast accuracy (later days)</a:t>
             </a:r>
           </a:p>
         </p:txBody>
@@ -4090,7 +4090,7 @@
                 </a:solidFill>
                 <a:latin typeface="Arial"/>
               </a:rPr>
-              <a:t>Serving − persistence: -1.88 mg/dL [-2.53, -1.32] at 30 min, -2.96 mg/dL [-4.34, -1.77] at 60 min. Test origins 7,730 (≈ 644 h); forecasts issued for 99.9 % of origins with a target.</a:t>
+              <a:t>Later recordings of the same 14 participants the model was trained on — not new patients. Serving − persistence: -1.88 mg/dL [-2.53, -1.32] at 30 min, -2.96 mg/dL [-4.34, -1.77] at 60 min. Test origins 7,730 (≈ 644 h); forecasts issued for 99.9 % of origins with a target.</a:t>
             </a:r>
           </a:p>
         </p:txBody>
@@ -4664,7 +4664,7 @@
                 </a:solidFill>
                 <a:latin typeface="Arial"/>
               </a:rPr>
-              <a:t>•  Prediction ranges (target coverage 80 %) covered 74.2 % (30 min) and 74.0 % (60 min) on test — under-covered; no guarantee claimed.</a:t>
+              <a:t>•  Prediction ranges (target coverage 80 %) covered 74.2 % (30 min) and 74.0 % (60 min) on test, 60–82 % and 51–88 % per participant — under-covered; no guarantee claimed.</a:t>
             </a:r>
           </a:p>
           <a:p>
@@ -5128,7 +5128,7 @@
                 </a:solidFill>
                 <a:latin typeface="Arial"/>
               </a:rPr>
-              <a:t>•  Measured on held-out test (retrospective): 14/14 participants improved over persistence at 30 min and 13/14 at 60 min; MAE 12.96 / 20.26 mg/dL vs 14.84 / 23.23.</a:t>
+              <a:t>•  Measured on later recordings of the same participants (retrospective): 14/14 participants improved over persistence at 30 min and 13/14 at 60 min; MAE 12.96 / 20.26 mg/dL vs 14.84 / 23.23.</a:t>
             </a:r>
           </a:p>
           <a:p>
@@ -5144,7 +5144,7 @@
                 </a:solidFill>
                 <a:latin typeface="Arial"/>
               </a:rPr>
-              <a:t>•  Personalization: small gains (-0.18 mg/dL and -0.33 mg/dL). Warnings: 61/64 onsets detected with 40 false alarms — the F1 threshold rule ignores review workload.</a:t>
+              <a:t>•  Personalization: small gains (-0.18 mg/dL and -0.33 mg/dL). Warnings: 61/64 onsets detected with 40 false alarms (1.49 per observed patient-day) — the F1 threshold rule ignores review workload.</a:t>
             </a:r>
           </a:p>
           <a:p>
@@ -6104,7 +6104,7 @@
                 </a:solidFill>
                 <a:latin typeface="Arial"/>
               </a:rPr>
-              <a:t>•  Demo video (20:00): unlisted YouTube link — added after recording and upload. Architecture: docs/submission/GlucoTwin_Architecture.pdf.</a:t>
+              <a:t>•  Demo video (at least 20 minutes): unlisted YouTube link — added after recording and upload. Architecture: docs/submission/GlucoTwin_Architecture.pdf.</a:t>
             </a:r>
           </a:p>
           <a:p>

</xml_diff>

<commit_message>
docs: add the team's college (VESIT, Mumbai) to the README, team details, checklist and slides
College supplied by the team on 17 Oct 2026 (D-041); slides rebuilt from configs/submission.yaml. Proposed folder name Kryptonite_VESIT recorded in the checklist.
</commit_message>
<xml_diff>
--- a/docs/submission/GlucoTwin_Presentation.pptx
+++ b/docs/submission/GlucoTwin_Presentation.pptx
@@ -3256,7 +3256,7 @@
                 </a:solidFill>
                 <a:latin typeface="Arial"/>
               </a:rPr>
-              <a:t>College / incubator: to be confirmed by the team</a:t>
+              <a:t>Vivekanand Education Society's Institute of Technology (VESIT), Mumbai</a:t>
             </a:r>
           </a:p>
           <a:p>
@@ -5876,7 +5876,7 @@
                 </a:solidFill>
                 <a:latin typeface="Arial"/>
               </a:rPr>
-              <a:t>•  Team Kryptonite — Avinash Gehi (team leader) · Hardik Hinduja. College / incubator: to be confirmed by the team.</a:t>
+              <a:t>•  Team Kryptonite — Avinash Gehi (team leader) · Hardik Hinduja. Vivekanand Education Society's Institute of Technology (VESIT), Mumbai.</a:t>
             </a:r>
           </a:p>
           <a:p>

</xml_diff>

<commit_message>
docs: add the Kryptonite_VESIT team folder; open the README with labelled results; brand slides and README
* Kryptonite_VESIT/ indexes the submission files for the challenge's Team Name_College Name rule (generated by
  build_submission_assets.py from configs/submission.yaml; check_submission.py now checks its links).
* README opens with a pitch, a results table in which every row names its model and evaluation setting, then the
  screenshot; the three-model notes move to section 7. Heading and slide 1: "Team Kryptonite · VESIT".
* A Mumbai example in the README, slide 3 and the demo script, labelled hypothetical; one person reviewed at a time.
* "Scores depend on the dataset, prediction task and evaluation protocol" in the README, slide 19 and demo script.
* Demo-script word counts recounted; checklist and access audit dated 19 Oct 2026; decision D-042.

No model, data, metric or experiment changed.

Co-Authored-By: Claude Opus 5.5 <noreply@anthropic.com>
</commit_message>
<xml_diff>
--- a/docs/submission/GlucoTwin_Presentation.pptx
+++ b/docs/submission/GlucoTwin_Presentation.pptx
@@ -3228,35 +3228,46 @@
           <a:lstStyle/>
           <a:p>
             <a:r>
-              <a:rPr sz="1800" b="0">
+              <a:rPr sz="2000" b="1">
+                <a:solidFill>
+                  <a:srgbClr val="0B1220"/>
+                </a:solidFill>
+                <a:latin typeface="Arial"/>
+              </a:rPr>
+              <a:t>Team Kryptonite · VESIT</a:t>
+            </a:r>
+          </a:p>
+          <a:p>
+            <a:r>
+              <a:rPr sz="1800">
+                <a:solidFill>
+                  <a:srgbClr val="0B1220"/>
+                </a:solidFill>
+                <a:latin typeface="Arial"/>
+              </a:rPr>
+              <a:t>Avinash Gehi (team leader) · Hardik Hinduja</a:t>
+            </a:r>
+          </a:p>
+          <a:p>
+            <a:r>
+              <a:rPr sz="1800">
+                <a:solidFill>
+                  <a:srgbClr val="0B1220"/>
+                </a:solidFill>
+                <a:latin typeface="Arial"/>
+              </a:rPr>
+              <a:t>Vivekanand Education Society's Institute of Technology (VESIT), Mumbai</a:t>
+            </a:r>
+          </a:p>
+          <a:p>
+            <a:r>
+              <a:rPr sz="1800">
                 <a:solidFill>
                   <a:srgbClr val="0B1220"/>
                 </a:solidFill>
                 <a:latin typeface="Arial"/>
               </a:rPr>
               <a:t>Digital Twin Challenge 2026 · Happiest Health</a:t>
-            </a:r>
-          </a:p>
-          <a:p>
-            <a:r>
-              <a:rPr sz="1800">
-                <a:solidFill>
-                  <a:srgbClr val="0B1220"/>
-                </a:solidFill>
-                <a:latin typeface="Arial"/>
-              </a:rPr>
-              <a:t>Team Kryptonite — Avinash Gehi (team leader) · Hardik Hinduja</a:t>
-            </a:r>
-          </a:p>
-          <a:p>
-            <a:r>
-              <a:rPr sz="1800">
-                <a:solidFill>
-                  <a:srgbClr val="0B1220"/>
-                </a:solidFill>
-                <a:latin typeface="Arial"/>
-              </a:rPr>
-              <a:t>Vivekanand Education Society's Institute of Technology (VESIT), Mumbai</a:t>
             </a:r>
           </a:p>
           <a:p>
@@ -5289,6 +5300,22 @@
               <a:t>•  Retrospective replay only: no clinician workflow, outcome or safety study. Optional Chronos-Bolt not run.</a:t>
             </a:r>
           </a:p>
+          <a:p>
+            <a:pPr>
+              <a:spcAft>
+                <a:spcPts val="1000"/>
+              </a:spcAft>
+            </a:pPr>
+            <a:r>
+              <a:rPr sz="1700">
+                <a:solidFill>
+                  <a:srgbClr val="0B1220"/>
+                </a:solidFill>
+                <a:latin typeface="Arial"/>
+              </a:rPr>
+              <a:t>•  Scores depend on the dataset, prediction task and evaluation protocol; performance on simulated patients does not establish performance on real patients.</a:t>
+            </a:r>
+          </a:p>
         </p:txBody>
       </p:sp>
     </p:spTree>
@@ -6094,7 +6121,7 @@
                 </a:solidFill>
                 <a:latin typeface="Arial"/>
               </a:rPr>
-              <a:t>•  User: a clinician reviewing a small monitored cohort; secondary user: a reviewer inspecting evidence.</a:t>
+              <a:t>•  Hypothetical example (an illustration, not a deployment): a diabetes educator in Mumbai follows adults with Type 2 diabetes who wear CGMs between quarterly visits, and opens one person’s replay to see forecasts, warnings and the data behind them.</a:t>
             </a:r>
           </a:p>
           <a:p>
@@ -6110,7 +6137,23 @@
                 </a:solidFill>
                 <a:latin typeface="Arial"/>
               </a:rPr>
-              <a:t>•  Workflow (proposed): baseline labs at a visit → CGM + wearable measurements → twin forecasts → review list.</a:t>
+              <a:t>•  User: a clinician reviewing a small monitored cohort; secondary user: a reviewer inspecting evidence.</a:t>
+            </a:r>
+          </a:p>
+          <a:p>
+            <a:pPr>
+              <a:spcAft>
+                <a:spcPts val="1000"/>
+              </a:spcAft>
+            </a:pPr>
+            <a:r>
+              <a:rPr sz="1700">
+                <a:solidFill>
+                  <a:srgbClr val="0B1220"/>
+                </a:solidFill>
+                <a:latin typeface="Arial"/>
+              </a:rPr>
+              <a:t>•  Workflow (proposed): baseline labs at a visit → CGM + wearable measurements → twin forecasts → warnings reviewed one person at a time (no multi-patient queue yet).</a:t>
             </a:r>
           </a:p>
           <a:p>

</xml_diff>

<commit_message>
docs(deck): slide 20 on the D-046 re-analysis; 24 slides; narration and target length updated
</commit_message>
<xml_diff>
--- a/docs/submission/GlucoTwin_Presentation.pptx
+++ b/docs/submission/GlucoTwin_Presentation.pptx
@@ -28,6 +28,7 @@
     <p:sldId id="276" r:id="rId27"/>
     <p:sldId id="277" r:id="rId28"/>
     <p:sldId id="278" r:id="rId29"/>
+    <p:sldId id="279" r:id="rId30"/>
   </p:sldIdLst>
   <p:sldSz cx="12191695" cy="6858000" type="screen4x3"/>
   <p:notesSz cx="6858000" cy="9144000"/>
@@ -5561,7 +5562,7 @@
                 </a:solidFill>
                 <a:latin typeface="Arial"/>
               </a:rPr>
-              <a:t>Project outcomes</a:t>
+              <a:t>Research: what we fixed, and what we could not</a:t>
             </a:r>
           </a:p>
         </p:txBody>
@@ -5655,7 +5656,7 @@
                 </a:solidFill>
                 <a:latin typeface="Arial"/>
               </a:rPr>
-              <a:t>•  Built: a working personalized glucose twin — replay API with a backend-owned clock, immutable forecasts, research warnings with outcomes — and a clinician workspace (landing page, Overview, Participants, Replay sessions, Model evidence, Data quality).</a:t>
+              <a:t>•  Declared and committed before any arm was computed (D-046): the saved two-hour predictions re-analysed, every choice made on development people, the outer people read once. Same 14 already-inspected people: internal validation.</a:t>
             </a:r>
           </a:p>
           <a:p>
@@ -5671,7 +5672,7 @@
                 </a:solidFill>
                 <a:latin typeface="Arial"/>
               </a:rPr>
-              <a:t>•  Found and corrected a data-provenance problem: the published 1-minute CGM values are interpolated; only native 5-minute readings are used.</a:t>
+              <a:t>•  Fixed — prediction ranges: calibrating on all development people instead of 2 per fold raised two-hour coverage from 76.5 % to 79.8 % (target 80 %; 60 min 78.2 → 79.5 %), ranges 7 mg/dL wider.</a:t>
             </a:r>
           </a:p>
           <a:p>
@@ -5687,7 +5688,7 @@
                 </a:solidFill>
                 <a:latin typeface="Arial"/>
               </a:rPr>
-              <a:t>•  Measured on later recordings of the same participants (retrospective): 14/14 participants improved over persistence at 30 min and 13/14 at 60 min; MAE 12.96 / 20.26 mg/dL vs 14.84 / 23.23.</a:t>
+              <a:t>•  Not shown — earlier warning: 126 vs 123 of 329 onsets warned ≥ 30 min ahead (+0.9 points [-5.5, +6.6]) at the same workload; median lead still 15 min.</a:t>
             </a:r>
           </a:p>
           <a:p>
@@ -5703,7 +5704,7 @@
                 </a:solidFill>
                 <a:latin typeface="Arial"/>
               </a:rPr>
-              <a:t>•  Personalization: small gains (-0.18 mg/dL and -0.33 mg/dL). Warnings: 61/64 onsets detected with 40 false alarms (1.49 per observed patient-day) — the F1 threshold rule ignores review workload.</a:t>
+              <a:t>•  Not shown — health record as a new person's starting correction: -0.53 [-1.57, +0.58] mg/dL at 120 min, -0.93 [-2.74, +0.48] in the first 24 hours; the intervals cross zero, so no benefit is claimed.</a:t>
             </a:r>
           </a:p>
           <a:p>
@@ -5719,23 +5720,7 @@
                 </a:solidFill>
                 <a:latin typeface="Arial"/>
               </a:rPr>
-              <a:t>•  Corrected after an independent review (activity-window defect, online warning double-credit; gt-primary-2026-10-11-v1 preserved), then re-run with the fusion constraint (gt-primary-2026-10-13-fusion); the dynamic-only model of gt-primary-2026-10-11-v2 stays registered for rollback.</a:t>
-            </a:r>
-          </a:p>
-          <a:p>
-            <a:pPr>
-              <a:spcAft>
-                <a:spcPts val="1000"/>
-              </a:spcAft>
-            </a:pPr>
-            <a:r>
-              <a:rPr sz="1700">
-                <a:solidFill>
-                  <a:srgbClr val="0B1220"/>
-                </a:solidFill>
-                <a:latin typeface="Arial"/>
-              </a:rPr>
-              <a:t>•  Reproducible: synthetic mode needs no download; recorded-data results regenerate from versioned configs; a fresh copy passes the automated backend, frontend and browser tests.</a:t>
+              <a:t>•  The demo model's ranges are already pooled over all 14 people; its under-coverage comes from drift between time segments, so this fix is not applied to it.</a:t>
             </a:r>
           </a:p>
         </p:txBody>
@@ -5795,7 +5780,7 @@
                 </a:solidFill>
                 <a:latin typeface="Arial"/>
               </a:rPr>
-              <a:t>Limitations</a:t>
+              <a:t>Project outcomes</a:t>
             </a:r>
           </a:p>
         </p:txBody>
@@ -5889,7 +5874,7 @@
                 </a:solidFill>
                 <a:latin typeface="Arial"/>
               </a:rPr>
-              <a:t>•  14 participants from one US site; overlapping windows are not independent patients.</a:t>
+              <a:t>•  Built: a working personalized glucose twin — replay API with a backend-owned clock, immutable forecasts, research warnings with outcomes — and a clinician workspace (landing page, Overview, Participants, Replay sessions, Model evidence, Data quality).</a:t>
             </a:r>
           </a:p>
           <a:p>
@@ -5905,7 +5890,7 @@
                 </a:solidFill>
                 <a:latin typeface="Arial"/>
               </a:rPr>
-              <a:t>•  No Indian participants — nothing here establishes performance for patients in India.</a:t>
+              <a:t>•  Found and corrected a data-provenance problem: the published 1-minute CGM values are interpolated; only native 5-minute readings are used.</a:t>
             </a:r>
           </a:p>
           <a:p>
@@ -5921,7 +5906,7 @@
                 </a:solidFill>
                 <a:latin typeface="Arial"/>
               </a:rPr>
-              <a:t>•  Blinded research CGMs replayed with assumed zero latency; native timestamps known to the minute.</a:t>
+              <a:t>•  Measured on later recordings of the same participants (retrospective): 14/14 participants improved over persistence at 30 min and 13/14 at 60 min; MAE 12.96 / 20.26 mg/dL vs 14.84 / 23.23.</a:t>
             </a:r>
           </a:p>
           <a:p>
@@ -5937,7 +5922,7 @@
                 </a:solidFill>
                 <a:latin typeface="Arial"/>
               </a:rPr>
-              <a:t>•  Medication and insulin use unknown; meal logging time undocumented.</a:t>
+              <a:t>•  Personalization: small gains (-0.18 mg/dL and -0.33 mg/dL). Warnings: 61/64 onsets detected with 40 false alarms (1.49 per observed patient-day) — the F1 threshold rule ignores review workload.</a:t>
             </a:r>
           </a:p>
           <a:p>
@@ -5953,7 +5938,7 @@
                 </a:solidFill>
                 <a:latin typeface="Arial"/>
               </a:rPr>
-              <a:t>•  Profile fusion: profile values are constant per person, so with 14 people they can act as an identity code; no benefit was shown on people held out entirely.</a:t>
+              <a:t>•  Corrected after an independent review (activity-window defect, online warning double-credit; gt-primary-2026-10-11-v1 preserved), then re-run with the fusion constraint (gt-primary-2026-10-13-fusion); the dynamic-only model of gt-primary-2026-10-11-v2 stays registered for rollback.</a:t>
             </a:r>
           </a:p>
           <a:p>
@@ -5969,39 +5954,7 @@
                 </a:solidFill>
                 <a:latin typeface="Arial"/>
               </a:rPr>
-              <a:t>•  Prediction ranges under-cover; the warning score is uncalibrated and its threshold rule (F1) ignores review workload; 180 mg/dL is a research threshold, not triage.</a:t>
-            </a:r>
-          </a:p>
-          <a:p>
-            <a:pPr>
-              <a:spcAft>
-                <a:spcPts val="1000"/>
-              </a:spcAft>
-            </a:pPr>
-            <a:r>
-              <a:rPr sz="1700">
-                <a:solidFill>
-                  <a:srgbClr val="0B1220"/>
-                </a:solidFill>
-                <a:latin typeface="Arial"/>
-              </a:rPr>
-              <a:t>•  Retrospective replay only: no clinician workflow, outcome or safety study. Optional Chronos-Bolt not run.</a:t>
-            </a:r>
-          </a:p>
-          <a:p>
-            <a:pPr>
-              <a:spcAft>
-                <a:spcPts val="1000"/>
-              </a:spcAft>
-            </a:pPr>
-            <a:r>
-              <a:rPr sz="1700">
-                <a:solidFill>
-                  <a:srgbClr val="0B1220"/>
-                </a:solidFill>
-                <a:latin typeface="Arial"/>
-              </a:rPr>
-              <a:t>•  Scores depend on the dataset, prediction task and evaluation protocol; performance on simulated patients does not establish performance on real patients.</a:t>
+              <a:t>•  Reproducible: synthetic mode needs no download; recorded-data results regenerate from versioned configs; a fresh copy passes the automated backend, frontend and browser tests.</a:t>
             </a:r>
           </a:p>
         </p:txBody>
@@ -6061,7 +6014,7 @@
                 </a:solidFill>
                 <a:latin typeface="Arial"/>
               </a:rPr>
-              <a:t>Next steps: evidence needed for Indian patients</a:t>
+              <a:t>Limitations</a:t>
             </a:r>
           </a:p>
         </p:txBody>
@@ -6155,7 +6108,7 @@
                 </a:solidFill>
                 <a:latin typeface="Arial"/>
               </a:rPr>
-              <a:t>•  Prospective, consented Indian cohort with unblinded CGMs, recorded transmission latency, medications and meal logging times.</a:t>
+              <a:t>•  14 participants from one US site; overlapping windows are not independent patients.</a:t>
             </a:r>
           </a:p>
           <a:p>
@@ -6171,7 +6124,7 @@
                 </a:solidFill>
                 <a:latin typeface="Arial"/>
               </a:rPr>
-              <a:t>•  Re-evaluate held-out participants (cold start) and per-site calibration; report subgroup performance.</a:t>
+              <a:t>•  No Indian participants — nothing here establishes performance for patients in India.</a:t>
             </a:r>
           </a:p>
           <a:p>
@@ -6187,7 +6140,7 @@
                 </a:solidFill>
                 <a:latin typeface="Arial"/>
               </a:rPr>
-              <a:t>•  AI-READI five-minute CGM and wearable data (access not yet requested; steps listed) for a larger new-person evaluation under the declared protocol gt-nested-2026-10-12-v2.</a:t>
+              <a:t>•  Blinded research CGMs replayed with assumed zero latency; native timestamps known to the minute.</a:t>
             </a:r>
           </a:p>
           <a:p>
@@ -6203,7 +6156,7 @@
                 </a:solidFill>
                 <a:latin typeface="Arial"/>
               </a:rPr>
-              <a:t>•  Clinician usability study of the review workflow; regulatory and data-protection review (DPDP Act).</a:t>
+              <a:t>•  Medication and insulin use unknown; meal logging time undocumented.</a:t>
             </a:r>
           </a:p>
           <a:p>
@@ -6219,7 +6172,55 @@
                 </a:solidFill>
                 <a:latin typeface="Arial"/>
               </a:rPr>
-              <a:t>•  Optional: compare a fine-tuned time-series foundation model (e.g. Chronos-Bolt) under the same protocol.</a:t>
+              <a:t>•  Profile fusion: profile values are constant per person, so with 14 people they can act as an identity code; no benefit was shown on people held out entirely.</a:t>
+            </a:r>
+          </a:p>
+          <a:p>
+            <a:pPr>
+              <a:spcAft>
+                <a:spcPts val="1000"/>
+              </a:spcAft>
+            </a:pPr>
+            <a:r>
+              <a:rPr sz="1700">
+                <a:solidFill>
+                  <a:srgbClr val="0B1220"/>
+                </a:solidFill>
+                <a:latin typeface="Arial"/>
+              </a:rPr>
+              <a:t>•  Prediction ranges under-cover; the warning score is uncalibrated and its threshold rule (F1) ignores review workload; 180 mg/dL is a research threshold, not triage.</a:t>
+            </a:r>
+          </a:p>
+          <a:p>
+            <a:pPr>
+              <a:spcAft>
+                <a:spcPts val="1000"/>
+              </a:spcAft>
+            </a:pPr>
+            <a:r>
+              <a:rPr sz="1700">
+                <a:solidFill>
+                  <a:srgbClr val="0B1220"/>
+                </a:solidFill>
+                <a:latin typeface="Arial"/>
+              </a:rPr>
+              <a:t>•  Retrospective replay only: no clinician workflow, outcome or safety study. Optional Chronos-Bolt not run.</a:t>
+            </a:r>
+          </a:p>
+          <a:p>
+            <a:pPr>
+              <a:spcAft>
+                <a:spcPts val="1000"/>
+              </a:spcAft>
+            </a:pPr>
+            <a:r>
+              <a:rPr sz="1700">
+                <a:solidFill>
+                  <a:srgbClr val="0B1220"/>
+                </a:solidFill>
+                <a:latin typeface="Arial"/>
+              </a:rPr>
+              <a:t>•  Scores depend on the dataset, prediction task and evaluation protocol; performance on simulated patients does not establish performance on real patients.</a:t>
             </a:r>
           </a:p>
         </p:txBody>
@@ -6279,7 +6280,7 @@
                 </a:solidFill>
                 <a:latin typeface="Arial"/>
               </a:rPr>
-              <a:t>Team, links, reproducibility and licenses</a:t>
+              <a:t>Next steps: evidence needed for Indian patients</a:t>
             </a:r>
           </a:p>
         </p:txBody>
@@ -6335,6 +6336,224 @@
                 <a:latin typeface="Arial"/>
               </a:rPr>
               <a:t>23</a:t>
+            </a:r>
+          </a:p>
+        </p:txBody>
+      </p:sp>
+      <p:sp>
+        <p:nvSpPr>
+          <p:cNvPr id="5" name="TextBox 4"/>
+          <p:cNvSpPr txBox="1"/>
+          <p:nvPr/>
+        </p:nvSpPr>
+        <p:spPr>
+          <a:xfrm>
+            <a:off x="548640" y="1234440"/>
+            <a:ext cx="11064240" cy="5120640"/>
+          </a:xfrm>
+          <a:prstGeom prst="rect">
+            <a:avLst/>
+          </a:prstGeom>
+          <a:noFill/>
+        </p:spPr>
+        <p:txBody>
+          <a:bodyPr wrap="square">
+            <a:spAutoFit/>
+          </a:bodyPr>
+          <a:lstStyle/>
+          <a:p>
+            <a:pPr>
+              <a:spcAft>
+                <a:spcPts val="1000"/>
+              </a:spcAft>
+            </a:pPr>
+            <a:r>
+              <a:rPr sz="1700">
+                <a:solidFill>
+                  <a:srgbClr val="0B1220"/>
+                </a:solidFill>
+                <a:latin typeface="Arial"/>
+              </a:rPr>
+              <a:t>•  Prospective, consented Indian cohort with unblinded CGMs, recorded transmission latency, medications and meal logging times.</a:t>
+            </a:r>
+          </a:p>
+          <a:p>
+            <a:pPr>
+              <a:spcAft>
+                <a:spcPts val="1000"/>
+              </a:spcAft>
+            </a:pPr>
+            <a:r>
+              <a:rPr sz="1700">
+                <a:solidFill>
+                  <a:srgbClr val="0B1220"/>
+                </a:solidFill>
+                <a:latin typeface="Arial"/>
+              </a:rPr>
+              <a:t>•  Re-evaluate held-out participants (cold start) and per-site calibration; report subgroup performance.</a:t>
+            </a:r>
+          </a:p>
+          <a:p>
+            <a:pPr>
+              <a:spcAft>
+                <a:spcPts val="1000"/>
+              </a:spcAft>
+            </a:pPr>
+            <a:r>
+              <a:rPr sz="1700">
+                <a:solidFill>
+                  <a:srgbClr val="0B1220"/>
+                </a:solidFill>
+                <a:latin typeface="Arial"/>
+              </a:rPr>
+              <a:t>•  AI-READI five-minute CGM and wearable data (access not yet requested; steps listed) for a larger new-person evaluation under the declared protocol gt-nested-2026-10-12-v2.</a:t>
+            </a:r>
+          </a:p>
+          <a:p>
+            <a:pPr>
+              <a:spcAft>
+                <a:spcPts val="1000"/>
+              </a:spcAft>
+            </a:pPr>
+            <a:r>
+              <a:rPr sz="1700">
+                <a:solidFill>
+                  <a:srgbClr val="0B1220"/>
+                </a:solidFill>
+                <a:latin typeface="Arial"/>
+              </a:rPr>
+              <a:t>•  Clinician usability study of the review workflow; regulatory and data-protection review (DPDP Act).</a:t>
+            </a:r>
+          </a:p>
+          <a:p>
+            <a:pPr>
+              <a:spcAft>
+                <a:spcPts val="1000"/>
+              </a:spcAft>
+            </a:pPr>
+            <a:r>
+              <a:rPr sz="1700">
+                <a:solidFill>
+                  <a:srgbClr val="0B1220"/>
+                </a:solidFill>
+                <a:latin typeface="Arial"/>
+              </a:rPr>
+              <a:t>•  Optional: compare a fine-tuned time-series foundation model (e.g. Chronos-Bolt) under the same protocol.</a:t>
+            </a:r>
+          </a:p>
+        </p:txBody>
+      </p:sp>
+    </p:spTree>
+  </p:cSld>
+  <p:clrMapOvr>
+    <a:masterClrMapping/>
+  </p:clrMapOvr>
+</p:sld>
+</file>
+
+<file path=ppt/slides/slide24.xml><?xml version="1.0" encoding="utf-8"?>
+<p:sld xmlns:a="http://schemas.openxmlformats.org/drawingml/2006/main" xmlns:p="http://schemas.openxmlformats.org/presentationml/2006/main" xmlns:r="http://schemas.openxmlformats.org/officeDocument/2006/relationships">
+  <p:cSld>
+    <p:bg>
+      <p:bgPr>
+        <a:solidFill>
+          <a:srgbClr val="FFFFFF"/>
+        </a:solidFill>
+        <a:effectLst/>
+      </p:bgPr>
+    </p:bg>
+    <p:spTree>
+      <p:nvGrpSpPr>
+        <p:cNvPr id="1" name=""/>
+        <p:cNvGrpSpPr/>
+        <p:nvPr/>
+      </p:nvGrpSpPr>
+      <p:grpSpPr/>
+      <p:sp>
+        <p:nvSpPr>
+          <p:cNvPr id="2" name="TextBox 1"/>
+          <p:cNvSpPr txBox="1"/>
+          <p:nvPr/>
+        </p:nvSpPr>
+        <p:spPr>
+          <a:xfrm>
+            <a:off x="548640" y="320040"/>
+            <a:ext cx="11064240" cy="731520"/>
+          </a:xfrm>
+          <a:prstGeom prst="rect">
+            <a:avLst/>
+          </a:prstGeom>
+          <a:noFill/>
+        </p:spPr>
+        <p:txBody>
+          <a:bodyPr wrap="square">
+            <a:spAutoFit/>
+          </a:bodyPr>
+          <a:lstStyle/>
+          <a:p>
+            <a:r>
+              <a:rPr sz="3000" b="1">
+                <a:solidFill>
+                  <a:srgbClr val="0B1220"/>
+                </a:solidFill>
+                <a:latin typeface="Arial"/>
+              </a:rPr>
+              <a:t>Team, links, reproducibility and licenses</a:t>
+            </a:r>
+          </a:p>
+        </p:txBody>
+      </p:sp>
+      <p:cxnSp>
+        <p:nvCxnSpPr>
+          <p:cNvPr id="3" name="Connector 2"/>
+          <p:cNvCxnSpPr/>
+          <p:nvPr/>
+        </p:nvCxnSpPr>
+        <p:spPr>
+          <a:xfrm>
+            <a:off x="548640" y="987552"/>
+            <a:ext cx="11091672" cy="0"/>
+          </a:xfrm>
+          <a:prstGeom prst="line">
+            <a:avLst/>
+          </a:prstGeom>
+          <a:ln w="9525">
+            <a:solidFill>
+              <a:srgbClr val="E3E8EF"/>
+            </a:solidFill>
+          </a:ln>
+        </p:spPr>
+      </p:cxnSp>
+      <p:sp>
+        <p:nvSpPr>
+          <p:cNvPr id="4" name="TextBox 3"/>
+          <p:cNvSpPr txBox="1"/>
+          <p:nvPr/>
+        </p:nvSpPr>
+        <p:spPr>
+          <a:xfrm>
+            <a:off x="11247120" y="6446520"/>
+            <a:ext cx="457200" cy="274320"/>
+          </a:xfrm>
+          <a:prstGeom prst="rect">
+            <a:avLst/>
+          </a:prstGeom>
+          <a:noFill/>
+        </p:spPr>
+        <p:txBody>
+          <a:bodyPr wrap="square">
+            <a:spAutoFit/>
+          </a:bodyPr>
+          <a:lstStyle/>
+          <a:p>
+            <a:r>
+              <a:rPr sz="1100" b="0">
+                <a:solidFill>
+                  <a:srgbClr val="0B1220"/>
+                </a:solidFill>
+                <a:latin typeface="Arial"/>
+              </a:rPr>
+              <a:t>24</a:t>
             </a:r>
           </a:p>
         </p:txBody>

</xml_diff>

<commit_message>
docs: README, judge journey, deck slide 20 (D-048) and branding 'Team Kryptonite, VESIT'; public evidence re-exported; screenshots refreshed
</commit_message>
<xml_diff>
--- a/docs/submission/GlucoTwin_Presentation.pptx
+++ b/docs/submission/GlucoTwin_Presentation.pptx
@@ -3237,7 +3237,7 @@
                 </a:solidFill>
                 <a:latin typeface="Arial"/>
               </a:rPr>
-              <a:t>Team Kryptonite · VESIT</a:t>
+              <a:t>Team Kryptonite, VESIT</a:t>
             </a:r>
           </a:p>
           <a:p>
@@ -5705,6 +5705,22 @@
                 <a:latin typeface="Arial"/>
               </a:rPr>
               <a:t>•  Not shown — health record as a new person's starting correction: -0.53 [-1.57, +0.58] mg/dL at 120 min, -0.93 [-2.74, +0.48] in the first 24 hours; the intervals cross zero, so no benefit is claimed.</a:t>
+            </a:r>
+          </a:p>
+          <a:p>
+            <a:pPr>
+              <a:spcAft>
+                <a:spcPts val="1000"/>
+              </a:spcAft>
+            </a:pPr>
+            <a:r>
+              <a:rPr sz="1700">
+                <a:solidFill>
+                  <a:srgbClr val="0B1220"/>
+                </a:solidFill>
+                <a:latin typeface="Arial"/>
+              </a:rPr>
+              <a:t>•  Not adopted — a LightGBM–CatBoost blend (D-048, declared before scoring): +0.02 mg/dL at 60 min on development people against a 0.5 target, so the demo model is unchanged and the held-out folds were never opened.</a:t>
             </a:r>
           </a:p>
           <a:p>

</xml_diff>

<commit_message>
research: D-049 negative — no retraining arm met the 0.5 mg/dL gate (best: 24-hour history +0.41); serving model unchanged
Report, decisions, README, model card, deck slide 20 and demo script updated; second-sprint handoff.
</commit_message>
<xml_diff>
--- a/docs/submission/GlucoTwin_Presentation.pptx
+++ b/docs/submission/GlucoTwin_Presentation.pptx
@@ -5721,6 +5721,22 @@
                 <a:latin typeface="Arial"/>
               </a:rPr>
               <a:t>•  Not adopted — a LightGBM–CatBoost blend (D-048, declared before scoring): +0.02 mg/dL at 60 min on development people against a 0.5 target, so the demo model is unchanged and the held-out folds were never opened.</a:t>
+            </a:r>
+          </a:p>
+          <a:p>
+            <a:pPr>
+              <a:spcAft>
+                <a:spcPts val="1000"/>
+              </a:spcAft>
+            </a:pPr>
+            <a:r>
+              <a:rPr sz="1700">
+                <a:solidFill>
+                  <a:srgbClr val="0B1220"/>
+                </a:solidFill>
+                <a:latin typeface="Arial"/>
+              </a:rPr>
+              <a:t>•  Not adopted — retraining with participant balance, rising-glucose weights or 24-hour history (D-049, fresh fits): 60-min gains -0.04, +0.07 and +0.41 mg/dL against a 0.5 target; the demo model is unchanged.</a:t>
             </a:r>
           </a:p>
           <a:p>

</xml_diff>

<commit_message>
research: D-051 — tuned 24-hour history gives a small reliable gain (−0.37 [−0.63, −0.06] mg/dL, 10/14) below the declared −0.5 bar; not adopted
Docs, deck slide 20, demo script and public evidence snapshot updated; deadline 24 Oct 19:00 IST.
</commit_message>
<xml_diff>
--- a/docs/submission/GlucoTwin_Presentation.pptx
+++ b/docs/submission/GlucoTwin_Presentation.pptx
@@ -5656,7 +5656,7 @@
                 </a:solidFill>
                 <a:latin typeface="Arial"/>
               </a:rPr>
-              <a:t>•  Declared and committed before any arm was computed (D-046): the saved two-hour predictions re-analysed, every choice made on development people, the outer people read once. Same 14 already-inspected people: internal validation.</a:t>
+              <a:t>•  Each test below was declared and committed before computing it; the same 14 already-inspected people (internal validation).</a:t>
             </a:r>
           </a:p>
           <a:p>
@@ -5737,6 +5737,22 @@
                 <a:latin typeface="Arial"/>
               </a:rPr>
               <a:t>•  Not adopted — retraining with participant balance, rising-glucose weights or 24-hour history (D-049, fresh fits): 60-min gains -0.04, +0.07 and +0.41 mg/dL against a 0.5 target; the demo model is unchanged.</a:t>
+            </a:r>
+          </a:p>
+          <a:p>
+            <a:pPr>
+              <a:spcAft>
+                <a:spcPts val="1000"/>
+              </a:spcAft>
+            </a:pPr>
+            <a:r>
+              <a:rPr sz="1700">
+                <a:solidFill>
+                  <a:srgbClr val="0B1220"/>
+                </a:solidFill>
+                <a:latin typeface="Arial"/>
+              </a:rPr>
+              <a:t>•  Small, reliable, below our bar — tuned retraining with 24-hour history (D-051, 1,830 fits, each person held out): -0.37 [-0.63, -0.06] mg/dL at 60 min, 10 of 14 people better, against a declared −0.5; not adopted.</a:t>
             </a:r>
           </a:p>
           <a:p>

</xml_diff>

<commit_message>
docs/evidence: D-051 budget wording (30 seeded trials, one round count each), gain stated vs the equally tuned control with the serving-recipe comparison; D-050 and D-051 added to the evidence manifest (19/19)
</commit_message>
<xml_diff>
--- a/docs/submission/GlucoTwin_Presentation.pptx
+++ b/docs/submission/GlucoTwin_Presentation.pptx
@@ -5720,7 +5720,7 @@
                 </a:solidFill>
                 <a:latin typeface="Arial"/>
               </a:rPr>
-              <a:t>•  Not adopted — a LightGBM–CatBoost blend (D-048, declared before scoring): +0.02 mg/dL at 60 min on development people against a 0.5 target, so the demo model is unchanged and the held-out folds were never opened.</a:t>
+              <a:t>•  Not adopted — a LightGBM–CatBoost blend (D-048): +0.02 mg/dL at 60 min on development people against a 0.5 target; held-out folds never opened.</a:t>
             </a:r>
           </a:p>
           <a:p>
@@ -5752,7 +5752,7 @@
                 </a:solidFill>
                 <a:latin typeface="Arial"/>
               </a:rPr>
-              <a:t>•  Small, reliable, below our bar — tuned retraining with 24-hour history (D-051, 1,830 fits, each person held out): -0.37 [-0.63, -0.06] mg/dL at 60 min, 10 of 14 people better, against a declared −0.5; not adopted.</a:t>
+              <a:t>•  Small internal gain, below our bar — tuned retraining with 24-hour history (D-051, 1,830 fits, each person held out): -0.37 [-0.63, -0.06] mg/dL at 60 min vs the equally tuned current features, 10 of 14 better; vs the refitted serving recipe -0.65 [-1.41, +0.07]. Declared bar −0.5; not adopted.</a:t>
             </a:r>
           </a:p>
           <a:p>

</xml_diff>

<commit_message>
research: D-052 — joint selection lowers 60-min error vs the refitted serving recipe (−0.88 [−1.75, −0.13]) but worsens peaks (+1.70) and alarms; gates not met, not adopted
README, decisions, model card, manifest (21/21), slide 20 and a shorter research chapter in the demo script.
</commit_message>
<xml_diff>
--- a/docs/submission/GlucoTwin_Presentation.pptx
+++ b/docs/submission/GlucoTwin_Presentation.pptx
@@ -5736,7 +5736,7 @@
                 </a:solidFill>
                 <a:latin typeface="Arial"/>
               </a:rPr>
-              <a:t>•  Not adopted — retraining with participant balance, rising-glucose weights or 24-hour history (D-049, fresh fits): 60-min gains -0.04, +0.07 and +0.41 mg/dL against a 0.5 target; the demo model is unchanged.</a:t>
+              <a:t>•  Not adopted — fixed and tuned retraining (D-049, D-051): best 60-min gain +0.41 mg/dL (fixed), -0.37 [-0.63, -0.06] with tuning, below the declared 0.5 bar.</a:t>
             </a:r>
           </a:p>
           <a:p>
@@ -5752,7 +5752,7 @@
                 </a:solidFill>
                 <a:latin typeface="Arial"/>
               </a:rPr>
-              <a:t>•  Small internal gain, below our bar — tuned retraining with 24-hour history (D-051, 1,830 fits, each person held out): -0.37 [-0.63, -0.06] mg/dL at 60 min vs the equally tuned current features, 10 of 14 better; vs the refitted serving recipe -0.65 [-1.41, +0.07]. Declared bar −0.5; not adopted.</a:t>
+              <a:t>•  Not adopted — joint selection (D-052, 1,570 fresh fits): -0.88 [-1.75, -0.13] mg/dL at 60 min vs the refitted serving recipe, but +1.70 on peaks above 180 and +0.60 false alarms/day — gates not met.</a:t>
             </a:r>
           </a:p>
           <a:p>

</xml_diff>

<commit_message>
submission: deck separates serving, participant-held-out and external evidence; results overview; pending D-053/D-054 slots; architecture marks bounded update, review ledger and research-only candidates; data opportunity check
</commit_message>
<xml_diff>
--- a/docs/submission/GlucoTwin_Presentation.pptx
+++ b/docs/submission/GlucoTwin_Presentation.pptx
@@ -29,6 +29,9 @@
     <p:sldId id="277" r:id="rId28"/>
     <p:sldId id="278" r:id="rId29"/>
     <p:sldId id="279" r:id="rId30"/>
+    <p:sldId id="280" r:id="rId31"/>
+    <p:sldId id="281" r:id="rId32"/>
+    <p:sldId id="282" r:id="rId33"/>
   </p:sldIdLst>
   <p:sldSz cx="12191695" cy="6858000" type="screen4x3"/>
   <p:notesSz cx="6858000" cy="9144000"/>
@@ -3321,7 +3324,7 @@
         <p:spPr>
           <a:xfrm>
             <a:off x="548640" y="320040"/>
-            <a:ext cx="11064240" cy="731520"/>
+            <a:ext cx="11064240" cy="640080"/>
           </a:xfrm>
           <a:prstGeom prst="rect">
             <a:avLst/>
@@ -3555,7 +3558,7 @@
         <p:spPr>
           <a:xfrm>
             <a:off x="548640" y="320040"/>
-            <a:ext cx="11064240" cy="731520"/>
+            <a:ext cx="11064240" cy="640080"/>
           </a:xfrm>
           <a:prstGeom prst="rect">
             <a:avLst/>
@@ -3728,7 +3731,7 @@
         <p:spPr>
           <a:xfrm>
             <a:off x="548640" y="320040"/>
-            <a:ext cx="11064240" cy="731520"/>
+            <a:ext cx="11064240" cy="640080"/>
           </a:xfrm>
           <a:prstGeom prst="rect">
             <a:avLst/>
@@ -3901,7 +3904,7 @@
         <p:spPr>
           <a:xfrm>
             <a:off x="548640" y="320040"/>
-            <a:ext cx="11064240" cy="731520"/>
+            <a:ext cx="11064240" cy="640080"/>
           </a:xfrm>
           <a:prstGeom prst="rect">
             <a:avLst/>
@@ -4135,7 +4138,7 @@
         <p:spPr>
           <a:xfrm>
             <a:off x="548640" y="320040"/>
-            <a:ext cx="11064240" cy="731520"/>
+            <a:ext cx="11064240" cy="640080"/>
           </a:xfrm>
           <a:prstGeom prst="rect">
             <a:avLst/>
@@ -4155,7 +4158,7 @@
                 </a:solidFill>
                 <a:latin typeface="Arial"/>
               </a:rPr>
-              <a:t>Measured evaluation: forecast accuracy (later days)</a:t>
+              <a:t>Results at a glance: three kinds of evidence, kept apart</a:t>
             </a:r>
           </a:p>
         </p:txBody>
@@ -4215,30 +4218,754 @@
           </a:p>
         </p:txBody>
       </p:sp>
-      <p:pic>
-        <p:nvPicPr>
-          <p:cNvPr id="5" name="Picture 4" descr="fig_mae_test.png"/>
-          <p:cNvPicPr>
-            <a:picLocks noChangeAspect="1"/>
-          </p:cNvPicPr>
-          <p:nvPr/>
-        </p:nvPicPr>
-        <p:blipFill>
-          <a:blip r:embed="rId2"/>
-          <a:stretch>
-            <a:fillRect/>
-          </a:stretch>
-        </p:blipFill>
-        <p:spPr>
-          <a:xfrm>
-            <a:off x="548640" y="1188720"/>
-            <a:ext cx="11064240" cy="3964640"/>
-          </a:xfrm>
-          <a:prstGeom prst="rect">
-            <a:avLst/>
-          </a:prstGeom>
-        </p:spPr>
-      </p:pic>
+      <p:graphicFrame>
+        <p:nvGraphicFramePr>
+          <p:cNvPr id="5" name="Table 4"/>
+          <p:cNvGraphicFramePr>
+            <a:graphicFrameLocks noGrp="1"/>
+          </p:cNvGraphicFramePr>
+          <p:nvPr/>
+        </p:nvGraphicFramePr>
+        <p:xfrm>
+          <a:off x="548640" y="1234440"/>
+          <a:ext cx="11064240" cy="3785616"/>
+        </p:xfrm>
+        <a:graphic>
+          <a:graphicData uri="http://schemas.openxmlformats.org/drawingml/2006/table">
+            <a:tbl>
+              <a:tblPr firstRow="1" bandRow="1">
+                <a:tableStyleId>{5C22544A-7EE6-4342-B048-85BDC9FD1C3A}</a:tableStyleId>
+              </a:tblPr>
+              <a:tblGrid>
+                <a:gridCol w="2651760"/>
+                <a:gridCol w="4846320"/>
+                <a:gridCol w="1783080"/>
+                <a:gridCol w="1783080"/>
+              </a:tblGrid>
+              <a:tr h="420624">
+                <a:tc>
+                  <a:txBody>
+                    <a:bodyPr/>
+                    <a:lstStyle/>
+                    <a:p>
+                      <a:r>
+                        <a:rPr sz="1350" b="1" i="0">
+                          <a:solidFill>
+                            <a:srgbClr val="0B1220"/>
+                          </a:solidFill>
+                          <a:latin typeface="Arial"/>
+                        </a:rPr>
+                        <a:t>Evaluated on</a:t>
+                      </a:r>
+                    </a:p>
+                  </a:txBody>
+                  <a:tcPr marT="38100" marB="38100">
+                    <a:solidFill>
+                      <a:srgbClr val="FFFFFF"/>
+                    </a:solidFill>
+                  </a:tcPr>
+                </a:tc>
+                <a:tc>
+                  <a:txBody>
+                    <a:bodyPr/>
+                    <a:lstStyle/>
+                    <a:p>
+                      <a:r>
+                        <a:rPr sz="1350" b="1" i="0">
+                          <a:solidFill>
+                            <a:srgbClr val="0B1220"/>
+                          </a:solidFill>
+                          <a:latin typeface="Arial"/>
+                        </a:rPr>
+                        <a:t>Model or procedure</a:t>
+                      </a:r>
+                    </a:p>
+                  </a:txBody>
+                  <a:tcPr marT="38100" marB="38100">
+                    <a:solidFill>
+                      <a:srgbClr val="FFFFFF"/>
+                    </a:solidFill>
+                  </a:tcPr>
+                </a:tc>
+                <a:tc>
+                  <a:txBody>
+                    <a:bodyPr/>
+                    <a:lstStyle/>
+                    <a:p>
+                      <a:r>
+                        <a:rPr sz="1350" b="1" i="0">
+                          <a:solidFill>
+                            <a:srgbClr val="0B1220"/>
+                          </a:solidFill>
+                          <a:latin typeface="Arial"/>
+                        </a:rPr>
+                        <a:t>MAE 30 / 60 min</a:t>
+                      </a:r>
+                    </a:p>
+                  </a:txBody>
+                  <a:tcPr marT="38100" marB="38100">
+                    <a:solidFill>
+                      <a:srgbClr val="FFFFFF"/>
+                    </a:solidFill>
+                  </a:tcPr>
+                </a:tc>
+                <a:tc>
+                  <a:txBody>
+                    <a:bodyPr/>
+                    <a:lstStyle/>
+                    <a:p>
+                      <a:r>
+                        <a:rPr sz="1350" b="1" i="0">
+                          <a:solidFill>
+                            <a:srgbClr val="0B1220"/>
+                          </a:solidFill>
+                          <a:latin typeface="Arial"/>
+                        </a:rPr>
+                        <a:t>Persistence 30 / 60</a:t>
+                      </a:r>
+                    </a:p>
+                  </a:txBody>
+                  <a:tcPr marT="38100" marB="38100">
+                    <a:solidFill>
+                      <a:srgbClr val="FFFFFF"/>
+                    </a:solidFill>
+                  </a:tcPr>
+                </a:tc>
+              </a:tr>
+              <a:tr h="420624">
+                <a:tc gridSpan="4">
+                  <a:txBody>
+                    <a:bodyPr/>
+                    <a:lstStyle/>
+                    <a:p>
+                      <a:r>
+                        <a:rPr sz="1350" b="1" i="0">
+                          <a:solidFill>
+                            <a:srgbClr val="2563EB"/>
+                          </a:solidFill>
+                          <a:latin typeface="Arial"/>
+                        </a:rPr>
+                        <a:t>Serving model — later recordings of the same 14 CGMacros Type 2 people (a test over time, retrospective)</a:t>
+                      </a:r>
+                    </a:p>
+                  </a:txBody>
+                  <a:tcPr marT="38100" marB="38100">
+                    <a:solidFill>
+                      <a:srgbClr val="FFFFFF"/>
+                    </a:solidFill>
+                  </a:tcPr>
+                </a:tc>
+                <a:tc hMerge="1">
+                  <a:txBody>
+                    <a:bodyPr/>
+                    <a:lstStyle/>
+                    <a:p/>
+                  </a:txBody>
+                  <a:tcPr marT="38100" marB="38100">
+                    <a:solidFill>
+                      <a:srgbClr val="FFFFFF"/>
+                    </a:solidFill>
+                  </a:tcPr>
+                </a:tc>
+                <a:tc hMerge="1">
+                  <a:txBody>
+                    <a:bodyPr/>
+                    <a:lstStyle/>
+                    <a:p/>
+                  </a:txBody>
+                  <a:tcPr marT="38100" marB="38100">
+                    <a:solidFill>
+                      <a:srgbClr val="FFFFFF"/>
+                    </a:solidFill>
+                  </a:tcPr>
+                </a:tc>
+                <a:tc hMerge="1">
+                  <a:txBody>
+                    <a:bodyPr/>
+                    <a:lstStyle/>
+                    <a:p/>
+                  </a:txBody>
+                  <a:tcPr marT="38100" marB="38100">
+                    <a:solidFill>
+                      <a:srgbClr val="FFFFFF"/>
+                    </a:solidFill>
+                  </a:tcPr>
+                </a:tc>
+              </a:tr>
+              <a:tr h="420624">
+                <a:tc>
+                  <a:txBody>
+                    <a:bodyPr/>
+                    <a:lstStyle/>
+                    <a:p>
+                      <a:r>
+                        <a:rPr sz="1350" b="0" i="0">
+                          <a:solidFill>
+                            <a:srgbClr val="0B1220"/>
+                          </a:solidFill>
+                          <a:latin typeface="Arial"/>
+                        </a:rPr>
+                        <a:t>Final 20 % of each recording</a:t>
+                      </a:r>
+                    </a:p>
+                  </a:txBody>
+                  <a:tcPr marT="38100" marB="38100">
+                    <a:solidFill>
+                      <a:srgbClr val="FFFFFF"/>
+                    </a:solidFill>
+                  </a:tcPr>
+                </a:tc>
+                <a:tc>
+                  <a:txBody>
+                    <a:bodyPr/>
+                    <a:lstStyle/>
+                    <a:p>
+                      <a:r>
+                        <a:rPr sz="1350" b="0" i="0">
+                          <a:solidFill>
+                            <a:srgbClr val="0B1220"/>
+                          </a:solidFill>
+                          <a:latin typeface="Arial"/>
+                        </a:rPr>
+                        <a:t>Fusion LightGBM + bounded patient correction (serving)</a:t>
+                      </a:r>
+                    </a:p>
+                  </a:txBody>
+                  <a:tcPr marT="38100" marB="38100">
+                    <a:solidFill>
+                      <a:srgbClr val="FFFFFF"/>
+                    </a:solidFill>
+                  </a:tcPr>
+                </a:tc>
+                <a:tc>
+                  <a:txBody>
+                    <a:bodyPr/>
+                    <a:lstStyle/>
+                    <a:p>
+                      <a:r>
+                        <a:rPr sz="1350" b="1" i="0">
+                          <a:solidFill>
+                            <a:srgbClr val="0B1220"/>
+                          </a:solidFill>
+                          <a:latin typeface="Arial"/>
+                        </a:rPr>
+                        <a:t>12.96 / 20.26</a:t>
+                      </a:r>
+                    </a:p>
+                  </a:txBody>
+                  <a:tcPr marT="38100" marB="38100">
+                    <a:solidFill>
+                      <a:srgbClr val="FFFFFF"/>
+                    </a:solidFill>
+                  </a:tcPr>
+                </a:tc>
+                <a:tc>
+                  <a:txBody>
+                    <a:bodyPr/>
+                    <a:lstStyle/>
+                    <a:p>
+                      <a:r>
+                        <a:rPr sz="1350" b="1" i="0">
+                          <a:solidFill>
+                            <a:srgbClr val="0B1220"/>
+                          </a:solidFill>
+                          <a:latin typeface="Arial"/>
+                        </a:rPr>
+                        <a:t>14.84 / 23.23</a:t>
+                      </a:r>
+                    </a:p>
+                  </a:txBody>
+                  <a:tcPr marT="38100" marB="38100">
+                    <a:solidFill>
+                      <a:srgbClr val="FFFFFF"/>
+                    </a:solidFill>
+                  </a:tcPr>
+                </a:tc>
+              </a:tr>
+              <a:tr h="420624">
+                <a:tc gridSpan="4">
+                  <a:txBody>
+                    <a:bodyPr/>
+                    <a:lstStyle/>
+                    <a:p>
+                      <a:r>
+                        <a:rPr sz="1350" b="1" i="0">
+                          <a:solidFill>
+                            <a:srgbClr val="2563EB"/>
+                          </a:solidFill>
+                          <a:latin typeface="Arial"/>
+                        </a:rPr>
+                        <a:t>Participant-held-out research — 14 CGMacros people, each held out once (internal validation)</a:t>
+                      </a:r>
+                    </a:p>
+                  </a:txBody>
+                  <a:tcPr marT="38100" marB="38100">
+                    <a:solidFill>
+                      <a:srgbClr val="FFFFFF"/>
+                    </a:solidFill>
+                  </a:tcPr>
+                </a:tc>
+                <a:tc hMerge="1">
+                  <a:txBody>
+                    <a:bodyPr/>
+                    <a:lstStyle/>
+                    <a:p/>
+                  </a:txBody>
+                  <a:tcPr marT="38100" marB="38100">
+                    <a:solidFill>
+                      <a:srgbClr val="FFFFFF"/>
+                    </a:solidFill>
+                  </a:tcPr>
+                </a:tc>
+                <a:tc hMerge="1">
+                  <a:txBody>
+                    <a:bodyPr/>
+                    <a:lstStyle/>
+                    <a:p/>
+                  </a:txBody>
+                  <a:tcPr marT="38100" marB="38100">
+                    <a:solidFill>
+                      <a:srgbClr val="FFFFFF"/>
+                    </a:solidFill>
+                  </a:tcPr>
+                </a:tc>
+                <a:tc hMerge="1">
+                  <a:txBody>
+                    <a:bodyPr/>
+                    <a:lstStyle/>
+                    <a:p/>
+                  </a:txBody>
+                  <a:tcPr marT="38100" marB="38100">
+                    <a:solidFill>
+                      <a:srgbClr val="FFFFFF"/>
+                    </a:solidFill>
+                  </a:tcPr>
+                </a:tc>
+              </a:tr>
+              <a:tr h="420624">
+                <a:tc>
+                  <a:txBody>
+                    <a:bodyPr/>
+                    <a:lstStyle/>
+                    <a:p>
+                      <a:r>
+                        <a:rPr sz="1350" b="0" i="0">
+                          <a:solidFill>
+                            <a:srgbClr val="0B1220"/>
+                          </a:solidFill>
+                          <a:latin typeface="Arial"/>
+                        </a:rPr>
+                        <a:t>Five participant folds (D-032)</a:t>
+                      </a:r>
+                    </a:p>
+                  </a:txBody>
+                  <a:tcPr marT="38100" marB="38100">
+                    <a:solidFill>
+                      <a:srgbClr val="FFFFFF"/>
+                    </a:solidFill>
+                  </a:tcPr>
+                </a:tc>
+                <a:tc>
+                  <a:txBody>
+                    <a:bodyPr/>
+                    <a:lstStyle/>
+                    <a:p>
+                      <a:r>
+                        <a:rPr sz="1350" b="0" i="0">
+                          <a:solidFill>
+                            <a:srgbClr val="0B1220"/>
+                          </a:solidFill>
+                          <a:latin typeface="Arial"/>
+                        </a:rPr>
+                        <a:t>CGM-only research procedure (Ridge in 4 of 5 folds), not served</a:t>
+                      </a:r>
+                    </a:p>
+                  </a:txBody>
+                  <a:tcPr marT="38100" marB="38100">
+                    <a:solidFill>
+                      <a:srgbClr val="FFFFFF"/>
+                    </a:solidFill>
+                  </a:tcPr>
+                </a:tc>
+                <a:tc>
+                  <a:txBody>
+                    <a:bodyPr/>
+                    <a:lstStyle/>
+                    <a:p>
+                      <a:r>
+                        <a:rPr sz="1350" b="0" i="0">
+                          <a:solidFill>
+                            <a:srgbClr val="0B1220"/>
+                          </a:solidFill>
+                          <a:latin typeface="Arial"/>
+                        </a:rPr>
+                        <a:t>13.88 / 22.30</a:t>
+                      </a:r>
+                    </a:p>
+                  </a:txBody>
+                  <a:tcPr marT="38100" marB="38100">
+                    <a:solidFill>
+                      <a:srgbClr val="FFFFFF"/>
+                    </a:solidFill>
+                  </a:tcPr>
+                </a:tc>
+                <a:tc>
+                  <a:txBody>
+                    <a:bodyPr/>
+                    <a:lstStyle/>
+                    <a:p>
+                      <a:r>
+                        <a:rPr sz="1350" b="0" i="0">
+                          <a:solidFill>
+                            <a:srgbClr val="0B1220"/>
+                          </a:solidFill>
+                          <a:latin typeface="Arial"/>
+                        </a:rPr>
+                        <a:t>15.34 / 24.47</a:t>
+                      </a:r>
+                    </a:p>
+                  </a:txBody>
+                  <a:tcPr marT="38100" marB="38100">
+                    <a:solidFill>
+                      <a:srgbClr val="FFFFFF"/>
+                    </a:solidFill>
+                  </a:tcPr>
+                </a:tc>
+              </a:tr>
+              <a:tr h="420624">
+                <a:tc>
+                  <a:txBody>
+                    <a:bodyPr/>
+                    <a:lstStyle/>
+                    <a:p>
+                      <a:r>
+                        <a:rPr sz="1350" b="0" i="0">
+                          <a:solidFill>
+                            <a:srgbClr val="0B1220"/>
+                          </a:solidFill>
+                          <a:latin typeface="Arial"/>
+                        </a:rPr>
+                        <a:t>14 CGMacros people (D-053)</a:t>
+                      </a:r>
+                    </a:p>
+                  </a:txBody>
+                  <a:tcPr marT="38100" marB="38100">
+                    <a:solidFill>
+                      <a:srgbClr val="FFFFFF"/>
+                    </a:solidFill>
+                  </a:tcPr>
+                </a:tc>
+                <a:tc>
+                  <a:txBody>
+                    <a:bodyPr/>
+                    <a:lstStyle/>
+                    <a:p>
+                      <a:r>
+                        <a:rPr sz="1350" b="0" i="0">
+                          <a:solidFill>
+                            <a:srgbClr val="0B1220"/>
+                          </a:solidFill>
+                          <a:latin typeface="Arial"/>
+                        </a:rPr>
+                        <a:t>Constrained LightGBM fusion</a:t>
+                      </a:r>
+                    </a:p>
+                  </a:txBody>
+                  <a:tcPr marT="38100" marB="38100">
+                    <a:solidFill>
+                      <a:srgbClr val="FFFFFF"/>
+                    </a:solidFill>
+                  </a:tcPr>
+                </a:tc>
+                <a:tc>
+                  <a:txBody>
+                    <a:bodyPr/>
+                    <a:lstStyle/>
+                    <a:p>
+                      <a:r>
+                        <a:rPr sz="1350" b="0" i="1">
+                          <a:solidFill>
+                            <a:srgbClr val="0B1220"/>
+                          </a:solidFill>
+                          <a:latin typeface="Arial"/>
+                        </a:rPr>
+                        <a:t>pending</a:t>
+                      </a:r>
+                    </a:p>
+                  </a:txBody>
+                  <a:tcPr marT="38100" marB="38100">
+                    <a:solidFill>
+                      <a:srgbClr val="FFFFFF"/>
+                    </a:solidFill>
+                  </a:tcPr>
+                </a:tc>
+                <a:tc>
+                  <a:txBody>
+                    <a:bodyPr/>
+                    <a:lstStyle/>
+                    <a:p>
+                      <a:r>
+                        <a:rPr sz="1350" b="0" i="1">
+                          <a:solidFill>
+                            <a:srgbClr val="0B1220"/>
+                          </a:solidFill>
+                          <a:latin typeface="Arial"/>
+                        </a:rPr>
+                        <a:t>pending</a:t>
+                      </a:r>
+                    </a:p>
+                  </a:txBody>
+                  <a:tcPr marT="38100" marB="38100">
+                    <a:solidFill>
+                      <a:srgbClr val="FFFFFF"/>
+                    </a:solidFill>
+                  </a:tcPr>
+                </a:tc>
+              </a:tr>
+              <a:tr h="420624">
+                <a:tc>
+                  <a:txBody>
+                    <a:bodyPr/>
+                    <a:lstStyle/>
+                    <a:p>
+                      <a:r>
+                        <a:rPr sz="1350" b="0" i="0">
+                          <a:solidFill>
+                            <a:srgbClr val="0B1220"/>
+                          </a:solidFill>
+                          <a:latin typeface="Arial"/>
+                        </a:rPr>
+                        <a:t>14 CGMacros people (D-054)</a:t>
+                      </a:r>
+                    </a:p>
+                  </a:txBody>
+                  <a:tcPr marT="38100" marB="38100">
+                    <a:solidFill>
+                      <a:srgbClr val="FFFFFF"/>
+                    </a:solidFill>
+                  </a:tcPr>
+                </a:tc>
+                <a:tc>
+                  <a:txBody>
+                    <a:bodyPr/>
+                    <a:lstStyle/>
+                    <a:p>
+                      <a:r>
+                        <a:rPr sz="1350" b="0" i="0">
+                          <a:solidFill>
+                            <a:srgbClr val="0B1220"/>
+                          </a:solidFill>
+                          <a:latin typeface="Arial"/>
+                        </a:rPr>
+                        <a:t>Zero-shot time-series foundation-model baseline on CGM only (a comparison, not a fusion model)</a:t>
+                      </a:r>
+                    </a:p>
+                  </a:txBody>
+                  <a:tcPr marT="38100" marB="38100">
+                    <a:solidFill>
+                      <a:srgbClr val="FFFFFF"/>
+                    </a:solidFill>
+                  </a:tcPr>
+                </a:tc>
+                <a:tc>
+                  <a:txBody>
+                    <a:bodyPr/>
+                    <a:lstStyle/>
+                    <a:p>
+                      <a:r>
+                        <a:rPr sz="1350" b="0" i="1">
+                          <a:solidFill>
+                            <a:srgbClr val="0B1220"/>
+                          </a:solidFill>
+                          <a:latin typeface="Arial"/>
+                        </a:rPr>
+                        <a:t>pending</a:t>
+                      </a:r>
+                    </a:p>
+                  </a:txBody>
+                  <a:tcPr marT="38100" marB="38100">
+                    <a:solidFill>
+                      <a:srgbClr val="FFFFFF"/>
+                    </a:solidFill>
+                  </a:tcPr>
+                </a:tc>
+                <a:tc>
+                  <a:txBody>
+                    <a:bodyPr/>
+                    <a:lstStyle/>
+                    <a:p>
+                      <a:r>
+                        <a:rPr sz="1350" b="0" i="1">
+                          <a:solidFill>
+                            <a:srgbClr val="0B1220"/>
+                          </a:solidFill>
+                          <a:latin typeface="Arial"/>
+                        </a:rPr>
+                        <a:t>pending</a:t>
+                      </a:r>
+                    </a:p>
+                  </a:txBody>
+                  <a:tcPr marT="38100" marB="38100">
+                    <a:solidFill>
+                      <a:srgbClr val="FFFFFF"/>
+                    </a:solidFill>
+                  </a:tcPr>
+                </a:tc>
+              </a:tr>
+              <a:tr h="420624">
+                <a:tc gridSpan="4">
+                  <a:txBody>
+                    <a:bodyPr/>
+                    <a:lstStyle/>
+                    <a:p>
+                      <a:r>
+                        <a:rPr sz="1350" b="1" i="0">
+                          <a:solidFill>
+                            <a:srgbClr val="2563EB"/>
+                          </a:solidFill>
+                          <a:latin typeface="Arial"/>
+                        </a:rPr>
+                        <a:t>External check — ShanghaiT2DM, 98 people, CGM only, assessed once</a:t>
+                      </a:r>
+                    </a:p>
+                  </a:txBody>
+                  <a:tcPr marT="38100" marB="38100">
+                    <a:solidFill>
+                      <a:srgbClr val="FFFFFF"/>
+                    </a:solidFill>
+                  </a:tcPr>
+                </a:tc>
+                <a:tc hMerge="1">
+                  <a:txBody>
+                    <a:bodyPr/>
+                    <a:lstStyle/>
+                    <a:p/>
+                  </a:txBody>
+                  <a:tcPr marT="38100" marB="38100">
+                    <a:solidFill>
+                      <a:srgbClr val="FFFFFF"/>
+                    </a:solidFill>
+                  </a:tcPr>
+                </a:tc>
+                <a:tc hMerge="1">
+                  <a:txBody>
+                    <a:bodyPr/>
+                    <a:lstStyle/>
+                    <a:p/>
+                  </a:txBody>
+                  <a:tcPr marT="38100" marB="38100">
+                    <a:solidFill>
+                      <a:srgbClr val="FFFFFF"/>
+                    </a:solidFill>
+                  </a:tcPr>
+                </a:tc>
+                <a:tc hMerge="1">
+                  <a:txBody>
+                    <a:bodyPr/>
+                    <a:lstStyle/>
+                    <a:p/>
+                  </a:txBody>
+                  <a:tcPr marT="38100" marB="38100">
+                    <a:solidFill>
+                      <a:srgbClr val="FFFFFF"/>
+                    </a:solidFill>
+                  </a:tcPr>
+                </a:tc>
+              </a:tr>
+              <a:tr h="420624">
+                <a:tc>
+                  <a:txBody>
+                    <a:bodyPr/>
+                    <a:lstStyle/>
+                    <a:p>
+                      <a:r>
+                        <a:rPr sz="1350" b="0" i="0">
+                          <a:solidFill>
+                            <a:srgbClr val="0B1220"/>
+                          </a:solidFill>
+                          <a:latin typeface="Arial"/>
+                        </a:rPr>
+                        <a:t>98 people, 15-min CGM (D-045)</a:t>
+                      </a:r>
+                    </a:p>
+                  </a:txBody>
+                  <a:tcPr marT="38100" marB="38100">
+                    <a:solidFill>
+                      <a:srgbClr val="FFFFFF"/>
+                    </a:solidFill>
+                  </a:tcPr>
+                </a:tc>
+                <a:tc>
+                  <a:txBody>
+                    <a:bodyPr/>
+                    <a:lstStyle/>
+                    <a:p>
+                      <a:r>
+                        <a:rPr sz="1350" b="0" i="0">
+                          <a:solidFill>
+                            <a:srgbClr val="0B1220"/>
+                          </a:solidFill>
+                          <a:latin typeface="Arial"/>
+                        </a:rPr>
+                        <a:t>Separate 15-min LightGBM on CGM only, not the serving fusion model</a:t>
+                      </a:r>
+                    </a:p>
+                  </a:txBody>
+                  <a:tcPr marT="38100" marB="38100">
+                    <a:solidFill>
+                      <a:srgbClr val="FFFFFF"/>
+                    </a:solidFill>
+                  </a:tcPr>
+                </a:tc>
+                <a:tc>
+                  <a:txBody>
+                    <a:bodyPr/>
+                    <a:lstStyle/>
+                    <a:p>
+                      <a:r>
+                        <a:rPr sz="1350" b="0" i="0">
+                          <a:solidFill>
+                            <a:srgbClr val="0B1220"/>
+                          </a:solidFill>
+                          <a:latin typeface="Arial"/>
+                        </a:rPr>
+                        <a:t>10.90 / 19.31</a:t>
+                      </a:r>
+                    </a:p>
+                  </a:txBody>
+                  <a:tcPr marT="38100" marB="38100">
+                    <a:solidFill>
+                      <a:srgbClr val="FFFFFF"/>
+                    </a:solidFill>
+                  </a:tcPr>
+                </a:tc>
+                <a:tc>
+                  <a:txBody>
+                    <a:bodyPr/>
+                    <a:lstStyle/>
+                    <a:p>
+                      <a:r>
+                        <a:rPr sz="1350" b="0" i="0">
+                          <a:solidFill>
+                            <a:srgbClr val="0B1220"/>
+                          </a:solidFill>
+                          <a:latin typeface="Arial"/>
+                        </a:rPr>
+                        <a:t>12.14 / 20.44</a:t>
+                      </a:r>
+                    </a:p>
+                  </a:txBody>
+                  <a:tcPr marT="38100" marB="38100">
+                    <a:solidFill>
+                      <a:srgbClr val="FFFFFF"/>
+                    </a:solidFill>
+                  </a:tcPr>
+                </a:tc>
+              </a:tr>
+            </a:tbl>
+          </a:graphicData>
+        </a:graphic>
+      </p:graphicFrame>
       <p:sp>
         <p:nvSpPr>
           <p:cNvPr id="6" name="TextBox 5"/>
@@ -4247,8 +4974,8 @@
         </p:nvSpPr>
         <p:spPr>
           <a:xfrm>
-            <a:off x="548640" y="5897880"/>
-            <a:ext cx="11064240" cy="822960"/>
+            <a:off x="548640" y="5568696"/>
+            <a:ext cx="11064240" cy="914400"/>
           </a:xfrm>
           <a:prstGeom prst="rect">
             <a:avLst/>
@@ -4262,13 +4989,13 @@
           <a:lstStyle/>
           <a:p>
             <a:r>
-              <a:rPr sz="1300" b="0">
-                <a:solidFill>
-                  <a:srgbClr val="0B1220"/>
-                </a:solidFill>
-                <a:latin typeface="Arial"/>
-              </a:rPr>
-              <a:t>Later recordings of the same 14 participants the model was trained on — not new patients. Serving − persistence: -1.88 mg/dL [-2.53, -1.32] at 30 min, -2.96 mg/dL [-4.34, -1.77] at 60 min. Test origins 7,730 (≈ 644 h); forecasts issued for 99.9 % of origins with a target.</a:t>
+              <a:rPr sz="1400" b="0">
+                <a:solidFill>
+                  <a:srgbClr val="0B1220"/>
+                </a:solidFill>
+                <a:latin typeface="Arial"/>
+              </a:rPr>
+              <a:t>Mean absolute error in mg/dL, averaged equally over participants: an average error, not an accuracy percentage. Each group is a different model and a different test — do not compare across groups. Serving ranges (target 80 %) covered 74.2 % / 74.0 %: under-coverage. Pending rows are filled only from verified, locked summaries.</a:t>
             </a:r>
           </a:p>
         </p:txBody>
@@ -4307,8 +5034,8 @@
         </p:nvSpPr>
         <p:spPr>
           <a:xfrm>
-            <a:off x="548640" y="320040"/>
-            <a:ext cx="11064240" cy="731520"/>
+            <a:off x="548640" y="128016"/>
+            <a:ext cx="11064240" cy="274320"/>
           </a:xfrm>
           <a:prstGeom prst="rect">
             <a:avLst/>
@@ -4322,20 +5049,54 @@
           <a:lstStyle/>
           <a:p>
             <a:r>
+              <a:rPr sz="1100" b="1">
+                <a:solidFill>
+                  <a:srgbClr val="2563EB"/>
+                </a:solidFill>
+                <a:latin typeface="Arial"/>
+              </a:rPr>
+              <a:t>SERVING MODEL · later recordings of the same 14 participants it was trained on — not new people</a:t>
+            </a:r>
+          </a:p>
+        </p:txBody>
+      </p:sp>
+      <p:sp>
+        <p:nvSpPr>
+          <p:cNvPr id="3" name="TextBox 2"/>
+          <p:cNvSpPr txBox="1"/>
+          <p:nvPr/>
+        </p:nvSpPr>
+        <p:spPr>
+          <a:xfrm>
+            <a:off x="548640" y="384048"/>
+            <a:ext cx="11064240" cy="640080"/>
+          </a:xfrm>
+          <a:prstGeom prst="rect">
+            <a:avLst/>
+          </a:prstGeom>
+          <a:noFill/>
+        </p:spPr>
+        <p:txBody>
+          <a:bodyPr wrap="square">
+            <a:spAutoFit/>
+          </a:bodyPr>
+          <a:lstStyle/>
+          <a:p>
+            <a:r>
               <a:rPr sz="3000" b="1">
                 <a:solidFill>
                   <a:srgbClr val="0B1220"/>
                 </a:solidFill>
                 <a:latin typeface="Arial"/>
               </a:rPr>
-              <a:t>Measured evaluation: does personalization help?</a:t>
+              <a:t>Measured evaluation: forecast accuracy (later days)</a:t>
             </a:r>
           </a:p>
         </p:txBody>
       </p:sp>
       <p:cxnSp>
         <p:nvCxnSpPr>
-          <p:cNvPr id="3" name="Connector 2"/>
+          <p:cNvPr id="4" name="Connector 3"/>
           <p:cNvCxnSpPr/>
           <p:nvPr/>
         </p:nvCxnSpPr>
@@ -4356,7 +5117,7 @@
       </p:cxnSp>
       <p:sp>
         <p:nvSpPr>
-          <p:cNvPr id="4" name="TextBox 3"/>
+          <p:cNvPr id="5" name="TextBox 4"/>
           <p:cNvSpPr txBox="1"/>
           <p:nvPr/>
         </p:nvSpPr>
@@ -4390,7 +5151,7 @@
       </p:sp>
       <p:pic>
         <p:nvPicPr>
-          <p:cNvPr id="5" name="Picture 4" descr="fig_paired_differences.png"/>
+          <p:cNvPr id="6" name="Picture 5" descr="fig_mae_test.png"/>
           <p:cNvPicPr>
             <a:picLocks noChangeAspect="1"/>
           </p:cNvPicPr>
@@ -4405,7 +5166,7 @@
         <p:spPr>
           <a:xfrm>
             <a:off x="548640" y="1188720"/>
-            <a:ext cx="11064240" cy="3201781"/>
+            <a:ext cx="11064240" cy="3964640"/>
           </a:xfrm>
           <a:prstGeom prst="rect">
             <a:avLst/>
@@ -4414,7 +5175,7 @@
       </p:pic>
       <p:sp>
         <p:nvSpPr>
-          <p:cNvPr id="6" name="TextBox 5"/>
+          <p:cNvPr id="7" name="TextBox 6"/>
           <p:cNvSpPr txBox="1"/>
           <p:nvPr/>
         </p:nvSpPr>
@@ -4441,7 +5202,7 @@
                 </a:solidFill>
                 <a:latin typeface="Arial"/>
               </a:rPr>
-              <a:t>Adaptation (LightGBM): -0.18 mg/dL [-0.35, -0.01] at 30 min, -0.33 mg/dL [-0.68, 0.02] at 60 min — small; population 13.14 / 20.59, frozen state 13.19 / 20.65, adaptive 12.96 / 20.26 mg/dL. New-participant cold start: 14.66/24.26 → 13.81/22.12 mg/dL with adaptation.</a:t>
+              <a:t>Later recordings of the same 14 participants the model was trained on — not new patients. Serving − persistence: -1.88 mg/dL [-2.53, -1.32] at 30 min, -2.96 mg/dL [-4.34, -1.77] at 60 min. Test origins 7,730 (≈ 644 h); forecasts issued for 99.9 % of origins with a target.</a:t>
             </a:r>
           </a:p>
         </p:txBody>
@@ -4480,8 +5241,8 @@
         </p:nvSpPr>
         <p:spPr>
           <a:xfrm>
-            <a:off x="548640" y="320040"/>
-            <a:ext cx="11064240" cy="731520"/>
+            <a:off x="548640" y="128016"/>
+            <a:ext cx="11064240" cy="274320"/>
           </a:xfrm>
           <a:prstGeom prst="rect">
             <a:avLst/>
@@ -4495,20 +5256,54 @@
           <a:lstStyle/>
           <a:p>
             <a:r>
+              <a:rPr sz="1100" b="1">
+                <a:solidFill>
+                  <a:srgbClr val="2563EB"/>
+                </a:solidFill>
+                <a:latin typeface="Arial"/>
+              </a:rPr>
+              <a:t>SERVING MODEL · later recordings of the same 14 participants it was trained on — not new people</a:t>
+            </a:r>
+          </a:p>
+        </p:txBody>
+      </p:sp>
+      <p:sp>
+        <p:nvSpPr>
+          <p:cNvPr id="3" name="TextBox 2"/>
+          <p:cNvSpPr txBox="1"/>
+          <p:nvPr/>
+        </p:nvSpPr>
+        <p:spPr>
+          <a:xfrm>
+            <a:off x="548640" y="384048"/>
+            <a:ext cx="11064240" cy="640080"/>
+          </a:xfrm>
+          <a:prstGeom prst="rect">
+            <a:avLst/>
+          </a:prstGeom>
+          <a:noFill/>
+        </p:spPr>
+        <p:txBody>
+          <a:bodyPr wrap="square">
+            <a:spAutoFit/>
+          </a:bodyPr>
+          <a:lstStyle/>
+          <a:p>
+            <a:r>
               <a:rPr sz="3000" b="1">
                 <a:solidFill>
                   <a:srgbClr val="0B1220"/>
                 </a:solidFill>
                 <a:latin typeface="Arial"/>
               </a:rPr>
-              <a:t>Measured evaluation: every participant</a:t>
+              <a:t>Measured evaluation: does personalization help?</a:t>
             </a:r>
           </a:p>
         </p:txBody>
       </p:sp>
       <p:cxnSp>
         <p:nvCxnSpPr>
-          <p:cNvPr id="3" name="Connector 2"/>
+          <p:cNvPr id="4" name="Connector 3"/>
           <p:cNvCxnSpPr/>
           <p:nvPr/>
         </p:nvCxnSpPr>
@@ -4529,7 +5324,7 @@
       </p:cxnSp>
       <p:sp>
         <p:nvSpPr>
-          <p:cNvPr id="4" name="TextBox 3"/>
+          <p:cNvPr id="5" name="TextBox 4"/>
           <p:cNvSpPr txBox="1"/>
           <p:nvPr/>
         </p:nvSpPr>
@@ -4563,7 +5358,7 @@
       </p:sp>
       <p:pic>
         <p:nvPicPr>
-          <p:cNvPr id="5" name="Picture 4" descr="fig_per_participant.png"/>
+          <p:cNvPr id="6" name="Picture 5" descr="fig_paired_differences.png"/>
           <p:cNvPicPr>
             <a:picLocks noChangeAspect="1"/>
           </p:cNvPicPr>
@@ -4577,8 +5372,8 @@
         </p:blipFill>
         <p:spPr>
           <a:xfrm>
-            <a:off x="926817" y="1188720"/>
-            <a:ext cx="10338061" cy="4572000"/>
+            <a:off x="548640" y="1188720"/>
+            <a:ext cx="11064240" cy="3201781"/>
           </a:xfrm>
           <a:prstGeom prst="rect">
             <a:avLst/>
@@ -4587,7 +5382,7 @@
       </p:pic>
       <p:sp>
         <p:nvSpPr>
-          <p:cNvPr id="6" name="TextBox 5"/>
+          <p:cNvPr id="7" name="TextBox 6"/>
           <p:cNvSpPr txBox="1"/>
           <p:nvPr/>
         </p:nvSpPr>
@@ -4614,7 +5409,7 @@
                 </a:solidFill>
                 <a:latin typeface="Arial"/>
               </a:rPr>
-              <a:t>Per-participant test MAE, persistence vs the serving pipeline. Gains are uneven: large for some participants, none for a few at 60 minutes. Fourteen people cannot establish population-level performance.</a:t>
+              <a:t>Adaptation (LightGBM): -0.18 mg/dL [-0.35, -0.01] at 30 min, -0.33 mg/dL [-0.68, 0.02] at 60 min — small; population 13.14 / 20.59, frozen state 13.19 / 20.65, adaptive 12.96 / 20.26 mg/dL. New-participant cold start: 14.66/24.26 → 13.81/22.12 mg/dL with adaptation.</a:t>
             </a:r>
           </a:p>
         </p:txBody>
@@ -4653,8 +5448,8 @@
         </p:nvSpPr>
         <p:spPr>
           <a:xfrm>
-            <a:off x="548640" y="320040"/>
-            <a:ext cx="11064240" cy="731520"/>
+            <a:off x="548640" y="128016"/>
+            <a:ext cx="11064240" cy="274320"/>
           </a:xfrm>
           <a:prstGeom prst="rect">
             <a:avLst/>
@@ -4668,20 +5463,54 @@
           <a:lstStyle/>
           <a:p>
             <a:r>
+              <a:rPr sz="1100" b="1">
+                <a:solidFill>
+                  <a:srgbClr val="2563EB"/>
+                </a:solidFill>
+                <a:latin typeface="Arial"/>
+              </a:rPr>
+              <a:t>SERVING MODEL · later recordings of the same 14 participants it was trained on — not new people</a:t>
+            </a:r>
+          </a:p>
+        </p:txBody>
+      </p:sp>
+      <p:sp>
+        <p:nvSpPr>
+          <p:cNvPr id="3" name="TextBox 2"/>
+          <p:cNvSpPr txBox="1"/>
+          <p:nvPr/>
+        </p:nvSpPr>
+        <p:spPr>
+          <a:xfrm>
+            <a:off x="548640" y="384048"/>
+            <a:ext cx="11064240" cy="640080"/>
+          </a:xfrm>
+          <a:prstGeom prst="rect">
+            <a:avLst/>
+          </a:prstGeom>
+          <a:noFill/>
+        </p:spPr>
+        <p:txBody>
+          <a:bodyPr wrap="square">
+            <a:spAutoFit/>
+          </a:bodyPr>
+          <a:lstStyle/>
+          <a:p>
+            <a:r>
               <a:rPr sz="3000" b="1">
                 <a:solidFill>
                   <a:srgbClr val="0B1220"/>
                 </a:solidFill>
                 <a:latin typeface="Arial"/>
               </a:rPr>
-              <a:t>Measured evaluation: early warning and uncertainty</a:t>
+              <a:t>Measured evaluation: every participant</a:t>
             </a:r>
           </a:p>
         </p:txBody>
       </p:sp>
       <p:cxnSp>
         <p:nvCxnSpPr>
-          <p:cNvPr id="3" name="Connector 2"/>
+          <p:cNvPr id="4" name="Connector 3"/>
           <p:cNvCxnSpPr/>
           <p:nvPr/>
         </p:nvCxnSpPr>
@@ -4702,7 +5531,7 @@
       </p:cxnSp>
       <p:sp>
         <p:nvSpPr>
-          <p:cNvPr id="4" name="TextBox 3"/>
+          <p:cNvPr id="5" name="TextBox 4"/>
           <p:cNvSpPr txBox="1"/>
           <p:nvPr/>
         </p:nvSpPr>
@@ -4734,16 +5563,40 @@
           </a:p>
         </p:txBody>
       </p:sp>
-      <p:sp>
-        <p:nvSpPr>
-          <p:cNvPr id="5" name="TextBox 4"/>
+      <p:pic>
+        <p:nvPicPr>
+          <p:cNvPr id="6" name="Picture 5" descr="fig_per_participant.png"/>
+          <p:cNvPicPr>
+            <a:picLocks noChangeAspect="1"/>
+          </p:cNvPicPr>
+          <p:nvPr/>
+        </p:nvPicPr>
+        <p:blipFill>
+          <a:blip r:embed="rId2"/>
+          <a:stretch>
+            <a:fillRect/>
+          </a:stretch>
+        </p:blipFill>
+        <p:spPr>
+          <a:xfrm>
+            <a:off x="926817" y="1188720"/>
+            <a:ext cx="10338061" cy="4572000"/>
+          </a:xfrm>
+          <a:prstGeom prst="rect">
+            <a:avLst/>
+          </a:prstGeom>
+        </p:spPr>
+      </p:pic>
+      <p:sp>
+        <p:nvSpPr>
+          <p:cNvPr id="7" name="TextBox 6"/>
           <p:cNvSpPr txBox="1"/>
           <p:nvPr/>
         </p:nvSpPr>
         <p:spPr>
           <a:xfrm>
-            <a:off x="548640" y="1234440"/>
-            <a:ext cx="11064240" cy="5120640"/>
+            <a:off x="548640" y="5897880"/>
+            <a:ext cx="11064240" cy="822960"/>
           </a:xfrm>
           <a:prstGeom prst="rect">
             <a:avLst/>
@@ -4756,67 +5609,14 @@
           </a:bodyPr>
           <a:lstStyle/>
           <a:p>
-            <a:pPr>
-              <a:spcAft>
-                <a:spcPts val="1000"/>
-              </a:spcAft>
-            </a:pPr>
-            <a:r>
-              <a:rPr sz="1700">
-                <a:solidFill>
-                  <a:srgbClr val="0B1220"/>
-                </a:solidFill>
-                <a:latin typeface="Arial"/>
-              </a:rPr>
-              <a:t>•  60-min warning (test, margin threshold -10 mg/dL chosen on validation by F1): 61/64 new onsets detected, precision 0.60, 40 false alarms (1.49 per observed patient-day; 2.28 per eligible day); forecast lead median 30 min (episode start 30 min).</a:t>
-            </a:r>
-          </a:p>
-          <a:p>
-            <a:pPr>
-              <a:spcAft>
-                <a:spcPts val="1000"/>
-              </a:spcAft>
-            </a:pPr>
-            <a:r>
-              <a:rPr sz="1700">
-                <a:solidFill>
-                  <a:srgbClr val="0B1220"/>
-                </a:solidFill>
-                <a:latin typeface="Arial"/>
-              </a:rPr>
-              <a:t>•  Same procedure on persistence (fires at glucose ≥ 150): 63/64 detected, 70 false alarms (2.61 per observed patient-day; 4.00 per eligible day).</a:t>
-            </a:r>
-          </a:p>
-          <a:p>
-            <a:pPr>
-              <a:spcAft>
-                <a:spcPts val="1000"/>
-              </a:spcAft>
-            </a:pPr>
-            <a:r>
-              <a:rPr sz="1700">
-                <a:solidFill>
-                  <a:srgbClr val="0B1220"/>
-                </a:solidFill>
-                <a:latin typeface="Arial"/>
-              </a:rPr>
-              <a:t>•  Prediction ranges (target coverage 80 %) covered 74.2 % (30 min) and 74.0 % (60 min) on test, 60–82 % and 51–88 % per participant — under-covered; no guarantee claimed.</a:t>
-            </a:r>
-          </a:p>
-          <a:p>
-            <a:pPr>
-              <a:spcAft>
-                <a:spcPts val="1000"/>
-              </a:spcAft>
-            </a:pPr>
-            <a:r>
-              <a:rPr sz="1700">
-                <a:solidFill>
-                  <a:srgbClr val="0B1220"/>
-                </a:solidFill>
-                <a:latin typeface="Arial"/>
-              </a:rPr>
-              <a:t>•  Optimistic meal logging: 19.07 vs 20.59 mg/dL at 60 min — timely meal data would likely help most.</a:t>
+            <a:r>
+              <a:rPr sz="1300" b="0">
+                <a:solidFill>
+                  <a:srgbClr val="0B1220"/>
+                </a:solidFill>
+                <a:latin typeface="Arial"/>
+              </a:rPr>
+              <a:t>Per-participant test MAE, persistence vs the serving pipeline. Gains are uneven: large for some participants, none for a few at 60 minutes. Fourteen people cannot establish population-level performance.</a:t>
             </a:r>
           </a:p>
         </p:txBody>
@@ -4855,8 +5655,8 @@
         </p:nvSpPr>
         <p:spPr>
           <a:xfrm>
-            <a:off x="548640" y="320040"/>
-            <a:ext cx="11064240" cy="731520"/>
+            <a:off x="548640" y="128016"/>
+            <a:ext cx="11064240" cy="274320"/>
           </a:xfrm>
           <a:prstGeom prst="rect">
             <a:avLst/>
@@ -4870,20 +5670,54 @@
           <a:lstStyle/>
           <a:p>
             <a:r>
+              <a:rPr sz="1100" b="1">
+                <a:solidFill>
+                  <a:srgbClr val="2563EB"/>
+                </a:solidFill>
+                <a:latin typeface="Arial"/>
+              </a:rPr>
+              <a:t>SERVING MODEL · later recordings of the same 14 participants it was trained on — not new people</a:t>
+            </a:r>
+          </a:p>
+        </p:txBody>
+      </p:sp>
+      <p:sp>
+        <p:nvSpPr>
+          <p:cNvPr id="3" name="TextBox 2"/>
+          <p:cNvSpPr txBox="1"/>
+          <p:nvPr/>
+        </p:nvSpPr>
+        <p:spPr>
+          <a:xfrm>
+            <a:off x="548640" y="384048"/>
+            <a:ext cx="11064240" cy="640080"/>
+          </a:xfrm>
+          <a:prstGeom prst="rect">
+            <a:avLst/>
+          </a:prstGeom>
+          <a:noFill/>
+        </p:spPr>
+        <p:txBody>
+          <a:bodyPr wrap="square">
+            <a:spAutoFit/>
+          </a:bodyPr>
+          <a:lstStyle/>
+          <a:p>
+            <a:r>
               <a:rPr sz="3000" b="1">
                 <a:solidFill>
                   <a:srgbClr val="0B1220"/>
                 </a:solidFill>
                 <a:latin typeface="Arial"/>
               </a:rPr>
-              <a:t>Research: new people and an independent cohort</a:t>
+              <a:t>Measured evaluation: early warning and uncertainty</a:t>
             </a:r>
           </a:p>
         </p:txBody>
       </p:sp>
       <p:cxnSp>
         <p:nvCxnSpPr>
-          <p:cNvPr id="3" name="Connector 2"/>
+          <p:cNvPr id="4" name="Connector 3"/>
           <p:cNvCxnSpPr/>
           <p:nvPr/>
         </p:nvCxnSpPr>
@@ -4904,7 +5738,7 @@
       </p:cxnSp>
       <p:sp>
         <p:nvSpPr>
-          <p:cNvPr id="4" name="TextBox 3"/>
+          <p:cNvPr id="5" name="TextBox 4"/>
           <p:cNvSpPr txBox="1"/>
           <p:nvPr/>
         </p:nvSpPr>
@@ -4938,7 +5772,7 @@
       </p:sp>
       <p:sp>
         <p:nvSpPr>
-          <p:cNvPr id="5" name="TextBox 4"/>
+          <p:cNvPr id="6" name="TextBox 5"/>
           <p:cNvSpPr txBox="1"/>
           <p:nvPr/>
         </p:nvSpPr>
@@ -4970,7 +5804,7 @@
                 </a:solidFill>
                 <a:latin typeface="Arial"/>
               </a:rPr>
-              <a:t>•  Models kept separate: the v2 recipe (LightGBM, dynamic streams only; the demo model when this experiment was declared), a Ridge five-minute candidate on CGM-only features, and a separate 15-minute LightGBM as the external check.</a:t>
+              <a:t>•  60-min warning (test, margin threshold -10 mg/dL chosen on validation by F1): 61/64 new onsets detected, precision 0.60, 40 false alarms (1.49 per observed patient-day; 2.28 per eligible day); forecast lead median 30 min (episode start 30 min).</a:t>
             </a:r>
           </a:p>
           <a:p>
@@ -4986,7 +5820,7 @@
                 </a:solidFill>
                 <a:latin typeface="Arial"/>
               </a:rPr>
-              <a:t>•  145 participants imported; 14 evaluated internally (five participant folds, each person held out once) and 98 evaluated externally (ShanghaiT2DM, China, opened once).</a:t>
+              <a:t>•  Same procedure on persistence (fires at glucose ≥ 150): 63/64 detected, 70 false alarms (2.61 per observed patient-day; 4.00 per eligible day).</a:t>
             </a:r>
           </a:p>
           <a:p>
@@ -5002,7 +5836,7 @@
                 </a:solidFill>
                 <a:latin typeface="Arial"/>
               </a:rPr>
-              <a:t>•  Held-out people, 30 / 60 min: candidate 13.88 / 22.30 vs v2 recipe refit 14.52 / 24.25 vs persistence 15.34 / 24.47 mg/dL — but worse on large highs (+2.71 [+0.28, +5.11] mg/dL at 60 min when the target exceeded 180).</a:t>
+              <a:t>•  Prediction ranges (target coverage 80 %) covered 74.2 % (30 min) and 74.0 % (60 min) on test, 60–82 % and 51–88 % per participant — under-covered; no guarantee claimed.</a:t>
             </a:r>
           </a:p>
           <a:p>
@@ -5018,39 +5852,7 @@
                 </a:solidFill>
                 <a:latin typeface="Arial"/>
               </a:rPr>
-              <a:t>•  Warnings chosen for ≤ 2 false alarms per day: 301/329 onsets at 1.31 false alarms per observed day (v2 recipe: 329/329 at 2.80).</a:t>
-            </a:r>
-          </a:p>
-          <a:p>
-            <a:pPr>
-              <a:spcAft>
-                <a:spcPts val="1000"/>
-              </a:spcAft>
-            </a:pPr>
-            <a:r>
-              <a:rPr sz="1700">
-                <a:solidFill>
-                  <a:srgbClr val="0B1220"/>
-                </a:solidFill>
-                <a:latin typeface="Arial"/>
-              </a:rPr>
-              <a:t>•  External 15-minute LightGBM vs persistence: -0.99 [-1.21, -0.77] mg/dL at 30 min (clear); -0.34 [-0.76, +0.10] mg/dL at 60 min (inconclusive).</a:t>
-            </a:r>
-          </a:p>
-          <a:p>
-            <a:pPr>
-              <a:spcAft>
-                <a:spcPts val="1000"/>
-              </a:spcAft>
-            </a:pPr>
-            <a:r>
-              <a:rPr sz="1700">
-                <a:solidFill>
-                  <a:srgbClr val="0B1220"/>
-                </a:solidFill>
-                <a:latin typeface="Arial"/>
-              </a:rPr>
-              <a:t>•  Not promoted, and not eligible as the demo model: the Ridge candidate reads CGM only. CGMacros was already inspected, so its folds are internal validation; the next protocol also bounds high-glucose error, missed onsets and false warnings (declared, not run).</a:t>
+              <a:t>•  Optimistic meal logging: 19.07 vs 20.59 mg/dL at 60 min — timely meal data would likely help most.</a:t>
             </a:r>
           </a:p>
         </p:txBody>
@@ -5089,8 +5891,8 @@
         </p:nvSpPr>
         <p:spPr>
           <a:xfrm>
-            <a:off x="548640" y="320040"/>
-            <a:ext cx="11064240" cy="731520"/>
+            <a:off x="548640" y="128016"/>
+            <a:ext cx="11064240" cy="274320"/>
           </a:xfrm>
           <a:prstGeom prst="rect">
             <a:avLst/>
@@ -5104,20 +5906,54 @@
           <a:lstStyle/>
           <a:p>
             <a:r>
+              <a:rPr sz="1100" b="1">
+                <a:solidFill>
+                  <a:srgbClr val="2563EB"/>
+                </a:solidFill>
+                <a:latin typeface="Arial"/>
+              </a:rPr>
+              <a:t>RESEARCH · each participant held out entirely · internal validation · not the serving model</a:t>
+            </a:r>
+          </a:p>
+        </p:txBody>
+      </p:sp>
+      <p:sp>
+        <p:nvSpPr>
+          <p:cNvPr id="3" name="TextBox 2"/>
+          <p:cNvSpPr txBox="1"/>
+          <p:nvPr/>
+        </p:nvSpPr>
+        <p:spPr>
+          <a:xfrm>
+            <a:off x="548640" y="384048"/>
+            <a:ext cx="11064240" cy="640080"/>
+          </a:xfrm>
+          <a:prstGeom prst="rect">
+            <a:avLst/>
+          </a:prstGeom>
+          <a:noFill/>
+        </p:spPr>
+        <p:txBody>
+          <a:bodyPr wrap="square">
+            <a:spAutoFit/>
+          </a:bodyPr>
+          <a:lstStyle/>
+          <a:p>
+            <a:r>
               <a:rPr sz="3000" b="1">
                 <a:solidFill>
                   <a:srgbClr val="0B1220"/>
                 </a:solidFill>
                 <a:latin typeface="Arial"/>
               </a:rPr>
-              <a:t>Research: warning two hours ahead</a:t>
+              <a:t>Research: people held out entirely</a:t>
             </a:r>
           </a:p>
         </p:txBody>
       </p:sp>
       <p:cxnSp>
         <p:nvCxnSpPr>
-          <p:cNvPr id="3" name="Connector 2"/>
+          <p:cNvPr id="4" name="Connector 3"/>
           <p:cNvCxnSpPr/>
           <p:nvPr/>
         </p:nvCxnSpPr>
@@ -5138,7 +5974,7 @@
       </p:cxnSp>
       <p:sp>
         <p:nvSpPr>
-          <p:cNvPr id="4" name="TextBox 3"/>
+          <p:cNvPr id="5" name="TextBox 4"/>
           <p:cNvSpPr txBox="1"/>
           <p:nvPr/>
         </p:nvSpPr>
@@ -5172,7 +6008,7 @@
       </p:sp>
       <p:sp>
         <p:nvSpPr>
-          <p:cNvPr id="5" name="TextBox 4"/>
+          <p:cNvPr id="6" name="TextBox 5"/>
           <p:cNvSpPr txBox="1"/>
           <p:nvPr/>
         </p:nvSpPr>
@@ -5204,7 +6040,7 @@
                 </a:solidFill>
                 <a:latin typeface="Arial"/>
               </a:rPr>
-              <a:t>•  The brief's example is a spike predicted 2 hours ahead. Declared before any fit (decision D-043): the people-held-out procedure above, same folds, plus a 120-minute horizon. 14 people, each held out once; not the demo model, nothing promoted.</a:t>
+              <a:t>•  Models kept separate: the v2 recipe (LightGBM, dynamic streams only; the demo model when this experiment was declared) and a Ridge five-minute candidate on CGM-only features. Neither is the serving model.</a:t>
             </a:r>
           </a:p>
           <a:p>
@@ -5220,7 +6056,7 @@
                 </a:solidFill>
                 <a:latin typeface="Arial"/>
               </a:rPr>
-              <a:t>•  Forecast error at 120 min: 30.6 mg/dL vs persistence 35.9 (-5.25 [-6.44, -4.05] mg/dL); at 60 min 22.3 vs 24.5.</a:t>
+              <a:t>•  145 participants imported; 14 evaluated here (five participant folds, each person held out once, protocol frozen before fitting, D-032).</a:t>
             </a:r>
           </a:p>
           <a:p>
@@ -5236,7 +6072,7 @@
                 </a:solidFill>
                 <a:latin typeface="Arial"/>
               </a:rPr>
-              <a:t>•  120-min warning: 315/329 onsets warned, 1.62 false alarms per observed day, median forecast lead 15 min. For comparison, 60-min warning: 313/329 onsets warned, 1.48 false alarms per observed day, median forecast lead 10 min.</a:t>
+              <a:t>•  Held-out people, 30 / 60 min: candidate 13.88 / 22.30 vs v2 recipe refit 14.52 / 24.25 vs persistence 15.34 / 24.47 mg/dL — but worse on large highs (+2.71 [+0.28, +5.11] mg/dL at 60 min when the target exceeded 180).</a:t>
             </a:r>
           </a:p>
           <a:p>
@@ -5252,7 +6088,7 @@
                 </a:solidFill>
                 <a:latin typeface="Arial"/>
               </a:rPr>
-              <a:t>•  Profile (EHR-like) inputs at 120 min, LightGBM with minus without: -0.86 [-2.60, +1.02] mg/dL (no reliable benefit on people held out).</a:t>
+              <a:t>•  Warnings chosen for ≤ 2 false alarms per day: 301/329 onsets at 1.31 false alarms per observed day (v2 recipe: 329/329 at 2.80).</a:t>
             </a:r>
           </a:p>
           <a:p>
@@ -5268,23 +6104,7 @@
                 </a:solidFill>
                 <a:latin typeface="Arial"/>
               </a:rPr>
-              <a:t>•  Thresholds chosen on development folds only (≤ 2 false alarms per observed day); each test fold opened once. The 14 people were inspected in earlier experiments, so this is internal validation.</a:t>
-            </a:r>
-          </a:p>
-          <a:p>
-            <a:pPr>
-              <a:spcAft>
-                <a:spcPts val="1000"/>
-              </a:spcAft>
-            </a:pPr>
-            <a:r>
-              <a:rPr sz="1700">
-                <a:solidFill>
-                  <a:srgbClr val="0B1220"/>
-                </a:solidFill>
-                <a:latin typeface="Arial"/>
-              </a:rPr>
-              <a:t>•  Independent cohort (98 ShanghaiT2DM people, CGM-only 15-minute model, assessed once; D-045): 29.6 vs persistence 31.7 mg/dL at 120 min (-2.12 [-2.67, -1.53]), better for 78 of 98 people.</a:t>
+              <a:t>•  Not promoted, and not eligible as the demo model: the Ridge candidate reads CGM only. CGMacros was already inspected, so its folds are internal validation; the next protocol also bounds high-glucose error, missed onsets and false warnings (declared, not run).</a:t>
             </a:r>
           </a:p>
         </p:txBody>
@@ -5324,7 +6144,7 @@
         <p:spPr>
           <a:xfrm>
             <a:off x="548640" y="320040"/>
-            <a:ext cx="11064240" cy="731520"/>
+            <a:ext cx="11064240" cy="640080"/>
           </a:xfrm>
           <a:prstGeom prst="rect">
             <a:avLst/>
@@ -5541,8 +6361,8 @@
         </p:nvSpPr>
         <p:spPr>
           <a:xfrm>
-            <a:off x="548640" y="320040"/>
-            <a:ext cx="11064240" cy="731520"/>
+            <a:off x="548640" y="128016"/>
+            <a:ext cx="11064240" cy="274320"/>
           </a:xfrm>
           <a:prstGeom prst="rect">
             <a:avLst/>
@@ -5556,20 +6376,54 @@
           <a:lstStyle/>
           <a:p>
             <a:r>
+              <a:rPr sz="1100" b="1">
+                <a:solidFill>
+                  <a:srgbClr val="2563EB"/>
+                </a:solidFill>
+                <a:latin typeface="Arial"/>
+              </a:rPr>
+              <a:t>RESEARCH · each participant held out entirely · internal validation · not the serving model</a:t>
+            </a:r>
+          </a:p>
+        </p:txBody>
+      </p:sp>
+      <p:sp>
+        <p:nvSpPr>
+          <p:cNvPr id="3" name="TextBox 2"/>
+          <p:cNvSpPr txBox="1"/>
+          <p:nvPr/>
+        </p:nvSpPr>
+        <p:spPr>
+          <a:xfrm>
+            <a:off x="548640" y="384048"/>
+            <a:ext cx="11064240" cy="640080"/>
+          </a:xfrm>
+          <a:prstGeom prst="rect">
+            <a:avLst/>
+          </a:prstGeom>
+          <a:noFill/>
+        </p:spPr>
+        <p:txBody>
+          <a:bodyPr wrap="square">
+            <a:spAutoFit/>
+          </a:bodyPr>
+          <a:lstStyle/>
+          <a:p>
+            <a:r>
               <a:rPr sz="3000" b="1">
                 <a:solidFill>
                   <a:srgbClr val="0B1220"/>
                 </a:solidFill>
                 <a:latin typeface="Arial"/>
               </a:rPr>
-              <a:t>Research: what we fixed, and what we could not</a:t>
+              <a:t>Research: warning two hours ahead</a:t>
             </a:r>
           </a:p>
         </p:txBody>
       </p:sp>
       <p:cxnSp>
         <p:nvCxnSpPr>
-          <p:cNvPr id="3" name="Connector 2"/>
+          <p:cNvPr id="4" name="Connector 3"/>
           <p:cNvCxnSpPr/>
           <p:nvPr/>
         </p:nvCxnSpPr>
@@ -5590,7 +6444,7 @@
       </p:cxnSp>
       <p:sp>
         <p:nvSpPr>
-          <p:cNvPr id="4" name="TextBox 3"/>
+          <p:cNvPr id="5" name="TextBox 4"/>
           <p:cNvSpPr txBox="1"/>
           <p:nvPr/>
         </p:nvSpPr>
@@ -5624,7 +6478,7 @@
       </p:sp>
       <p:sp>
         <p:nvSpPr>
-          <p:cNvPr id="5" name="TextBox 4"/>
+          <p:cNvPr id="6" name="TextBox 5"/>
           <p:cNvSpPr txBox="1"/>
           <p:nvPr/>
         </p:nvSpPr>
@@ -5656,7 +6510,7 @@
                 </a:solidFill>
                 <a:latin typeface="Arial"/>
               </a:rPr>
-              <a:t>•  Each test below was declared and committed before computing it; the same 14 already-inspected people (internal validation).</a:t>
+              <a:t>•  The brief's example is a spike predicted 2 hours ahead. Declared before any fit (decision D-043): the people-held-out procedure above, same folds, plus a 120-minute horizon. 14 people, each held out once; not the demo model, nothing promoted.</a:t>
             </a:r>
           </a:p>
           <a:p>
@@ -5672,7 +6526,7 @@
                 </a:solidFill>
                 <a:latin typeface="Arial"/>
               </a:rPr>
-              <a:t>•  Fixed — prediction ranges: calibrating on all development people instead of 2 per fold raised two-hour coverage from 76.5 % to 79.8 % (target 80 %; 60 min 78.2 → 79.5 %), ranges 7 mg/dL wider.</a:t>
+              <a:t>•  Forecast error at 120 min: 30.6 mg/dL vs persistence 35.9 (-5.25 [-6.44, -4.05] mg/dL); at 60 min 22.3 vs 24.5.</a:t>
             </a:r>
           </a:p>
           <a:p>
@@ -5688,7 +6542,7 @@
                 </a:solidFill>
                 <a:latin typeface="Arial"/>
               </a:rPr>
-              <a:t>•  Not shown — earlier warning: 126 vs 123 of 329 onsets warned ≥ 30 min ahead (+0.9 points [-5.5, +6.6]) at the same workload; median lead still 15 min.</a:t>
+              <a:t>•  120-min warning: 315/329 onsets warned, 1.62 false alarms per observed day, median forecast lead 15 min. For comparison, 60-min warning: 313/329 onsets warned, 1.48 false alarms per observed day, median forecast lead 10 min.</a:t>
             </a:r>
           </a:p>
           <a:p>
@@ -5704,7 +6558,7 @@
                 </a:solidFill>
                 <a:latin typeface="Arial"/>
               </a:rPr>
-              <a:t>•  Not shown — health record as a new person's starting correction: -0.53 [-1.57, +0.58] mg/dL at 120 min, -0.93 [-2.74, +0.48] in the first 24 hours; the intervals cross zero, so no benefit is claimed.</a:t>
+              <a:t>•  Profile (EHR-like) inputs at 120 min, LightGBM with minus without: -0.86 [-2.60, +1.02] mg/dL (no reliable benefit on people held out).</a:t>
             </a:r>
           </a:p>
           <a:p>
@@ -5720,55 +6574,7 @@
                 </a:solidFill>
                 <a:latin typeface="Arial"/>
               </a:rPr>
-              <a:t>•  Not adopted — a LightGBM–CatBoost blend (D-048): +0.02 mg/dL at 60 min on development people against a 0.5 target; held-out folds never opened.</a:t>
-            </a:r>
-          </a:p>
-          <a:p>
-            <a:pPr>
-              <a:spcAft>
-                <a:spcPts val="1000"/>
-              </a:spcAft>
-            </a:pPr>
-            <a:r>
-              <a:rPr sz="1700">
-                <a:solidFill>
-                  <a:srgbClr val="0B1220"/>
-                </a:solidFill>
-                <a:latin typeface="Arial"/>
-              </a:rPr>
-              <a:t>•  Not adopted — fixed and tuned retraining (D-049, D-051): best 60-min gain +0.41 mg/dL (fixed), -0.37 [-0.63, -0.06] with tuning, below the declared 0.5 bar.</a:t>
-            </a:r>
-          </a:p>
-          <a:p>
-            <a:pPr>
-              <a:spcAft>
-                <a:spcPts val="1000"/>
-              </a:spcAft>
-            </a:pPr>
-            <a:r>
-              <a:rPr sz="1700">
-                <a:solidFill>
-                  <a:srgbClr val="0B1220"/>
-                </a:solidFill>
-                <a:latin typeface="Arial"/>
-              </a:rPr>
-              <a:t>•  Not adopted — joint selection (D-052, 1,570 fresh fits): -0.88 [-1.75, -0.13] mg/dL at 60 min vs the refitted serving recipe, but +1.70 on peaks above 180 and +0.60 false alarms/day — gates not met.</a:t>
-            </a:r>
-          </a:p>
-          <a:p>
-            <a:pPr>
-              <a:spcAft>
-                <a:spcPts val="1000"/>
-              </a:spcAft>
-            </a:pPr>
-            <a:r>
-              <a:rPr sz="1700">
-                <a:solidFill>
-                  <a:srgbClr val="0B1220"/>
-                </a:solidFill>
-                <a:latin typeface="Arial"/>
-              </a:rPr>
-              <a:t>•  The demo model's ranges are already pooled over all 14 people; its under-coverage most likely comes from drift between time segments, so this fix is not applied to it.</a:t>
+              <a:t>•  Thresholds chosen on development folds only (≤ 2 false alarms per observed day); each test fold opened once. The 14 people were inspected in earlier experiments, so this is internal validation.</a:t>
             </a:r>
           </a:p>
         </p:txBody>
@@ -5807,8 +6613,8 @@
         </p:nvSpPr>
         <p:spPr>
           <a:xfrm>
-            <a:off x="548640" y="320040"/>
-            <a:ext cx="11064240" cy="731520"/>
+            <a:off x="548640" y="128016"/>
+            <a:ext cx="11064240" cy="274320"/>
           </a:xfrm>
           <a:prstGeom prst="rect">
             <a:avLst/>
@@ -5822,20 +6628,54 @@
           <a:lstStyle/>
           <a:p>
             <a:r>
+              <a:rPr sz="1100" b="1">
+                <a:solidFill>
+                  <a:srgbClr val="2563EB"/>
+                </a:solidFill>
+                <a:latin typeface="Arial"/>
+              </a:rPr>
+              <a:t>RESEARCH · each participant held out entirely · internal validation · not the serving model</a:t>
+            </a:r>
+          </a:p>
+        </p:txBody>
+      </p:sp>
+      <p:sp>
+        <p:nvSpPr>
+          <p:cNvPr id="3" name="TextBox 2"/>
+          <p:cNvSpPr txBox="1"/>
+          <p:nvPr/>
+        </p:nvSpPr>
+        <p:spPr>
+          <a:xfrm>
+            <a:off x="548640" y="384048"/>
+            <a:ext cx="11064240" cy="640080"/>
+          </a:xfrm>
+          <a:prstGeom prst="rect">
+            <a:avLst/>
+          </a:prstGeom>
+          <a:noFill/>
+        </p:spPr>
+        <p:txBody>
+          <a:bodyPr wrap="square">
+            <a:spAutoFit/>
+          </a:bodyPr>
+          <a:lstStyle/>
+          <a:p>
+            <a:r>
               <a:rPr sz="3000" b="1">
                 <a:solidFill>
                   <a:srgbClr val="0B1220"/>
                 </a:solidFill>
                 <a:latin typeface="Arial"/>
               </a:rPr>
-              <a:t>Project outcomes</a:t>
+              <a:t>Research: what we fixed, and what we could not</a:t>
             </a:r>
           </a:p>
         </p:txBody>
       </p:sp>
       <p:cxnSp>
         <p:nvCxnSpPr>
-          <p:cNvPr id="3" name="Connector 2"/>
+          <p:cNvPr id="4" name="Connector 3"/>
           <p:cNvCxnSpPr/>
           <p:nvPr/>
         </p:nvCxnSpPr>
@@ -5856,7 +6696,7 @@
       </p:cxnSp>
       <p:sp>
         <p:nvSpPr>
-          <p:cNvPr id="4" name="TextBox 3"/>
+          <p:cNvPr id="5" name="TextBox 4"/>
           <p:cNvSpPr txBox="1"/>
           <p:nvPr/>
         </p:nvSpPr>
@@ -5890,7 +6730,7 @@
       </p:sp>
       <p:sp>
         <p:nvSpPr>
-          <p:cNvPr id="5" name="TextBox 4"/>
+          <p:cNvPr id="6" name="TextBox 5"/>
           <p:cNvSpPr txBox="1"/>
           <p:nvPr/>
         </p:nvSpPr>
@@ -5916,13 +6756,13 @@
               </a:spcAft>
             </a:pPr>
             <a:r>
-              <a:rPr sz="1700">
-                <a:solidFill>
-                  <a:srgbClr val="0B1220"/>
-                </a:solidFill>
-                <a:latin typeface="Arial"/>
-              </a:rPr>
-              <a:t>•  Built: a working personalized glucose twin — replay API with a backend-owned clock, immutable forecasts, research warnings with outcomes — and a clinician workspace (landing page, Overview, Participants, Replay sessions, Model evidence, Data quality).</a:t>
+              <a:rPr sz="1550">
+                <a:solidFill>
+                  <a:srgbClr val="0B1220"/>
+                </a:solidFill>
+                <a:latin typeface="Arial"/>
+              </a:rPr>
+              <a:t>•  We declared each study before its own run. Later studies reused previously inspected participants, so those results are internal validation.</a:t>
             </a:r>
           </a:p>
           <a:p>
@@ -5932,13 +6772,13 @@
               </a:spcAft>
             </a:pPr>
             <a:r>
-              <a:rPr sz="1700">
-                <a:solidFill>
-                  <a:srgbClr val="0B1220"/>
-                </a:solidFill>
-                <a:latin typeface="Arial"/>
-              </a:rPr>
-              <a:t>•  Found and corrected a data-provenance problem: the published 1-minute CGM values are interpolated; only native 5-minute readings are used.</a:t>
+              <a:rPr sz="1550">
+                <a:solidFill>
+                  <a:srgbClr val="0B1220"/>
+                </a:solidFill>
+                <a:latin typeface="Arial"/>
+              </a:rPr>
+              <a:t>•  Fixed — prediction ranges: calibrating on all development people instead of 2 per fold raised two-hour coverage from 76.5 % to 79.8 % (target 80 %; 60 min 78.2 → 79.5 %), ranges 7 mg/dL wider.</a:t>
             </a:r>
           </a:p>
           <a:p>
@@ -5948,13 +6788,13 @@
               </a:spcAft>
             </a:pPr>
             <a:r>
-              <a:rPr sz="1700">
-                <a:solidFill>
-                  <a:srgbClr val="0B1220"/>
-                </a:solidFill>
-                <a:latin typeface="Arial"/>
-              </a:rPr>
-              <a:t>•  Measured on later recordings of the same participants (retrospective): 14/14 participants improved over persistence at 30 min and 13/14 at 60 min; MAE 12.96 / 20.26 mg/dL vs 14.84 / 23.23.</a:t>
+              <a:rPr sz="1550">
+                <a:solidFill>
+                  <a:srgbClr val="0B1220"/>
+                </a:solidFill>
+                <a:latin typeface="Arial"/>
+              </a:rPr>
+              <a:t>•  Not shown — earlier warning: 126 vs 123 of 329 onsets warned ≥ 30 min ahead (+0.9 points [-5.5, +6.6]) at the same workload; median lead still 15 min.</a:t>
             </a:r>
           </a:p>
           <a:p>
@@ -5964,13 +6804,13 @@
               </a:spcAft>
             </a:pPr>
             <a:r>
-              <a:rPr sz="1700">
-                <a:solidFill>
-                  <a:srgbClr val="0B1220"/>
-                </a:solidFill>
-                <a:latin typeface="Arial"/>
-              </a:rPr>
-              <a:t>•  Personalization: small gains (-0.18 mg/dL and -0.33 mg/dL). Warnings: 61/64 onsets detected with 40 false alarms (1.49 per observed patient-day) — the F1 threshold rule ignores review workload.</a:t>
+              <a:rPr sz="1550">
+                <a:solidFill>
+                  <a:srgbClr val="0B1220"/>
+                </a:solidFill>
+                <a:latin typeface="Arial"/>
+              </a:rPr>
+              <a:t>•  Not shown — health record as a new person's starting correction: -0.53 [-1.57, +0.58] mg/dL at 120 min, -0.93 [-2.74, +0.48] in the first 24 hours; the intervals cross zero, so no benefit is claimed.</a:t>
             </a:r>
           </a:p>
           <a:p>
@@ -5980,13 +6820,13 @@
               </a:spcAft>
             </a:pPr>
             <a:r>
-              <a:rPr sz="1700">
-                <a:solidFill>
-                  <a:srgbClr val="0B1220"/>
-                </a:solidFill>
-                <a:latin typeface="Arial"/>
-              </a:rPr>
-              <a:t>•  Corrected after an independent review (activity-window defect, online warning double-credit; gt-primary-2026-10-11-v1 preserved), then re-run with the fusion constraint (gt-primary-2026-10-13-fusion); the dynamic-only model of gt-primary-2026-10-11-v2 stays registered for rollback.</a:t>
+              <a:rPr sz="1550">
+                <a:solidFill>
+                  <a:srgbClr val="0B1220"/>
+                </a:solidFill>
+                <a:latin typeface="Arial"/>
+              </a:rPr>
+              <a:t>•  Not adopted — a LightGBM–CatBoost blend (D-048): +0.02 mg/dL at 60 min on development people against a 0.5 target; held-out folds never opened.</a:t>
             </a:r>
           </a:p>
           <a:p>
@@ -5996,13 +6836,45 @@
               </a:spcAft>
             </a:pPr>
             <a:r>
-              <a:rPr sz="1700">
-                <a:solidFill>
-                  <a:srgbClr val="0B1220"/>
-                </a:solidFill>
-                <a:latin typeface="Arial"/>
-              </a:rPr>
-              <a:t>•  Reproducible: synthetic mode needs no download; recorded-data results regenerate from versioned configs; a fresh copy passes the automated backend, frontend and browser tests.</a:t>
+              <a:rPr sz="1550">
+                <a:solidFill>
+                  <a:srgbClr val="0B1220"/>
+                </a:solidFill>
+                <a:latin typeface="Arial"/>
+              </a:rPr>
+              <a:t>•  Not adopted — fixed and tuned retraining (D-049, D-051): best 60-min gain +0.41 mg/dL (fixed), -0.37 [-0.63, -0.06] with tuning, below the declared 0.5 bar.</a:t>
+            </a:r>
+          </a:p>
+          <a:p>
+            <a:pPr>
+              <a:spcAft>
+                <a:spcPts val="1000"/>
+              </a:spcAft>
+            </a:pPr>
+            <a:r>
+              <a:rPr sz="1550">
+                <a:solidFill>
+                  <a:srgbClr val="0B1220"/>
+                </a:solidFill>
+                <a:latin typeface="Arial"/>
+              </a:rPr>
+              <a:t>•  Not adopted — joint selection (D-052, 1,570 fresh fits): -0.88 [-1.75, -0.13] mg/dL at 60 min vs the refitted serving recipe, but +1.70 on peaks above 180 and +0.60 false alarms/day — gates not met.</a:t>
+            </a:r>
+          </a:p>
+          <a:p>
+            <a:pPr>
+              <a:spcAft>
+                <a:spcPts val="1000"/>
+              </a:spcAft>
+            </a:pPr>
+            <a:r>
+              <a:rPr sz="1550">
+                <a:solidFill>
+                  <a:srgbClr val="0B1220"/>
+                </a:solidFill>
+                <a:latin typeface="Arial"/>
+              </a:rPr>
+              <a:t>•  The demo model's ranges are already pooled over all 14 people; its under-coverage most likely comes from drift between time segments, so this fix is not applied to it.</a:t>
             </a:r>
           </a:p>
         </p:txBody>
@@ -6041,8 +6913,8 @@
         </p:nvSpPr>
         <p:spPr>
           <a:xfrm>
-            <a:off x="548640" y="320040"/>
-            <a:ext cx="11064240" cy="731520"/>
+            <a:off x="548640" y="128016"/>
+            <a:ext cx="11064240" cy="274320"/>
           </a:xfrm>
           <a:prstGeom prst="rect">
             <a:avLst/>
@@ -6056,20 +6928,54 @@
           <a:lstStyle/>
           <a:p>
             <a:r>
+              <a:rPr sz="1100" b="1">
+                <a:solidFill>
+                  <a:srgbClr val="2563EB"/>
+                </a:solidFill>
+                <a:latin typeface="Arial"/>
+              </a:rPr>
+              <a:t>RESEARCH · each participant held out entirely · internal validation · not the serving model</a:t>
+            </a:r>
+          </a:p>
+        </p:txBody>
+      </p:sp>
+      <p:sp>
+        <p:nvSpPr>
+          <p:cNvPr id="3" name="TextBox 2"/>
+          <p:cNvSpPr txBox="1"/>
+          <p:nvPr/>
+        </p:nvSpPr>
+        <p:spPr>
+          <a:xfrm>
+            <a:off x="548640" y="384048"/>
+            <a:ext cx="11064240" cy="640080"/>
+          </a:xfrm>
+          <a:prstGeom prst="rect">
+            <a:avLst/>
+          </a:prstGeom>
+          <a:noFill/>
+        </p:spPr>
+        <p:txBody>
+          <a:bodyPr wrap="square">
+            <a:spAutoFit/>
+          </a:bodyPr>
+          <a:lstStyle/>
+          <a:p>
+            <a:r>
               <a:rPr sz="3000" b="1">
                 <a:solidFill>
                   <a:srgbClr val="0B1220"/>
                 </a:solidFill>
                 <a:latin typeface="Arial"/>
               </a:rPr>
-              <a:t>Limitations</a:t>
+              <a:t>Research, 21–22 October: two declared studies</a:t>
             </a:r>
           </a:p>
         </p:txBody>
       </p:sp>
       <p:cxnSp>
         <p:nvCxnSpPr>
-          <p:cNvPr id="3" name="Connector 2"/>
+          <p:cNvPr id="4" name="Connector 3"/>
           <p:cNvCxnSpPr/>
           <p:nvPr/>
         </p:nvCxnSpPr>
@@ -6090,7 +6996,7 @@
       </p:cxnSp>
       <p:sp>
         <p:nvSpPr>
-          <p:cNvPr id="4" name="TextBox 3"/>
+          <p:cNvPr id="5" name="TextBox 4"/>
           <p:cNvSpPr txBox="1"/>
           <p:nvPr/>
         </p:nvSpPr>
@@ -6124,7 +7030,7 @@
       </p:sp>
       <p:sp>
         <p:nvSpPr>
-          <p:cNvPr id="5" name="TextBox 4"/>
+          <p:cNvPr id="6" name="TextBox 5"/>
           <p:cNvSpPr txBox="1"/>
           <p:nvPr/>
         </p:nvSpPr>
@@ -6156,7 +7062,7 @@
                 </a:solidFill>
                 <a:latin typeface="Arial"/>
               </a:rPr>
-              <a:t>•  14 participants from one US site; overlapping windows are not independent patients.</a:t>
+              <a:t>•  D-053 · gt-constrained-2026-10-21 — Constrained LightGBM fusion: peak-aware selection with the patient correction, each person held out once, against a freshly refitted serving recipe. Result and release-gate outcome: pending (inserted only from the locked, verified summary).</a:t>
             </a:r>
           </a:p>
           <a:p>
@@ -6172,7 +7078,7 @@
                 </a:solidFill>
                 <a:latin typeface="Arial"/>
               </a:rPr>
-              <a:t>•  No Indian participants — nothing here establishes performance for patients in India.</a:t>
+              <a:t>•  D-054 · gt-foundation-2026-10-21 — Zero-shot time-series foundation-model baseline on CGM only (a comparison, not a fusion model). Result and release-gate outcome: pending (inserted only from the locked, verified summary).</a:t>
             </a:r>
           </a:p>
           <a:p>
@@ -6188,7 +7094,7 @@
                 </a:solidFill>
                 <a:latin typeface="Arial"/>
               </a:rPr>
-              <a:t>•  Blinded research CGMs replayed with assumed zero latency; native timestamps known to the minute.</a:t>
+              <a:t>•  Both protocols were declared before their own runs. Later studies reused previously inspected participants, so their results are internal validation.</a:t>
             </a:r>
           </a:p>
           <a:p>
@@ -6204,71 +7110,7 @@
                 </a:solidFill>
                 <a:latin typeface="Arial"/>
               </a:rPr>
-              <a:t>•  Medication and insulin use unknown; meal logging time undocumented.</a:t>
-            </a:r>
-          </a:p>
-          <a:p>
-            <a:pPr>
-              <a:spcAft>
-                <a:spcPts val="1000"/>
-              </a:spcAft>
-            </a:pPr>
-            <a:r>
-              <a:rPr sz="1700">
-                <a:solidFill>
-                  <a:srgbClr val="0B1220"/>
-                </a:solidFill>
-                <a:latin typeface="Arial"/>
-              </a:rPr>
-              <a:t>•  Profile fusion: profile values are constant per person, so with 14 people they can act as an identity code; no benefit was shown on people held out entirely.</a:t>
-            </a:r>
-          </a:p>
-          <a:p>
-            <a:pPr>
-              <a:spcAft>
-                <a:spcPts val="1000"/>
-              </a:spcAft>
-            </a:pPr>
-            <a:r>
-              <a:rPr sz="1700">
-                <a:solidFill>
-                  <a:srgbClr val="0B1220"/>
-                </a:solidFill>
-                <a:latin typeface="Arial"/>
-              </a:rPr>
-              <a:t>•  Prediction ranges under-cover; the warning score is uncalibrated and its threshold rule (F1) ignores review workload; 180 mg/dL is a research threshold, not triage.</a:t>
-            </a:r>
-          </a:p>
-          <a:p>
-            <a:pPr>
-              <a:spcAft>
-                <a:spcPts val="1000"/>
-              </a:spcAft>
-            </a:pPr>
-            <a:r>
-              <a:rPr sz="1700">
-                <a:solidFill>
-                  <a:srgbClr val="0B1220"/>
-                </a:solidFill>
-                <a:latin typeface="Arial"/>
-              </a:rPr>
-              <a:t>•  Retrospective replay only: no clinician workflow, outcome or safety study. Optional Chronos-Bolt not run.</a:t>
-            </a:r>
-          </a:p>
-          <a:p>
-            <a:pPr>
-              <a:spcAft>
-                <a:spcPts val="1000"/>
-              </a:spcAft>
-            </a:pPr>
-            <a:r>
-              <a:rPr sz="1700">
-                <a:solidFill>
-                  <a:srgbClr val="0B1220"/>
-                </a:solidFill>
-                <a:latin typeface="Arial"/>
-              </a:rPr>
-              <a:t>•  Scores depend on the dataset, prediction task and evaluation protocol; performance on simulated patients does not establish performance on real patients.</a:t>
+              <a:t>•  Nothing from these studies reaches the app unless every declared release gate passes and the candidate passes serving parity and integration checks; otherwise the serving model is unchanged.</a:t>
             </a:r>
           </a:p>
         </p:txBody>
@@ -6307,8 +7149,8 @@
         </p:nvSpPr>
         <p:spPr>
           <a:xfrm>
-            <a:off x="548640" y="320040"/>
-            <a:ext cx="11064240" cy="731520"/>
+            <a:off x="548640" y="128016"/>
+            <a:ext cx="11064240" cy="274320"/>
           </a:xfrm>
           <a:prstGeom prst="rect">
             <a:avLst/>
@@ -6322,20 +7164,54 @@
           <a:lstStyle/>
           <a:p>
             <a:r>
+              <a:rPr sz="1100" b="1">
+                <a:solidFill>
+                  <a:srgbClr val="2563EB"/>
+                </a:solidFill>
+                <a:latin typeface="Arial"/>
+              </a:rPr>
+              <a:t>RESEARCH · external cohort, CGM only · not the serving fusion model</a:t>
+            </a:r>
+          </a:p>
+        </p:txBody>
+      </p:sp>
+      <p:sp>
+        <p:nvSpPr>
+          <p:cNvPr id="3" name="TextBox 2"/>
+          <p:cNvSpPr txBox="1"/>
+          <p:nvPr/>
+        </p:nvSpPr>
+        <p:spPr>
+          <a:xfrm>
+            <a:off x="548640" y="384048"/>
+            <a:ext cx="11064240" cy="640080"/>
+          </a:xfrm>
+          <a:prstGeom prst="rect">
+            <a:avLst/>
+          </a:prstGeom>
+          <a:noFill/>
+        </p:spPr>
+        <p:txBody>
+          <a:bodyPr wrap="square">
+            <a:spAutoFit/>
+          </a:bodyPr>
+          <a:lstStyle/>
+          <a:p>
+            <a:r>
               <a:rPr sz="3000" b="1">
                 <a:solidFill>
                   <a:srgbClr val="0B1220"/>
                 </a:solidFill>
                 <a:latin typeface="Arial"/>
               </a:rPr>
-              <a:t>Next steps: evidence needed for Indian patients</a:t>
+              <a:t>External check: an independent Type 2 cohort</a:t>
             </a:r>
           </a:p>
         </p:txBody>
       </p:sp>
       <p:cxnSp>
         <p:nvCxnSpPr>
-          <p:cNvPr id="3" name="Connector 2"/>
+          <p:cNvPr id="4" name="Connector 3"/>
           <p:cNvCxnSpPr/>
           <p:nvPr/>
         </p:nvCxnSpPr>
@@ -6356,7 +7232,7 @@
       </p:cxnSp>
       <p:sp>
         <p:nvSpPr>
-          <p:cNvPr id="4" name="TextBox 3"/>
+          <p:cNvPr id="5" name="TextBox 4"/>
           <p:cNvSpPr txBox="1"/>
           <p:nvPr/>
         </p:nvSpPr>
@@ -6390,7 +7266,7 @@
       </p:sp>
       <p:sp>
         <p:nvSpPr>
-          <p:cNvPr id="5" name="TextBox 4"/>
+          <p:cNvPr id="6" name="TextBox 5"/>
           <p:cNvSpPr txBox="1"/>
           <p:nvPr/>
         </p:nvSpPr>
@@ -6422,7 +7298,7 @@
                 </a:solidFill>
                 <a:latin typeface="Arial"/>
               </a:rPr>
-              <a:t>•  Prospective, consented Indian cohort with unblinded CGMs, recorded transmission latency, medications and meal logging times.</a:t>
+              <a:t>•  Who: 98 adults with Type 2 diabetes in ShanghaiT2DM (China, FreeStyle Libre H, 15-minute readings), never trained on. No wearable or dated labs, so this checks the forecasting core only, not the fusion.</a:t>
             </a:r>
           </a:p>
           <a:p>
@@ -6438,7 +7314,7 @@
                 </a:solidFill>
                 <a:latin typeface="Arial"/>
               </a:rPr>
-              <a:t>•  Re-evaluate held-out participants (cold start) and per-site calibration; report subgroup performance.</a:t>
+              <a:t>•  What: a separate 15-minute LightGBM on CGM-only features, developed on CGMacros. It is not the serving fusion model and not the Ridge candidate.</a:t>
             </a:r>
           </a:p>
           <a:p>
@@ -6454,7 +7330,7 @@
                 </a:solidFill>
                 <a:latin typeface="Arial"/>
               </a:rPr>
-              <a:t>•  AI-READI five-minute CGM and wearable data (access not yet requested; steps listed) for a larger new-person evaluation under the declared protocol gt-nested-2026-10-12-v2.</a:t>
+              <a:t>•  30 / 60 minutes (D-032, opened once): -0.99 [-1.21, -0.77] mg/dL at 30 min (clear) and -0.34 [-0.76, +0.10] mg/dL at 60 min (inconclusive), versus carrying the last reading forward.</a:t>
             </a:r>
           </a:p>
           <a:p>
@@ -6470,7 +7346,7 @@
                 </a:solidFill>
                 <a:latin typeface="Arial"/>
               </a:rPr>
-              <a:t>•  Clinician usability study of the review workflow; regulatory and data-protection review (DPDP Act).</a:t>
+              <a:t>•  Two hours ahead (D-045, declared before any fit, assessed once): 29.6 vs persistence 31.7 mg/dL at 120 min (-2.12 [-2.67, -1.53]), better for 78 of 98 people.</a:t>
             </a:r>
           </a:p>
           <a:p>
@@ -6486,7 +7362,7 @@
                 </a:solidFill>
                 <a:latin typeface="Arial"/>
               </a:rPr>
-              <a:t>•  Optional: compare a fine-tuned time-series foundation model (e.g. Chronos-Bolt) under the same protocol.</a:t>
+              <a:t>•  Nothing was chosen on this cohort; other frozen pipelines were reported but not adopted, because choosing on it would turn it into a tuning set.</a:t>
             </a:r>
           </a:p>
         </p:txBody>
@@ -6526,7 +7402,7 @@
         <p:spPr>
           <a:xfrm>
             <a:off x="548640" y="320040"/>
-            <a:ext cx="11064240" cy="731520"/>
+            <a:ext cx="11064240" cy="640080"/>
           </a:xfrm>
           <a:prstGeom prst="rect">
             <a:avLst/>
@@ -6546,7 +7422,7 @@
                 </a:solidFill>
                 <a:latin typeface="Arial"/>
               </a:rPr>
-              <a:t>Team, links, reproducibility and licenses</a:t>
+              <a:t>Project outcomes</a:t>
             </a:r>
           </a:p>
         </p:txBody>
@@ -6602,6 +7478,724 @@
                 <a:latin typeface="Arial"/>
               </a:rPr>
               <a:t>24</a:t>
+            </a:r>
+          </a:p>
+        </p:txBody>
+      </p:sp>
+      <p:sp>
+        <p:nvSpPr>
+          <p:cNvPr id="5" name="TextBox 4"/>
+          <p:cNvSpPr txBox="1"/>
+          <p:nvPr/>
+        </p:nvSpPr>
+        <p:spPr>
+          <a:xfrm>
+            <a:off x="548640" y="1234440"/>
+            <a:ext cx="11064240" cy="5120640"/>
+          </a:xfrm>
+          <a:prstGeom prst="rect">
+            <a:avLst/>
+          </a:prstGeom>
+          <a:noFill/>
+        </p:spPr>
+        <p:txBody>
+          <a:bodyPr wrap="square">
+            <a:spAutoFit/>
+          </a:bodyPr>
+          <a:lstStyle/>
+          <a:p>
+            <a:pPr>
+              <a:spcAft>
+                <a:spcPts val="1000"/>
+              </a:spcAft>
+            </a:pPr>
+            <a:r>
+              <a:rPr sz="1700">
+                <a:solidFill>
+                  <a:srgbClr val="0B1220"/>
+                </a:solidFill>
+                <a:latin typeface="Arial"/>
+              </a:rPr>
+              <a:t>•  Built: a working personalized glucose twin — replay API with a backend-owned clock, immutable forecasts, research warnings with outcomes — and a clinician workspace (landing page, Overview, Participants, Replay sessions, Model evidence, Data quality).</a:t>
+            </a:r>
+          </a:p>
+          <a:p>
+            <a:pPr>
+              <a:spcAft>
+                <a:spcPts val="1000"/>
+              </a:spcAft>
+            </a:pPr>
+            <a:r>
+              <a:rPr sz="1700">
+                <a:solidFill>
+                  <a:srgbClr val="0B1220"/>
+                </a:solidFill>
+                <a:latin typeface="Arial"/>
+              </a:rPr>
+              <a:t>•  Found and corrected a data-provenance problem: the published 1-minute CGM values are interpolated; only native 5-minute readings are used.</a:t>
+            </a:r>
+          </a:p>
+          <a:p>
+            <a:pPr>
+              <a:spcAft>
+                <a:spcPts val="1000"/>
+              </a:spcAft>
+            </a:pPr>
+            <a:r>
+              <a:rPr sz="1700">
+                <a:solidFill>
+                  <a:srgbClr val="0B1220"/>
+                </a:solidFill>
+                <a:latin typeface="Arial"/>
+              </a:rPr>
+              <a:t>•  Measured on later recordings of the same participants (retrospective): 14/14 participants improved over persistence at 30 min and 13/14 at 60 min; MAE 12.96 / 20.26 mg/dL vs 14.84 / 23.23.</a:t>
+            </a:r>
+          </a:p>
+          <a:p>
+            <a:pPr>
+              <a:spcAft>
+                <a:spcPts val="1000"/>
+              </a:spcAft>
+            </a:pPr>
+            <a:r>
+              <a:rPr sz="1700">
+                <a:solidFill>
+                  <a:srgbClr val="0B1220"/>
+                </a:solidFill>
+                <a:latin typeface="Arial"/>
+              </a:rPr>
+              <a:t>•  Personalization: small gains (-0.18 mg/dL and -0.33 mg/dL). Warnings: 61/64 onsets detected with 40 false alarms (1.49 per observed patient-day) — the F1 threshold rule ignores review workload.</a:t>
+            </a:r>
+          </a:p>
+          <a:p>
+            <a:pPr>
+              <a:spcAft>
+                <a:spcPts val="1000"/>
+              </a:spcAft>
+            </a:pPr>
+            <a:r>
+              <a:rPr sz="1700">
+                <a:solidFill>
+                  <a:srgbClr val="0B1220"/>
+                </a:solidFill>
+                <a:latin typeface="Arial"/>
+              </a:rPr>
+              <a:t>•  Corrected after an independent review (activity-window defect, online warning double-credit; gt-primary-2026-10-11-v1 preserved), then re-run with the fusion constraint (gt-primary-2026-10-13-fusion); the dynamic-only model of gt-primary-2026-10-11-v2 stays registered for rollback.</a:t>
+            </a:r>
+          </a:p>
+          <a:p>
+            <a:pPr>
+              <a:spcAft>
+                <a:spcPts val="1000"/>
+              </a:spcAft>
+            </a:pPr>
+            <a:r>
+              <a:rPr sz="1700">
+                <a:solidFill>
+                  <a:srgbClr val="0B1220"/>
+                </a:solidFill>
+                <a:latin typeface="Arial"/>
+              </a:rPr>
+              <a:t>•  Reproducible: synthetic mode needs no download; recorded-data results regenerate from versioned configs; a fresh copy passes the automated backend, frontend and browser tests.</a:t>
+            </a:r>
+          </a:p>
+        </p:txBody>
+      </p:sp>
+    </p:spTree>
+  </p:cSld>
+  <p:clrMapOvr>
+    <a:masterClrMapping/>
+  </p:clrMapOvr>
+</p:sld>
+</file>
+
+<file path=ppt/slides/slide25.xml><?xml version="1.0" encoding="utf-8"?>
+<p:sld xmlns:a="http://schemas.openxmlformats.org/drawingml/2006/main" xmlns:p="http://schemas.openxmlformats.org/presentationml/2006/main" xmlns:r="http://schemas.openxmlformats.org/officeDocument/2006/relationships">
+  <p:cSld>
+    <p:bg>
+      <p:bgPr>
+        <a:solidFill>
+          <a:srgbClr val="FFFFFF"/>
+        </a:solidFill>
+        <a:effectLst/>
+      </p:bgPr>
+    </p:bg>
+    <p:spTree>
+      <p:nvGrpSpPr>
+        <p:cNvPr id="1" name=""/>
+        <p:cNvGrpSpPr/>
+        <p:nvPr/>
+      </p:nvGrpSpPr>
+      <p:grpSpPr/>
+      <p:sp>
+        <p:nvSpPr>
+          <p:cNvPr id="2" name="TextBox 1"/>
+          <p:cNvSpPr txBox="1"/>
+          <p:nvPr/>
+        </p:nvSpPr>
+        <p:spPr>
+          <a:xfrm>
+            <a:off x="548640" y="320040"/>
+            <a:ext cx="11064240" cy="640080"/>
+          </a:xfrm>
+          <a:prstGeom prst="rect">
+            <a:avLst/>
+          </a:prstGeom>
+          <a:noFill/>
+        </p:spPr>
+        <p:txBody>
+          <a:bodyPr wrap="square">
+            <a:spAutoFit/>
+          </a:bodyPr>
+          <a:lstStyle/>
+          <a:p>
+            <a:r>
+              <a:rPr sz="3000" b="1">
+                <a:solidFill>
+                  <a:srgbClr val="0B1220"/>
+                </a:solidFill>
+                <a:latin typeface="Arial"/>
+              </a:rPr>
+              <a:t>Limitations</a:t>
+            </a:r>
+          </a:p>
+        </p:txBody>
+      </p:sp>
+      <p:cxnSp>
+        <p:nvCxnSpPr>
+          <p:cNvPr id="3" name="Connector 2"/>
+          <p:cNvCxnSpPr/>
+          <p:nvPr/>
+        </p:nvCxnSpPr>
+        <p:spPr>
+          <a:xfrm>
+            <a:off x="548640" y="987552"/>
+            <a:ext cx="11091672" cy="0"/>
+          </a:xfrm>
+          <a:prstGeom prst="line">
+            <a:avLst/>
+          </a:prstGeom>
+          <a:ln w="9525">
+            <a:solidFill>
+              <a:srgbClr val="E3E8EF"/>
+            </a:solidFill>
+          </a:ln>
+        </p:spPr>
+      </p:cxnSp>
+      <p:sp>
+        <p:nvSpPr>
+          <p:cNvPr id="4" name="TextBox 3"/>
+          <p:cNvSpPr txBox="1"/>
+          <p:nvPr/>
+        </p:nvSpPr>
+        <p:spPr>
+          <a:xfrm>
+            <a:off x="11247120" y="6446520"/>
+            <a:ext cx="457200" cy="274320"/>
+          </a:xfrm>
+          <a:prstGeom prst="rect">
+            <a:avLst/>
+          </a:prstGeom>
+          <a:noFill/>
+        </p:spPr>
+        <p:txBody>
+          <a:bodyPr wrap="square">
+            <a:spAutoFit/>
+          </a:bodyPr>
+          <a:lstStyle/>
+          <a:p>
+            <a:r>
+              <a:rPr sz="1100" b="0">
+                <a:solidFill>
+                  <a:srgbClr val="0B1220"/>
+                </a:solidFill>
+                <a:latin typeface="Arial"/>
+              </a:rPr>
+              <a:t>25</a:t>
+            </a:r>
+          </a:p>
+        </p:txBody>
+      </p:sp>
+      <p:sp>
+        <p:nvSpPr>
+          <p:cNvPr id="5" name="TextBox 4"/>
+          <p:cNvSpPr txBox="1"/>
+          <p:nvPr/>
+        </p:nvSpPr>
+        <p:spPr>
+          <a:xfrm>
+            <a:off x="548640" y="1234440"/>
+            <a:ext cx="11064240" cy="5120640"/>
+          </a:xfrm>
+          <a:prstGeom prst="rect">
+            <a:avLst/>
+          </a:prstGeom>
+          <a:noFill/>
+        </p:spPr>
+        <p:txBody>
+          <a:bodyPr wrap="square">
+            <a:spAutoFit/>
+          </a:bodyPr>
+          <a:lstStyle/>
+          <a:p>
+            <a:pPr>
+              <a:spcAft>
+                <a:spcPts val="1000"/>
+              </a:spcAft>
+            </a:pPr>
+            <a:r>
+              <a:rPr sz="1550">
+                <a:solidFill>
+                  <a:srgbClr val="0B1220"/>
+                </a:solidFill>
+                <a:latin typeface="Arial"/>
+              </a:rPr>
+              <a:t>•  14 participants from one US site; overlapping windows are not independent patients.</a:t>
+            </a:r>
+          </a:p>
+          <a:p>
+            <a:pPr>
+              <a:spcAft>
+                <a:spcPts val="1000"/>
+              </a:spcAft>
+            </a:pPr>
+            <a:r>
+              <a:rPr sz="1550">
+                <a:solidFill>
+                  <a:srgbClr val="0B1220"/>
+                </a:solidFill>
+                <a:latin typeface="Arial"/>
+              </a:rPr>
+              <a:t>•  No Indian participants — nothing here establishes performance for patients in India.</a:t>
+            </a:r>
+          </a:p>
+          <a:p>
+            <a:pPr>
+              <a:spcAft>
+                <a:spcPts val="1000"/>
+              </a:spcAft>
+            </a:pPr>
+            <a:r>
+              <a:rPr sz="1550">
+                <a:solidFill>
+                  <a:srgbClr val="0B1220"/>
+                </a:solidFill>
+                <a:latin typeface="Arial"/>
+              </a:rPr>
+              <a:t>•  Blinded research CGMs replayed with assumed zero latency; native timestamps known to the minute.</a:t>
+            </a:r>
+          </a:p>
+          <a:p>
+            <a:pPr>
+              <a:spcAft>
+                <a:spcPts val="1000"/>
+              </a:spcAft>
+            </a:pPr>
+            <a:r>
+              <a:rPr sz="1550">
+                <a:solidFill>
+                  <a:srgbClr val="0B1220"/>
+                </a:solidFill>
+                <a:latin typeface="Arial"/>
+              </a:rPr>
+              <a:t>•  Medication and insulin use unknown; meal logging time undocumented.</a:t>
+            </a:r>
+          </a:p>
+          <a:p>
+            <a:pPr>
+              <a:spcAft>
+                <a:spcPts val="1000"/>
+              </a:spcAft>
+            </a:pPr>
+            <a:r>
+              <a:rPr sz="1550">
+                <a:solidFill>
+                  <a:srgbClr val="0B1220"/>
+                </a:solidFill>
+                <a:latin typeface="Arial"/>
+              </a:rPr>
+              <a:t>•  Profile fusion: profile values are constant per person, so with 14 people they can act as an identity code; no benefit was shown on people held out entirely.</a:t>
+            </a:r>
+          </a:p>
+          <a:p>
+            <a:pPr>
+              <a:spcAft>
+                <a:spcPts val="1000"/>
+              </a:spcAft>
+            </a:pPr>
+            <a:r>
+              <a:rPr sz="1550">
+                <a:solidFill>
+                  <a:srgbClr val="0B1220"/>
+                </a:solidFill>
+                <a:latin typeface="Arial"/>
+              </a:rPr>
+              <a:t>•  Prediction ranges under-cover; the warning score is uncalibrated and its threshold rule (F1) ignores review workload; 180 mg/dL is a research threshold, not triage.</a:t>
+            </a:r>
+          </a:p>
+          <a:p>
+            <a:pPr>
+              <a:spcAft>
+                <a:spcPts val="1000"/>
+              </a:spcAft>
+            </a:pPr>
+            <a:r>
+              <a:rPr sz="1550">
+                <a:solidFill>
+                  <a:srgbClr val="0B1220"/>
+                </a:solidFill>
+                <a:latin typeface="Arial"/>
+              </a:rPr>
+              <a:t>•  Retrospective replay only: no clinician workflow, outcome or safety study. Foundation-model baseline (D-054): result pending.</a:t>
+            </a:r>
+          </a:p>
+          <a:p>
+            <a:pPr>
+              <a:spcAft>
+                <a:spcPts val="1000"/>
+              </a:spcAft>
+            </a:pPr>
+            <a:r>
+              <a:rPr sz="1550">
+                <a:solidFill>
+                  <a:srgbClr val="0B1220"/>
+                </a:solidFill>
+                <a:latin typeface="Arial"/>
+              </a:rPr>
+              <a:t>•  Scores depend on the dataset, prediction task and evaluation protocol; performance on simulated patients does not establish performance on real patients.</a:t>
+            </a:r>
+          </a:p>
+        </p:txBody>
+      </p:sp>
+    </p:spTree>
+  </p:cSld>
+  <p:clrMapOvr>
+    <a:masterClrMapping/>
+  </p:clrMapOvr>
+</p:sld>
+</file>
+
+<file path=ppt/slides/slide26.xml><?xml version="1.0" encoding="utf-8"?>
+<p:sld xmlns:a="http://schemas.openxmlformats.org/drawingml/2006/main" xmlns:p="http://schemas.openxmlformats.org/presentationml/2006/main" xmlns:r="http://schemas.openxmlformats.org/officeDocument/2006/relationships">
+  <p:cSld>
+    <p:bg>
+      <p:bgPr>
+        <a:solidFill>
+          <a:srgbClr val="FFFFFF"/>
+        </a:solidFill>
+        <a:effectLst/>
+      </p:bgPr>
+    </p:bg>
+    <p:spTree>
+      <p:nvGrpSpPr>
+        <p:cNvPr id="1" name=""/>
+        <p:cNvGrpSpPr/>
+        <p:nvPr/>
+      </p:nvGrpSpPr>
+      <p:grpSpPr/>
+      <p:sp>
+        <p:nvSpPr>
+          <p:cNvPr id="2" name="TextBox 1"/>
+          <p:cNvSpPr txBox="1"/>
+          <p:nvPr/>
+        </p:nvSpPr>
+        <p:spPr>
+          <a:xfrm>
+            <a:off x="548640" y="320040"/>
+            <a:ext cx="11064240" cy="640080"/>
+          </a:xfrm>
+          <a:prstGeom prst="rect">
+            <a:avLst/>
+          </a:prstGeom>
+          <a:noFill/>
+        </p:spPr>
+        <p:txBody>
+          <a:bodyPr wrap="square">
+            <a:spAutoFit/>
+          </a:bodyPr>
+          <a:lstStyle/>
+          <a:p>
+            <a:r>
+              <a:rPr sz="3000" b="1">
+                <a:solidFill>
+                  <a:srgbClr val="0B1220"/>
+                </a:solidFill>
+                <a:latin typeface="Arial"/>
+              </a:rPr>
+              <a:t>Next steps: evidence needed for Indian patients</a:t>
+            </a:r>
+          </a:p>
+        </p:txBody>
+      </p:sp>
+      <p:cxnSp>
+        <p:nvCxnSpPr>
+          <p:cNvPr id="3" name="Connector 2"/>
+          <p:cNvCxnSpPr/>
+          <p:nvPr/>
+        </p:nvCxnSpPr>
+        <p:spPr>
+          <a:xfrm>
+            <a:off x="548640" y="987552"/>
+            <a:ext cx="11091672" cy="0"/>
+          </a:xfrm>
+          <a:prstGeom prst="line">
+            <a:avLst/>
+          </a:prstGeom>
+          <a:ln w="9525">
+            <a:solidFill>
+              <a:srgbClr val="E3E8EF"/>
+            </a:solidFill>
+          </a:ln>
+        </p:spPr>
+      </p:cxnSp>
+      <p:sp>
+        <p:nvSpPr>
+          <p:cNvPr id="4" name="TextBox 3"/>
+          <p:cNvSpPr txBox="1"/>
+          <p:nvPr/>
+        </p:nvSpPr>
+        <p:spPr>
+          <a:xfrm>
+            <a:off x="11247120" y="6446520"/>
+            <a:ext cx="457200" cy="274320"/>
+          </a:xfrm>
+          <a:prstGeom prst="rect">
+            <a:avLst/>
+          </a:prstGeom>
+          <a:noFill/>
+        </p:spPr>
+        <p:txBody>
+          <a:bodyPr wrap="square">
+            <a:spAutoFit/>
+          </a:bodyPr>
+          <a:lstStyle/>
+          <a:p>
+            <a:r>
+              <a:rPr sz="1100" b="0">
+                <a:solidFill>
+                  <a:srgbClr val="0B1220"/>
+                </a:solidFill>
+                <a:latin typeface="Arial"/>
+              </a:rPr>
+              <a:t>26</a:t>
+            </a:r>
+          </a:p>
+        </p:txBody>
+      </p:sp>
+      <p:sp>
+        <p:nvSpPr>
+          <p:cNvPr id="5" name="TextBox 4"/>
+          <p:cNvSpPr txBox="1"/>
+          <p:nvPr/>
+        </p:nvSpPr>
+        <p:spPr>
+          <a:xfrm>
+            <a:off x="548640" y="1234440"/>
+            <a:ext cx="11064240" cy="5120640"/>
+          </a:xfrm>
+          <a:prstGeom prst="rect">
+            <a:avLst/>
+          </a:prstGeom>
+          <a:noFill/>
+        </p:spPr>
+        <p:txBody>
+          <a:bodyPr wrap="square">
+            <a:spAutoFit/>
+          </a:bodyPr>
+          <a:lstStyle/>
+          <a:p>
+            <a:pPr>
+              <a:spcAft>
+                <a:spcPts val="1000"/>
+              </a:spcAft>
+            </a:pPr>
+            <a:r>
+              <a:rPr sz="1700">
+                <a:solidFill>
+                  <a:srgbClr val="0B1220"/>
+                </a:solidFill>
+                <a:latin typeface="Arial"/>
+              </a:rPr>
+              <a:t>•  Prospective, consented Indian cohort with unblinded CGMs, recorded transmission latency, medications and meal logging times.</a:t>
+            </a:r>
+          </a:p>
+          <a:p>
+            <a:pPr>
+              <a:spcAft>
+                <a:spcPts val="1000"/>
+              </a:spcAft>
+            </a:pPr>
+            <a:r>
+              <a:rPr sz="1700">
+                <a:solidFill>
+                  <a:srgbClr val="0B1220"/>
+                </a:solidFill>
+                <a:latin typeface="Arial"/>
+              </a:rPr>
+              <a:t>•  Re-evaluate held-out participants (cold start) and per-site calibration; report subgroup performance.</a:t>
+            </a:r>
+          </a:p>
+          <a:p>
+            <a:pPr>
+              <a:spcAft>
+                <a:spcPts val="1000"/>
+              </a:spcAft>
+            </a:pPr>
+            <a:r>
+              <a:rPr sz="1700">
+                <a:solidFill>
+                  <a:srgbClr val="0B1220"/>
+                </a:solidFill>
+                <a:latin typeface="Arial"/>
+              </a:rPr>
+              <a:t>•  AI-READI five-minute CGM and wearable data (access not yet requested; steps listed) for a larger new-person evaluation under the declared protocol gt-nested-2026-10-12-v2.</a:t>
+            </a:r>
+          </a:p>
+          <a:p>
+            <a:pPr>
+              <a:spcAft>
+                <a:spcPts val="1000"/>
+              </a:spcAft>
+            </a:pPr>
+            <a:r>
+              <a:rPr sz="1700">
+                <a:solidFill>
+                  <a:srgbClr val="0B1220"/>
+                </a:solidFill>
+                <a:latin typeface="Arial"/>
+              </a:rPr>
+              <a:t>•  Clinician usability study of the review workflow; regulatory and data-protection review (DPDP Act).</a:t>
+            </a:r>
+          </a:p>
+          <a:p>
+            <a:pPr>
+              <a:spcAft>
+                <a:spcPts val="1000"/>
+              </a:spcAft>
+            </a:pPr>
+            <a:r>
+              <a:rPr sz="1700">
+                <a:solidFill>
+                  <a:srgbClr val="0B1220"/>
+                </a:solidFill>
+                <a:latin typeface="Arial"/>
+              </a:rPr>
+              <a:t>•  Optional: compare a fine-tuned time-series foundation model (e.g. Chronos-Bolt) under the same protocol.</a:t>
+            </a:r>
+          </a:p>
+        </p:txBody>
+      </p:sp>
+    </p:spTree>
+  </p:cSld>
+  <p:clrMapOvr>
+    <a:masterClrMapping/>
+  </p:clrMapOvr>
+</p:sld>
+</file>
+
+<file path=ppt/slides/slide27.xml><?xml version="1.0" encoding="utf-8"?>
+<p:sld xmlns:a="http://schemas.openxmlformats.org/drawingml/2006/main" xmlns:p="http://schemas.openxmlformats.org/presentationml/2006/main" xmlns:r="http://schemas.openxmlformats.org/officeDocument/2006/relationships">
+  <p:cSld>
+    <p:bg>
+      <p:bgPr>
+        <a:solidFill>
+          <a:srgbClr val="FFFFFF"/>
+        </a:solidFill>
+        <a:effectLst/>
+      </p:bgPr>
+    </p:bg>
+    <p:spTree>
+      <p:nvGrpSpPr>
+        <p:cNvPr id="1" name=""/>
+        <p:cNvGrpSpPr/>
+        <p:nvPr/>
+      </p:nvGrpSpPr>
+      <p:grpSpPr/>
+      <p:sp>
+        <p:nvSpPr>
+          <p:cNvPr id="2" name="TextBox 1"/>
+          <p:cNvSpPr txBox="1"/>
+          <p:nvPr/>
+        </p:nvSpPr>
+        <p:spPr>
+          <a:xfrm>
+            <a:off x="548640" y="320040"/>
+            <a:ext cx="11064240" cy="640080"/>
+          </a:xfrm>
+          <a:prstGeom prst="rect">
+            <a:avLst/>
+          </a:prstGeom>
+          <a:noFill/>
+        </p:spPr>
+        <p:txBody>
+          <a:bodyPr wrap="square">
+            <a:spAutoFit/>
+          </a:bodyPr>
+          <a:lstStyle/>
+          <a:p>
+            <a:r>
+              <a:rPr sz="3000" b="1">
+                <a:solidFill>
+                  <a:srgbClr val="0B1220"/>
+                </a:solidFill>
+                <a:latin typeface="Arial"/>
+              </a:rPr>
+              <a:t>Team, links, reproducibility and licenses</a:t>
+            </a:r>
+          </a:p>
+        </p:txBody>
+      </p:sp>
+      <p:cxnSp>
+        <p:nvCxnSpPr>
+          <p:cNvPr id="3" name="Connector 2"/>
+          <p:cNvCxnSpPr/>
+          <p:nvPr/>
+        </p:nvCxnSpPr>
+        <p:spPr>
+          <a:xfrm>
+            <a:off x="548640" y="987552"/>
+            <a:ext cx="11091672" cy="0"/>
+          </a:xfrm>
+          <a:prstGeom prst="line">
+            <a:avLst/>
+          </a:prstGeom>
+          <a:ln w="9525">
+            <a:solidFill>
+              <a:srgbClr val="E3E8EF"/>
+            </a:solidFill>
+          </a:ln>
+        </p:spPr>
+      </p:cxnSp>
+      <p:sp>
+        <p:nvSpPr>
+          <p:cNvPr id="4" name="TextBox 3"/>
+          <p:cNvSpPr txBox="1"/>
+          <p:nvPr/>
+        </p:nvSpPr>
+        <p:spPr>
+          <a:xfrm>
+            <a:off x="11247120" y="6446520"/>
+            <a:ext cx="457200" cy="274320"/>
+          </a:xfrm>
+          <a:prstGeom prst="rect">
+            <a:avLst/>
+          </a:prstGeom>
+          <a:noFill/>
+        </p:spPr>
+        <p:txBody>
+          <a:bodyPr wrap="square">
+            <a:spAutoFit/>
+          </a:bodyPr>
+          <a:lstStyle/>
+          <a:p>
+            <a:r>
+              <a:rPr sz="1100" b="0">
+                <a:solidFill>
+                  <a:srgbClr val="0B1220"/>
+                </a:solidFill>
+                <a:latin typeface="Arial"/>
+              </a:rPr>
+              <a:t>27</a:t>
             </a:r>
           </a:p>
         </p:txBody>
@@ -6744,7 +8338,7 @@
         <p:spPr>
           <a:xfrm>
             <a:off x="548640" y="320040"/>
-            <a:ext cx="11064240" cy="731520"/>
+            <a:ext cx="11064240" cy="640080"/>
           </a:xfrm>
           <a:prstGeom prst="rect">
             <a:avLst/>
@@ -6978,7 +8572,7 @@
         <p:spPr>
           <a:xfrm>
             <a:off x="548640" y="320040"/>
-            <a:ext cx="11064240" cy="731520"/>
+            <a:ext cx="11064240" cy="640080"/>
           </a:xfrm>
           <a:prstGeom prst="rect">
             <a:avLst/>
@@ -7204,7 +8798,7 @@
         <p:spPr>
           <a:xfrm>
             <a:off x="548640" y="320040"/>
-            <a:ext cx="11064240" cy="731520"/>
+            <a:ext cx="11064240" cy="640080"/>
           </a:xfrm>
           <a:prstGeom prst="rect">
             <a:avLst/>
@@ -7422,7 +9016,7 @@
         <p:spPr>
           <a:xfrm>
             <a:off x="548640" y="320040"/>
-            <a:ext cx="11064240" cy="731520"/>
+            <a:ext cx="11064240" cy="640080"/>
           </a:xfrm>
           <a:prstGeom prst="rect">
             <a:avLst/>
@@ -7648,7 +9242,7 @@
         <p:spPr>
           <a:xfrm>
             <a:off x="548640" y="320040"/>
-            <a:ext cx="11064240" cy="731520"/>
+            <a:ext cx="11064240" cy="640080"/>
           </a:xfrm>
           <a:prstGeom prst="rect">
             <a:avLst/>
@@ -9633,7 +11227,7 @@
                 </a:solidFill>
                 <a:latin typeface="Arial"/>
               </a:rPr>
-              <a:t>3  patient adaptation (matured errors)</a:t>
+              <a:t>3  bounded patient update (±25 mg/dL)</a:t>
             </a:r>
           </a:p>
           <a:p>
@@ -9649,7 +11243,7 @@
                 </a:solidFill>
                 <a:latin typeface="Arial"/>
               </a:rPr>
-              <a:t>4  80 % prediction range (conformal)</a:t>
+              <a:t>4  80 % range · warning &gt; 180 mg/dL</a:t>
             </a:r>
           </a:p>
           <a:p>
@@ -9665,7 +11259,7 @@
                 </a:solidFill>
                 <a:latin typeface="Arial"/>
               </a:rPr>
-              <a:t>5  warning: new episode &gt; 180 mg/dL</a:t>
+              <a:t>5  abstain / degraded / stale guards</a:t>
             </a:r>
           </a:p>
         </p:txBody>
@@ -9788,7 +11382,7 @@
                 </a:solidFill>
                 <a:latin typeface="Arial"/>
               </a:rPr>
-              <a:t>Overview · Participants</a:t>
+              <a:t>warnings with outcomes</a:t>
             </a:r>
           </a:p>
           <a:p>
@@ -9804,7 +11398,7 @@
                 </a:solidFill>
                 <a:latin typeface="Arial"/>
               </a:rPr>
-              <a:t>Replay with warnings</a:t>
+              <a:t>clinician review + note</a:t>
             </a:r>
           </a:p>
           <a:p>
@@ -9820,7 +11414,7 @@
                 </a:solidFill>
                 <a:latin typeface="Arial"/>
               </a:rPr>
-              <a:t>Model evidence</a:t>
+              <a:t>review ledger (SQLite)</a:t>
             </a:r>
           </a:p>
           <a:p>
@@ -9836,7 +11430,7 @@
                 </a:solidFill>
                 <a:latin typeface="Arial"/>
               </a:rPr>
-              <a:t>Data quality</a:t>
+              <a:t>evidence · data quality</a:t>
             </a:r>
           </a:p>
         </p:txBody>
@@ -10308,14 +11902,48 @@
       </p:sp>
       <p:sp>
         <p:nvSpPr>
-          <p:cNvPr id="70" name="TextBox 69"/>
+          <p:cNvPr id="70" name="Rounded Rectangle 69"/>
+          <p:cNvSpPr/>
+          <p:nvPr/>
+        </p:nvSpPr>
+        <p:spPr>
+          <a:xfrm>
+            <a:off x="4956048" y="3304184"/>
+            <a:ext cx="1444752" cy="1096365"/>
+          </a:xfrm>
+          <a:prstGeom prst="roundRect">
+            <a:avLst>
+              <a:gd name="adj" fmla="val 5000"/>
+            </a:avLst>
+          </a:prstGeom>
+          <a:solidFill>
+            <a:srgbClr val="FFFFFF"/>
+          </a:solidFill>
+          <a:ln w="12700">
+            <a:solidFill>
+              <a:srgbClr val="3F4652"/>
+            </a:solidFill>
+            <a:prstDash val="dash"/>
+          </a:ln>
+        </p:spPr>
+        <p:txBody>
+          <a:bodyPr rtlCol="0" anchor="ctr"/>
+          <a:lstStyle/>
+          <a:p>
+            <a:pPr algn="ctr"/>
+          </a:p>
+        </p:txBody>
+      </p:sp>
+      <p:sp>
+        <p:nvSpPr>
+          <p:cNvPr id="71" name="TextBox 70"/>
           <p:cNvSpPr txBox="1"/>
           <p:nvPr/>
         </p:nvSpPr>
         <p:spPr>
           <a:xfrm>
-            <a:off x="365760" y="6438290"/>
-            <a:ext cx="11521440" cy="228600"/>
+            <a:off x="5065776" y="3413912"/>
+            <a:ext cx="1225296" cy="292608"/>
           </a:xfrm>
           <a:prstGeom prst="rect">
             <a:avLst/>
@@ -10330,13 +11958,119 @@
           <a:p>
             <a:pPr algn="l"/>
             <a:r>
+              <a:rPr sz="1150" b="1" i="0">
+                <a:solidFill>
+                  <a:srgbClr val="0B1220"/>
+                </a:solidFill>
+                <a:latin typeface="Arial"/>
+              </a:rPr>
+              <a:t>Candidates</a:t>
+            </a:r>
+          </a:p>
+        </p:txBody>
+      </p:sp>
+      <p:sp>
+        <p:nvSpPr>
+          <p:cNvPr id="72" name="TextBox 71"/>
+          <p:cNvSpPr txBox="1"/>
+          <p:nvPr/>
+        </p:nvSpPr>
+        <p:spPr>
+          <a:xfrm>
+            <a:off x="5065776" y="3706520"/>
+            <a:ext cx="1225296" cy="617220"/>
+          </a:xfrm>
+          <a:prstGeom prst="rect">
+            <a:avLst/>
+          </a:prstGeom>
+          <a:noFill/>
+        </p:spPr>
+        <p:txBody>
+          <a:bodyPr wrap="none" lIns="0" rIns="0" tIns="0" bIns="0" anchor="t">
+            <a:spAutoFit/>
+          </a:bodyPr>
+          <a:lstStyle/>
+          <a:p>
+            <a:pPr algn="l">
+              <a:lnSpc>
+                <a:spcPts val="1620"/>
+              </a:lnSpc>
+            </a:pPr>
+            <a:r>
+              <a:rPr sz="950" b="0" i="0">
+                <a:solidFill>
+                  <a:srgbClr val="0B1220"/>
+                </a:solidFill>
+                <a:latin typeface="Arial"/>
+              </a:rPr>
+              <a:t>research only, offline;</a:t>
+            </a:r>
+          </a:p>
+          <a:p>
+            <a:pPr algn="l">
+              <a:lnSpc>
+                <a:spcPts val="1620"/>
+              </a:lnSpc>
+            </a:pPr>
+            <a:r>
+              <a:rPr sz="950" b="0" i="0">
+                <a:solidFill>
+                  <a:srgbClr val="0B1220"/>
+                </a:solidFill>
+                <a:latin typeface="Arial"/>
+              </a:rPr>
+              <a:t>served only if every</a:t>
+            </a:r>
+          </a:p>
+          <a:p>
+            <a:pPr algn="l">
+              <a:lnSpc>
+                <a:spcPts val="1620"/>
+              </a:lnSpc>
+            </a:pPr>
+            <a:r>
+              <a:rPr sz="950" b="0" i="0">
+                <a:solidFill>
+                  <a:srgbClr val="0B1220"/>
+                </a:solidFill>
+                <a:latin typeface="Arial"/>
+              </a:rPr>
+              <a:t>release gate passes</a:t>
+            </a:r>
+          </a:p>
+        </p:txBody>
+      </p:sp>
+      <p:sp>
+        <p:nvSpPr>
+          <p:cNvPr id="73" name="TextBox 72"/>
+          <p:cNvSpPr txBox="1"/>
+          <p:nvPr/>
+        </p:nvSpPr>
+        <p:spPr>
+          <a:xfrm>
+            <a:off x="365760" y="6438290"/>
+            <a:ext cx="11521440" cy="228600"/>
+          </a:xfrm>
+          <a:prstGeom prst="rect">
+            <a:avLst/>
+          </a:prstGeom>
+          <a:noFill/>
+        </p:spPr>
+        <p:txBody>
+          <a:bodyPr wrap="none" lIns="0" rIns="0" tIns="0" bIns="0" anchor="t">
+            <a:spAutoFit/>
+          </a:bodyPr>
+          <a:lstStyle/>
+          <a:p>
+            <a:pPr algn="l"/>
+            <a:r>
               <a:rPr sz="850" b="0" i="0">
                 <a:solidFill>
                   <a:srgbClr val="3F4652"/>
                 </a:solidFill>
                 <a:latin typeface="Arial"/>
               </a:rPr>
-              <a:t>Solid arrow: data flow   ·   Dashed: identical code offline and online   ·   Blue: serving model   ·   CPU only, runs locally, no cloud, no LLM   ·   research prototype, not a medical device</a:t>
+              <a:t>Solid arrow: data flow   ·   Dashed line: identical code offline and online   ·   Blue: serving model   ·   Dashed box: research only, not served   ·   CPU only, local, no cloud, no LLM   ·   not a medical device</a:t>
             </a:r>
           </a:p>
         </p:txBody>
@@ -10376,7 +12110,7 @@
         <p:spPr>
           <a:xfrm>
             <a:off x="548640" y="320040"/>
-            <a:ext cx="11064240" cy="731520"/>
+            <a:ext cx="11064240" cy="640080"/>
           </a:xfrm>
           <a:prstGeom prst="rect">
             <a:avLst/>
@@ -10610,7 +12344,7 @@
         <p:spPr>
           <a:xfrm>
             <a:off x="548640" y="320040"/>
-            <a:ext cx="11064240" cy="731520"/>
+            <a:ext cx="11064240" cy="640080"/>
           </a:xfrm>
           <a:prstGeom prst="rect">
             <a:avLst/>

</xml_diff>

<commit_message>
submission: deck reads D-054 from its saved summary; Shanghai rows name the cohort's second opening; D-053 stays pending
</commit_message>
<xml_diff>
--- a/docs/submission/GlucoTwin_Presentation.pptx
+++ b/docs/submission/GlucoTwin_Presentation.pptx
@@ -32,6 +32,7 @@
     <p:sldId id="280" r:id="rId31"/>
     <p:sldId id="281" r:id="rId32"/>
     <p:sldId id="282" r:id="rId33"/>
+    <p:sldId id="283" r:id="rId34"/>
   </p:sldIdLst>
   <p:sldSz cx="12191695" cy="6858000" type="screen4x3"/>
   <p:notesSz cx="6858000" cy="9144000"/>
@@ -4577,7 +4578,7 @@
                           </a:solidFill>
                           <a:latin typeface="Arial"/>
                         </a:rPr>
-                        <a:t>CGM-only research procedure (Ridge in 4 of 5 folds), not served</a:t>
+                        <a:t>CGM-only procedure (Ridge in 4 of 5 folds), not served</a:t>
                       </a:r>
                     </a:p>
                   </a:txBody>
@@ -4735,7 +4736,7 @@
                           </a:solidFill>
                           <a:latin typeface="Arial"/>
                         </a:rPr>
-                        <a:t>14 CGMacros people (D-054)</a:t>
+                        <a:t>Same 14 people (D-054)</a:t>
                       </a:r>
                     </a:p>
                   </a:txBody>
@@ -4757,7 +4758,7 @@
                           </a:solidFill>
                           <a:latin typeface="Arial"/>
                         </a:rPr>
-                        <a:t>Zero-shot time-series foundation-model baseline on CGM only (a comparison, not a fusion model)</a:t>
+                        <a:t>Zero-shot foundation model, CGM only, not served</a:t>
                       </a:r>
                     </a:p>
                   </a:txBody>
@@ -4773,13 +4774,13 @@
                     <a:lstStyle/>
                     <a:p>
                       <a:r>
-                        <a:rPr sz="1350" b="0" i="1">
+                        <a:rPr sz="1350" b="0" i="0">
                           <a:solidFill>
                             <a:srgbClr val="0B1220"/>
                           </a:solidFill>
                           <a:latin typeface="Arial"/>
                         </a:rPr>
-                        <a:t>pending</a:t>
+                        <a:t>14.55 / 22.92</a:t>
                       </a:r>
                     </a:p>
                   </a:txBody>
@@ -4795,13 +4796,13 @@
                     <a:lstStyle/>
                     <a:p>
                       <a:r>
-                        <a:rPr sz="1350" b="0" i="1">
+                        <a:rPr sz="1350" b="0" i="0">
                           <a:solidFill>
                             <a:srgbClr val="0B1220"/>
                           </a:solidFill>
                           <a:latin typeface="Arial"/>
                         </a:rPr>
-                        <a:t>pending</a:t>
+                        <a:t>15.34 / 24.47</a:t>
                       </a:r>
                     </a:p>
                   </a:txBody>
@@ -4825,7 +4826,7 @@
                           </a:solidFill>
                           <a:latin typeface="Arial"/>
                         </a:rPr>
-                        <a:t>External check — ShanghaiT2DM, 98 people, CGM only, assessed once</a:t>
+                        <a:t>External check — ShanghaiT2DM, 98 people, CGM only; D-045 was the cohort's second opening</a:t>
                       </a:r>
                     </a:p>
                   </a:txBody>
@@ -4907,7 +4908,7 @@
                           </a:solidFill>
                           <a:latin typeface="Arial"/>
                         </a:rPr>
-                        <a:t>Separate 15-min LightGBM on CGM only, not the serving fusion model</a:t>
+                        <a:t>Separate 15-min LightGBM, CGM only, not served</a:t>
                       </a:r>
                     </a:p>
                   </a:txBody>
@@ -6968,7 +6969,7 @@
                 </a:solidFill>
                 <a:latin typeface="Arial"/>
               </a:rPr>
-              <a:t>Research, 21–22 October: two declared studies</a:t>
+              <a:t>Research, 21–22 October: constrained LightGBM (D-053)</a:t>
             </a:r>
           </a:p>
         </p:txBody>
@@ -7078,7 +7079,7 @@
                 </a:solidFill>
                 <a:latin typeface="Arial"/>
               </a:rPr>
-              <a:t>•  D-054 · gt-foundation-2026-10-21 — Zero-shot time-series foundation-model baseline on CGM only (a comparison, not a fusion model). Result and release-gate outcome: pending (inserted only from the locked, verified summary).</a:t>
+              <a:t>•  The protocol was declared before its own run. It reuses previously inspected participants, so its result is internal validation.</a:t>
             </a:r>
           </a:p>
           <a:p>
@@ -7094,23 +7095,7 @@
                 </a:solidFill>
                 <a:latin typeface="Arial"/>
               </a:rPr>
-              <a:t>•  Both protocols were declared before their own runs. Later studies reused previously inspected participants, so their results are internal validation.</a:t>
-            </a:r>
-          </a:p>
-          <a:p>
-            <a:pPr>
-              <a:spcAft>
-                <a:spcPts val="1000"/>
-              </a:spcAft>
-            </a:pPr>
-            <a:r>
-              <a:rPr sz="1700">
-                <a:solidFill>
-                  <a:srgbClr val="0B1220"/>
-                </a:solidFill>
-                <a:latin typeface="Arial"/>
-              </a:rPr>
-              <a:t>•  Nothing from these studies reaches the app unless every declared release gate passes and the candidate passes serving parity and integration checks; otherwise the serving model is unchanged.</a:t>
+              <a:t>•  Nothing from it reaches the app unless every declared release gate passes and the candidate passes serving parity and integration checks; otherwise the serving model is unchanged.</a:t>
             </a:r>
           </a:p>
         </p:txBody>
@@ -7170,7 +7155,7 @@
                 </a:solidFill>
                 <a:latin typeface="Arial"/>
               </a:rPr>
-              <a:t>RESEARCH · external cohort, CGM only · not the serving fusion model</a:t>
+              <a:t>RESEARCH · 14 previously inspected people · internal comparison · CGM only · not served</a:t>
             </a:r>
           </a:p>
         </p:txBody>
@@ -7204,7 +7189,7 @@
                 </a:solidFill>
                 <a:latin typeface="Arial"/>
               </a:rPr>
-              <a:t>External check: an independent Type 2 cohort</a:t>
+              <a:t>Research: a zero-shot foundation-model baseline (D-054)</a:t>
             </a:r>
           </a:p>
         </p:txBody>
@@ -7298,7 +7283,7 @@
                 </a:solidFill>
                 <a:latin typeface="Arial"/>
               </a:rPr>
-              <a:t>•  Who: 98 adults with Type 2 diabetes in ShanghaiT2DM (China, FreeStyle Libre H, 15-minute readings), never trained on. No wearable or dated labs, so this checks the forecasting core only, not the fusion.</a:t>
+              <a:t>•  What: amazon/chronos-bolt-tiny (pinned revision, 8.7 M parameters, apache-2.0), zero-shot on CGM only: each forecast origin is its own series of past readings; median forecast fixed in advance. Not fine-tuned, not a fusion model, not served. Its public pretraining data may include CGM recordings.</a:t>
             </a:r>
           </a:p>
           <a:p>
@@ -7314,7 +7299,7 @@
                 </a:solidFill>
                 <a:latin typeface="Arial"/>
               </a:rPr>
-              <a:t>•  What: a separate 15-minute LightGBM on CGM-only features, developed on CGMacros. It is not the serving fusion model and not the Ridge candidate.</a:t>
+              <a:t>•  Against carrying the last reading forward, on identical origins: -0.79 [-1.01, -0.59] mg/dL at 30 min and -1.54 [-1.81, -1.30] at 60 min (macro MAE 22.92 vs 24.47; lower for 14 of 14 people).</a:t>
             </a:r>
           </a:p>
           <a:p>
@@ -7330,7 +7315,7 @@
                 </a:solidFill>
                 <a:latin typeface="Arial"/>
               </a:rPr>
-              <a:t>•  30 / 60 minutes (D-032, opened once): -0.99 [-1.21, -0.77] mg/dL at 30 min (clear) and -0.34 [-0.76, +0.10] mg/dL at 60 min (inconclusive), versus carrying the last reading forward.</a:t>
+              <a:t>•  Against the serving recipe refitted with each person held out (saved from D-052): +0.42 [-0.70, +1.47] mg/dL at 60 min (22.92 vs 22.50) — not better, and clearly worse on readings above 180.</a:t>
             </a:r>
           </a:p>
           <a:p>
@@ -7346,7 +7331,7 @@
                 </a:solidFill>
                 <a:latin typeface="Arial"/>
               </a:rPr>
-              <a:t>•  Two hours ahead (D-045, declared before any fit, assessed once): 29.6 vs persistence 31.7 mg/dL at 120 min (-2.12 [-2.67, -1.53]), better for 78 of 98 people.</a:t>
+              <a:t>•  Declared secondary: the foundation forecast plus a freshly fitted LightGBM residual on the served inputs, -0.46 [-0.72, -0.21] mg/dL at 60 min against the same-code refit. Descriptive only; not a release candidate.</a:t>
             </a:r>
           </a:p>
           <a:p>
@@ -7362,7 +7347,7 @@
                 </a:solidFill>
                 <a:latin typeface="Arial"/>
               </a:rPr>
-              <a:t>•  Nothing was chosen on this cohort; other frozen pipelines were reported but not adopted, because choosing on it would turn it into a tuning set.</a:t>
+              <a:t>•  Declared before any participant forecast; the 14 people were inspected in earlier experiments, so this is an internal comparison, not independent confirmation.</a:t>
             </a:r>
           </a:p>
         </p:txBody>
@@ -7401,8 +7386,8 @@
         </p:nvSpPr>
         <p:spPr>
           <a:xfrm>
-            <a:off x="548640" y="320040"/>
-            <a:ext cx="11064240" cy="640080"/>
+            <a:off x="548640" y="128016"/>
+            <a:ext cx="11064240" cy="274320"/>
           </a:xfrm>
           <a:prstGeom prst="rect">
             <a:avLst/>
@@ -7416,20 +7401,54 @@
           <a:lstStyle/>
           <a:p>
             <a:r>
+              <a:rPr sz="1100" b="1">
+                <a:solidFill>
+                  <a:srgbClr val="2563EB"/>
+                </a:solidFill>
+                <a:latin typeface="Arial"/>
+              </a:rPr>
+              <a:t>RESEARCH · external cohort, CGM only · not the serving fusion model</a:t>
+            </a:r>
+          </a:p>
+        </p:txBody>
+      </p:sp>
+      <p:sp>
+        <p:nvSpPr>
+          <p:cNvPr id="3" name="TextBox 2"/>
+          <p:cNvSpPr txBox="1"/>
+          <p:nvPr/>
+        </p:nvSpPr>
+        <p:spPr>
+          <a:xfrm>
+            <a:off x="548640" y="384048"/>
+            <a:ext cx="11064240" cy="640080"/>
+          </a:xfrm>
+          <a:prstGeom prst="rect">
+            <a:avLst/>
+          </a:prstGeom>
+          <a:noFill/>
+        </p:spPr>
+        <p:txBody>
+          <a:bodyPr wrap="square">
+            <a:spAutoFit/>
+          </a:bodyPr>
+          <a:lstStyle/>
+          <a:p>
+            <a:r>
               <a:rPr sz="3000" b="1">
                 <a:solidFill>
                   <a:srgbClr val="0B1220"/>
                 </a:solidFill>
                 <a:latin typeface="Arial"/>
               </a:rPr>
-              <a:t>Project outcomes</a:t>
+              <a:t>External check: an independent Type 2 cohort</a:t>
             </a:r>
           </a:p>
         </p:txBody>
       </p:sp>
       <p:cxnSp>
         <p:nvCxnSpPr>
-          <p:cNvPr id="3" name="Connector 2"/>
+          <p:cNvPr id="4" name="Connector 3"/>
           <p:cNvCxnSpPr/>
           <p:nvPr/>
         </p:nvCxnSpPr>
@@ -7450,7 +7469,7 @@
       </p:cxnSp>
       <p:sp>
         <p:nvSpPr>
-          <p:cNvPr id="4" name="TextBox 3"/>
+          <p:cNvPr id="5" name="TextBox 4"/>
           <p:cNvSpPr txBox="1"/>
           <p:nvPr/>
         </p:nvSpPr>
@@ -7484,7 +7503,7 @@
       </p:sp>
       <p:sp>
         <p:nvSpPr>
-          <p:cNvPr id="5" name="TextBox 4"/>
+          <p:cNvPr id="6" name="TextBox 5"/>
           <p:cNvSpPr txBox="1"/>
           <p:nvPr/>
         </p:nvSpPr>
@@ -7516,7 +7535,7 @@
                 </a:solidFill>
                 <a:latin typeface="Arial"/>
               </a:rPr>
-              <a:t>•  Built: a working personalized glucose twin — replay API with a backend-owned clock, immutable forecasts, research warnings with outcomes — and a clinician workspace (landing page, Overview, Participants, Replay sessions, Model evidence, Data quality).</a:t>
+              <a:t>•  Who: 98 adults with Type 2 diabetes in ShanghaiT2DM (China, FreeStyle Libre H, 15-minute readings), never trained on. No wearable or dated labs, so this checks the forecasting core only, not the fusion.</a:t>
             </a:r>
           </a:p>
           <a:p>
@@ -7532,7 +7551,7 @@
                 </a:solidFill>
                 <a:latin typeface="Arial"/>
               </a:rPr>
-              <a:t>•  Found and corrected a data-provenance problem: the published 1-minute CGM values are interpolated; only native 5-minute readings are used.</a:t>
+              <a:t>•  What: a separate 15-minute LightGBM on CGM-only features, developed on CGMacros. It is not the serving fusion model and not the Ridge candidate.</a:t>
             </a:r>
           </a:p>
           <a:p>
@@ -7548,7 +7567,7 @@
                 </a:solidFill>
                 <a:latin typeface="Arial"/>
               </a:rPr>
-              <a:t>•  Measured on later recordings of the same participants (retrospective): 14/14 participants improved over persistence at 30 min and 13/14 at 60 min; MAE 12.96 / 20.26 mg/dL vs 14.84 / 23.23.</a:t>
+              <a:t>•  30 / 60 minutes (D-032, the cohort's first opening): -0.99 [-1.21, -0.77] mg/dL at 30 min (clear) and -0.34 [-0.76, +0.10] mg/dL at 60 min (inconclusive), versus carrying the last reading forward.</a:t>
             </a:r>
           </a:p>
           <a:p>
@@ -7564,7 +7583,7 @@
                 </a:solidFill>
                 <a:latin typeface="Arial"/>
               </a:rPr>
-              <a:t>•  Personalization: small gains (-0.18 mg/dL and -0.33 mg/dL). Warnings: 61/64 onsets detected with 40 false alarms (1.49 per observed patient-day) — the F1 threshold rule ignores review workload.</a:t>
+              <a:t>•  Two hours ahead (D-045, declared before any fit; its first 120-minute assessment and the cohort's second opening): 29.6 vs persistence 31.7 mg/dL at 120 min (-2.12 [-2.67, -1.53]), better for 78 of 98 people.</a:t>
             </a:r>
           </a:p>
           <a:p>
@@ -7580,23 +7599,7 @@
                 </a:solidFill>
                 <a:latin typeface="Arial"/>
               </a:rPr>
-              <a:t>•  Corrected after an independent review (activity-window defect, online warning double-credit; gt-primary-2026-10-11-v1 preserved), then re-run with the fusion constraint (gt-primary-2026-10-13-fusion); the dynamic-only model of gt-primary-2026-10-11-v2 stays registered for rollback.</a:t>
-            </a:r>
-          </a:p>
-          <a:p>
-            <a:pPr>
-              <a:spcAft>
-                <a:spcPts val="1000"/>
-              </a:spcAft>
-            </a:pPr>
-            <a:r>
-              <a:rPr sz="1700">
-                <a:solidFill>
-                  <a:srgbClr val="0B1220"/>
-                </a:solidFill>
-                <a:latin typeface="Arial"/>
-              </a:rPr>
-              <a:t>•  Reproducible: synthetic mode needs no download; recorded-data results regenerate from versioned configs; a fresh copy passes the automated backend, frontend and browser tests.</a:t>
+              <a:t>•  Nothing was chosen on this cohort; other frozen pipelines were reported but not adopted, because choosing on it would turn it into a tuning set.</a:t>
             </a:r>
           </a:p>
         </p:txBody>
@@ -7656,7 +7659,7 @@
                 </a:solidFill>
                 <a:latin typeface="Arial"/>
               </a:rPr>
-              <a:t>Limitations</a:t>
+              <a:t>Project outcomes</a:t>
             </a:r>
           </a:p>
         </p:txBody>
@@ -7744,13 +7747,13 @@
               </a:spcAft>
             </a:pPr>
             <a:r>
-              <a:rPr sz="1550">
-                <a:solidFill>
-                  <a:srgbClr val="0B1220"/>
-                </a:solidFill>
-                <a:latin typeface="Arial"/>
-              </a:rPr>
-              <a:t>•  14 participants from one US site; overlapping windows are not independent patients.</a:t>
+              <a:rPr sz="1700">
+                <a:solidFill>
+                  <a:srgbClr val="0B1220"/>
+                </a:solidFill>
+                <a:latin typeface="Arial"/>
+              </a:rPr>
+              <a:t>•  Built: a working personalized glucose twin — replay API with a backend-owned clock, immutable forecasts, research warnings with outcomes — and a clinician workspace (landing page, Overview, Participants, Replay sessions, Model evidence, Data quality).</a:t>
             </a:r>
           </a:p>
           <a:p>
@@ -7760,13 +7763,13 @@
               </a:spcAft>
             </a:pPr>
             <a:r>
-              <a:rPr sz="1550">
-                <a:solidFill>
-                  <a:srgbClr val="0B1220"/>
-                </a:solidFill>
-                <a:latin typeface="Arial"/>
-              </a:rPr>
-              <a:t>•  No Indian participants — nothing here establishes performance for patients in India.</a:t>
+              <a:rPr sz="1700">
+                <a:solidFill>
+                  <a:srgbClr val="0B1220"/>
+                </a:solidFill>
+                <a:latin typeface="Arial"/>
+              </a:rPr>
+              <a:t>•  Found and corrected a data-provenance problem: the published 1-minute CGM values are interpolated; only native 5-minute readings are used.</a:t>
             </a:r>
           </a:p>
           <a:p>
@@ -7776,13 +7779,13 @@
               </a:spcAft>
             </a:pPr>
             <a:r>
-              <a:rPr sz="1550">
-                <a:solidFill>
-                  <a:srgbClr val="0B1220"/>
-                </a:solidFill>
-                <a:latin typeface="Arial"/>
-              </a:rPr>
-              <a:t>•  Blinded research CGMs replayed with assumed zero latency; native timestamps known to the minute.</a:t>
+              <a:rPr sz="1700">
+                <a:solidFill>
+                  <a:srgbClr val="0B1220"/>
+                </a:solidFill>
+                <a:latin typeface="Arial"/>
+              </a:rPr>
+              <a:t>•  Measured on later recordings of the same participants (retrospective): 14/14 participants improved over persistence at 30 min and 13/14 at 60 min; MAE 12.96 / 20.26 mg/dL vs 14.84 / 23.23.</a:t>
             </a:r>
           </a:p>
           <a:p>
@@ -7792,13 +7795,13 @@
               </a:spcAft>
             </a:pPr>
             <a:r>
-              <a:rPr sz="1550">
-                <a:solidFill>
-                  <a:srgbClr val="0B1220"/>
-                </a:solidFill>
-                <a:latin typeface="Arial"/>
-              </a:rPr>
-              <a:t>•  Medication and insulin use unknown; meal logging time undocumented.</a:t>
+              <a:rPr sz="1700">
+                <a:solidFill>
+                  <a:srgbClr val="0B1220"/>
+                </a:solidFill>
+                <a:latin typeface="Arial"/>
+              </a:rPr>
+              <a:t>•  Personalization: small gains (-0.18 mg/dL and -0.33 mg/dL). Warnings: 61/64 onsets detected with 40 false alarms (1.49 per observed patient-day) — the F1 threshold rule ignores review workload.</a:t>
             </a:r>
           </a:p>
           <a:p>
@@ -7808,13 +7811,13 @@
               </a:spcAft>
             </a:pPr>
             <a:r>
-              <a:rPr sz="1550">
-                <a:solidFill>
-                  <a:srgbClr val="0B1220"/>
-                </a:solidFill>
-                <a:latin typeface="Arial"/>
-              </a:rPr>
-              <a:t>•  Profile fusion: profile values are constant per person, so with 14 people they can act as an identity code; no benefit was shown on people held out entirely.</a:t>
+              <a:rPr sz="1700">
+                <a:solidFill>
+                  <a:srgbClr val="0B1220"/>
+                </a:solidFill>
+                <a:latin typeface="Arial"/>
+              </a:rPr>
+              <a:t>•  Corrected after an independent review (activity-window defect, online warning double-credit; gt-primary-2026-10-11-v1 preserved), then re-run with the fusion constraint (gt-primary-2026-10-13-fusion); the dynamic-only model of gt-primary-2026-10-11-v2 stays registered for rollback.</a:t>
             </a:r>
           </a:p>
           <a:p>
@@ -7824,45 +7827,13 @@
               </a:spcAft>
             </a:pPr>
             <a:r>
-              <a:rPr sz="1550">
-                <a:solidFill>
-                  <a:srgbClr val="0B1220"/>
-                </a:solidFill>
-                <a:latin typeface="Arial"/>
-              </a:rPr>
-              <a:t>•  Prediction ranges under-cover; the warning score is uncalibrated and its threshold rule (F1) ignores review workload; 180 mg/dL is a research threshold, not triage.</a:t>
-            </a:r>
-          </a:p>
-          <a:p>
-            <a:pPr>
-              <a:spcAft>
-                <a:spcPts val="1000"/>
-              </a:spcAft>
-            </a:pPr>
-            <a:r>
-              <a:rPr sz="1550">
-                <a:solidFill>
-                  <a:srgbClr val="0B1220"/>
-                </a:solidFill>
-                <a:latin typeface="Arial"/>
-              </a:rPr>
-              <a:t>•  Retrospective replay only: no clinician workflow, outcome or safety study. Foundation-model baseline (D-054): result pending.</a:t>
-            </a:r>
-          </a:p>
-          <a:p>
-            <a:pPr>
-              <a:spcAft>
-                <a:spcPts val="1000"/>
-              </a:spcAft>
-            </a:pPr>
-            <a:r>
-              <a:rPr sz="1550">
-                <a:solidFill>
-                  <a:srgbClr val="0B1220"/>
-                </a:solidFill>
-                <a:latin typeface="Arial"/>
-              </a:rPr>
-              <a:t>•  Scores depend on the dataset, prediction task and evaluation protocol; performance on simulated patients does not establish performance on real patients.</a:t>
+              <a:rPr sz="1700">
+                <a:solidFill>
+                  <a:srgbClr val="0B1220"/>
+                </a:solidFill>
+                <a:latin typeface="Arial"/>
+              </a:rPr>
+              <a:t>•  Reproducible: synthetic mode needs no download; recorded-data results regenerate from versioned configs; a fresh copy passes the automated backend, frontend and browser tests.</a:t>
             </a:r>
           </a:p>
         </p:txBody>
@@ -7922,7 +7893,7 @@
                 </a:solidFill>
                 <a:latin typeface="Arial"/>
               </a:rPr>
-              <a:t>Next steps: evidence needed for Indian patients</a:t>
+              <a:t>Limitations</a:t>
             </a:r>
           </a:p>
         </p:txBody>
@@ -8010,13 +7981,13 @@
               </a:spcAft>
             </a:pPr>
             <a:r>
-              <a:rPr sz="1700">
-                <a:solidFill>
-                  <a:srgbClr val="0B1220"/>
-                </a:solidFill>
-                <a:latin typeface="Arial"/>
-              </a:rPr>
-              <a:t>•  Prospective, consented Indian cohort with unblinded CGMs, recorded transmission latency, medications and meal logging times.</a:t>
+              <a:rPr sz="1550">
+                <a:solidFill>
+                  <a:srgbClr val="0B1220"/>
+                </a:solidFill>
+                <a:latin typeface="Arial"/>
+              </a:rPr>
+              <a:t>•  14 participants from one US site; overlapping windows are not independent patients.</a:t>
             </a:r>
           </a:p>
           <a:p>
@@ -8026,13 +7997,13 @@
               </a:spcAft>
             </a:pPr>
             <a:r>
-              <a:rPr sz="1700">
-                <a:solidFill>
-                  <a:srgbClr val="0B1220"/>
-                </a:solidFill>
-                <a:latin typeface="Arial"/>
-              </a:rPr>
-              <a:t>•  Re-evaluate held-out participants (cold start) and per-site calibration; report subgroup performance.</a:t>
+              <a:rPr sz="1550">
+                <a:solidFill>
+                  <a:srgbClr val="0B1220"/>
+                </a:solidFill>
+                <a:latin typeface="Arial"/>
+              </a:rPr>
+              <a:t>•  No Indian participants — nothing here establishes performance for patients in India.</a:t>
             </a:r>
           </a:p>
           <a:p>
@@ -8042,13 +8013,13 @@
               </a:spcAft>
             </a:pPr>
             <a:r>
-              <a:rPr sz="1700">
-                <a:solidFill>
-                  <a:srgbClr val="0B1220"/>
-                </a:solidFill>
-                <a:latin typeface="Arial"/>
-              </a:rPr>
-              <a:t>•  AI-READI five-minute CGM and wearable data (access not yet requested; steps listed) for a larger new-person evaluation under the declared protocol gt-nested-2026-10-12-v2.</a:t>
+              <a:rPr sz="1550">
+                <a:solidFill>
+                  <a:srgbClr val="0B1220"/>
+                </a:solidFill>
+                <a:latin typeface="Arial"/>
+              </a:rPr>
+              <a:t>•  Blinded research CGMs replayed with assumed zero latency; native timestamps known to the minute.</a:t>
             </a:r>
           </a:p>
           <a:p>
@@ -8058,13 +8029,13 @@
               </a:spcAft>
             </a:pPr>
             <a:r>
-              <a:rPr sz="1700">
-                <a:solidFill>
-                  <a:srgbClr val="0B1220"/>
-                </a:solidFill>
-                <a:latin typeface="Arial"/>
-              </a:rPr>
-              <a:t>•  Clinician usability study of the review workflow; regulatory and data-protection review (DPDP Act).</a:t>
+              <a:rPr sz="1550">
+                <a:solidFill>
+                  <a:srgbClr val="0B1220"/>
+                </a:solidFill>
+                <a:latin typeface="Arial"/>
+              </a:rPr>
+              <a:t>•  Medication and insulin use unknown; meal logging time undocumented.</a:t>
             </a:r>
           </a:p>
           <a:p>
@@ -8074,13 +8045,61 @@
               </a:spcAft>
             </a:pPr>
             <a:r>
-              <a:rPr sz="1700">
-                <a:solidFill>
-                  <a:srgbClr val="0B1220"/>
-                </a:solidFill>
-                <a:latin typeface="Arial"/>
-              </a:rPr>
-              <a:t>•  Optional: compare a fine-tuned time-series foundation model (e.g. Chronos-Bolt) under the same protocol.</a:t>
+              <a:rPr sz="1550">
+                <a:solidFill>
+                  <a:srgbClr val="0B1220"/>
+                </a:solidFill>
+                <a:latin typeface="Arial"/>
+              </a:rPr>
+              <a:t>•  Profile fusion: profile values are constant per person, so with 14 people they can act as an identity code; no benefit was shown on people held out entirely.</a:t>
+            </a:r>
+          </a:p>
+          <a:p>
+            <a:pPr>
+              <a:spcAft>
+                <a:spcPts val="1000"/>
+              </a:spcAft>
+            </a:pPr>
+            <a:r>
+              <a:rPr sz="1550">
+                <a:solidFill>
+                  <a:srgbClr val="0B1220"/>
+                </a:solidFill>
+                <a:latin typeface="Arial"/>
+              </a:rPr>
+              <a:t>•  Prediction ranges under-cover; the warning score is uncalibrated and its threshold rule (F1) ignores review workload; 180 mg/dL is a research threshold, not triage.</a:t>
+            </a:r>
+          </a:p>
+          <a:p>
+            <a:pPr>
+              <a:spcAft>
+                <a:spcPts val="1000"/>
+              </a:spcAft>
+            </a:pPr>
+            <a:r>
+              <a:rPr sz="1550">
+                <a:solidFill>
+                  <a:srgbClr val="0B1220"/>
+                </a:solidFill>
+                <a:latin typeface="Arial"/>
+              </a:rPr>
+              <a:t>•  Retrospective replay only: no clinician workflow, outcome or safety study. The foundation-model baseline was zero-shot only; fine-tuning was not run.</a:t>
+            </a:r>
+          </a:p>
+          <a:p>
+            <a:pPr>
+              <a:spcAft>
+                <a:spcPts val="1000"/>
+              </a:spcAft>
+            </a:pPr>
+            <a:r>
+              <a:rPr sz="1550">
+                <a:solidFill>
+                  <a:srgbClr val="0B1220"/>
+                </a:solidFill>
+                <a:latin typeface="Arial"/>
+              </a:rPr>
+              <a:t>•  Scores depend on the dataset, prediction task and evaluation protocol; performance on simulated patients does not establish performance on real patients.</a:t>
             </a:r>
           </a:p>
         </p:txBody>
@@ -8140,7 +8159,7 @@
                 </a:solidFill>
                 <a:latin typeface="Arial"/>
               </a:rPr>
-              <a:t>Team, links, reproducibility and licenses</a:t>
+              <a:t>Next steps: evidence needed for Indian patients</a:t>
             </a:r>
           </a:p>
         </p:txBody>
@@ -8196,6 +8215,224 @@
                 <a:latin typeface="Arial"/>
               </a:rPr>
               <a:t>27</a:t>
+            </a:r>
+          </a:p>
+        </p:txBody>
+      </p:sp>
+      <p:sp>
+        <p:nvSpPr>
+          <p:cNvPr id="5" name="TextBox 4"/>
+          <p:cNvSpPr txBox="1"/>
+          <p:nvPr/>
+        </p:nvSpPr>
+        <p:spPr>
+          <a:xfrm>
+            <a:off x="548640" y="1234440"/>
+            <a:ext cx="11064240" cy="5120640"/>
+          </a:xfrm>
+          <a:prstGeom prst="rect">
+            <a:avLst/>
+          </a:prstGeom>
+          <a:noFill/>
+        </p:spPr>
+        <p:txBody>
+          <a:bodyPr wrap="square">
+            <a:spAutoFit/>
+          </a:bodyPr>
+          <a:lstStyle/>
+          <a:p>
+            <a:pPr>
+              <a:spcAft>
+                <a:spcPts val="1000"/>
+              </a:spcAft>
+            </a:pPr>
+            <a:r>
+              <a:rPr sz="1700">
+                <a:solidFill>
+                  <a:srgbClr val="0B1220"/>
+                </a:solidFill>
+                <a:latin typeface="Arial"/>
+              </a:rPr>
+              <a:t>•  Prospective, consented Indian cohort with unblinded CGMs, recorded transmission latency, medications and meal logging times.</a:t>
+            </a:r>
+          </a:p>
+          <a:p>
+            <a:pPr>
+              <a:spcAft>
+                <a:spcPts val="1000"/>
+              </a:spcAft>
+            </a:pPr>
+            <a:r>
+              <a:rPr sz="1700">
+                <a:solidFill>
+                  <a:srgbClr val="0B1220"/>
+                </a:solidFill>
+                <a:latin typeface="Arial"/>
+              </a:rPr>
+              <a:t>•  Re-evaluate held-out participants (cold start) and per-site calibration; report subgroup performance.</a:t>
+            </a:r>
+          </a:p>
+          <a:p>
+            <a:pPr>
+              <a:spcAft>
+                <a:spcPts val="1000"/>
+              </a:spcAft>
+            </a:pPr>
+            <a:r>
+              <a:rPr sz="1700">
+                <a:solidFill>
+                  <a:srgbClr val="0B1220"/>
+                </a:solidFill>
+                <a:latin typeface="Arial"/>
+              </a:rPr>
+              <a:t>•  AI-READI five-minute CGM and wearable data (access not yet requested; steps listed) for a larger new-person evaluation under the declared protocol gt-nested-2026-10-12-v2.</a:t>
+            </a:r>
+          </a:p>
+          <a:p>
+            <a:pPr>
+              <a:spcAft>
+                <a:spcPts val="1000"/>
+              </a:spcAft>
+            </a:pPr>
+            <a:r>
+              <a:rPr sz="1700">
+                <a:solidFill>
+                  <a:srgbClr val="0B1220"/>
+                </a:solidFill>
+                <a:latin typeface="Arial"/>
+              </a:rPr>
+              <a:t>•  Clinician usability study of the review workflow; regulatory and data-protection review (DPDP Act).</a:t>
+            </a:r>
+          </a:p>
+          <a:p>
+            <a:pPr>
+              <a:spcAft>
+                <a:spcPts val="1000"/>
+              </a:spcAft>
+            </a:pPr>
+            <a:r>
+              <a:rPr sz="1700">
+                <a:solidFill>
+                  <a:srgbClr val="0B1220"/>
+                </a:solidFill>
+                <a:latin typeface="Arial"/>
+              </a:rPr>
+              <a:t>•  Optional: fine-tune a time-series foundation model inside each training boundary and compare it under the same protocol (zero-shot only so far, D-054).</a:t>
+            </a:r>
+          </a:p>
+        </p:txBody>
+      </p:sp>
+    </p:spTree>
+  </p:cSld>
+  <p:clrMapOvr>
+    <a:masterClrMapping/>
+  </p:clrMapOvr>
+</p:sld>
+</file>
+
+<file path=ppt/slides/slide28.xml><?xml version="1.0" encoding="utf-8"?>
+<p:sld xmlns:a="http://schemas.openxmlformats.org/drawingml/2006/main" xmlns:p="http://schemas.openxmlformats.org/presentationml/2006/main" xmlns:r="http://schemas.openxmlformats.org/officeDocument/2006/relationships">
+  <p:cSld>
+    <p:bg>
+      <p:bgPr>
+        <a:solidFill>
+          <a:srgbClr val="FFFFFF"/>
+        </a:solidFill>
+        <a:effectLst/>
+      </p:bgPr>
+    </p:bg>
+    <p:spTree>
+      <p:nvGrpSpPr>
+        <p:cNvPr id="1" name=""/>
+        <p:cNvGrpSpPr/>
+        <p:nvPr/>
+      </p:nvGrpSpPr>
+      <p:grpSpPr/>
+      <p:sp>
+        <p:nvSpPr>
+          <p:cNvPr id="2" name="TextBox 1"/>
+          <p:cNvSpPr txBox="1"/>
+          <p:nvPr/>
+        </p:nvSpPr>
+        <p:spPr>
+          <a:xfrm>
+            <a:off x="548640" y="320040"/>
+            <a:ext cx="11064240" cy="640080"/>
+          </a:xfrm>
+          <a:prstGeom prst="rect">
+            <a:avLst/>
+          </a:prstGeom>
+          <a:noFill/>
+        </p:spPr>
+        <p:txBody>
+          <a:bodyPr wrap="square">
+            <a:spAutoFit/>
+          </a:bodyPr>
+          <a:lstStyle/>
+          <a:p>
+            <a:r>
+              <a:rPr sz="3000" b="1">
+                <a:solidFill>
+                  <a:srgbClr val="0B1220"/>
+                </a:solidFill>
+                <a:latin typeface="Arial"/>
+              </a:rPr>
+              <a:t>Team, links, reproducibility and licenses</a:t>
+            </a:r>
+          </a:p>
+        </p:txBody>
+      </p:sp>
+      <p:cxnSp>
+        <p:nvCxnSpPr>
+          <p:cNvPr id="3" name="Connector 2"/>
+          <p:cNvCxnSpPr/>
+          <p:nvPr/>
+        </p:nvCxnSpPr>
+        <p:spPr>
+          <a:xfrm>
+            <a:off x="548640" y="987552"/>
+            <a:ext cx="11091672" cy="0"/>
+          </a:xfrm>
+          <a:prstGeom prst="line">
+            <a:avLst/>
+          </a:prstGeom>
+          <a:ln w="9525">
+            <a:solidFill>
+              <a:srgbClr val="E3E8EF"/>
+            </a:solidFill>
+          </a:ln>
+        </p:spPr>
+      </p:cxnSp>
+      <p:sp>
+        <p:nvSpPr>
+          <p:cNvPr id="4" name="TextBox 3"/>
+          <p:cNvSpPr txBox="1"/>
+          <p:nvPr/>
+        </p:nvSpPr>
+        <p:spPr>
+          <a:xfrm>
+            <a:off x="11247120" y="6446520"/>
+            <a:ext cx="457200" cy="274320"/>
+          </a:xfrm>
+          <a:prstGeom prst="rect">
+            <a:avLst/>
+          </a:prstGeom>
+          <a:noFill/>
+        </p:spPr>
+        <p:txBody>
+          <a:bodyPr wrap="square">
+            <a:spAutoFit/>
+          </a:bodyPr>
+          <a:lstStyle/>
+          <a:p>
+            <a:r>
+              <a:rPr sz="1100" b="0">
+                <a:solidFill>
+                  <a:srgbClr val="0B1220"/>
+                </a:solidFill>
+                <a:latin typeface="Arial"/>
+              </a:rPr>
+              <a:t>28</a:t>
             </a:r>
           </a:p>
         </p:txBody>

</xml_diff>

<commit_message>
submission: D-053 result (primary gate not met, not adopted) in README, deck, script and judge guide from its locked summary; evidence manifest checks D-053 and D-054 with artifact hashes; recording checklist
</commit_message>
<xml_diff>
--- a/docs/submission/GlucoTwin_Presentation.pptx
+++ b/docs/submission/GlucoTwin_Presentation.pptx
@@ -4646,7 +4646,7 @@
                           </a:solidFill>
                           <a:latin typeface="Arial"/>
                         </a:rPr>
-                        <a:t>14 CGMacros people (D-053)</a:t>
+                        <a:t>Same folds (D-053)</a:t>
                       </a:r>
                     </a:p>
                   </a:txBody>
@@ -4668,7 +4668,7 @@
                           </a:solidFill>
                           <a:latin typeface="Arial"/>
                         </a:rPr>
-                        <a:t>Constrained LightGBM fusion</a:t>
+                        <a:t>Peak-aware constrained fusion selection, not adopted</a:t>
                       </a:r>
                     </a:p>
                   </a:txBody>
@@ -4684,13 +4684,13 @@
                     <a:lstStyle/>
                     <a:p>
                       <a:r>
-                        <a:rPr sz="1350" b="0" i="1">
+                        <a:rPr sz="1350" b="0" i="0">
                           <a:solidFill>
                             <a:srgbClr val="0B1220"/>
                           </a:solidFill>
                           <a:latin typeface="Arial"/>
                         </a:rPr>
-                        <a:t>pending</a:t>
+                        <a:t>13.89 / 22.00</a:t>
                       </a:r>
                     </a:p>
                   </a:txBody>
@@ -4706,13 +4706,13 @@
                     <a:lstStyle/>
                     <a:p>
                       <a:r>
-                        <a:rPr sz="1350" b="0" i="1">
+                        <a:rPr sz="1350" b="0" i="0">
                           <a:solidFill>
                             <a:srgbClr val="0B1220"/>
                           </a:solidFill>
                           <a:latin typeface="Arial"/>
                         </a:rPr>
-                        <a:t>pending</a:t>
+                        <a:t>15.34 / 24.47</a:t>
                       </a:r>
                     </a:p>
                   </a:txBody>
@@ -4996,7 +4996,7 @@
                 </a:solidFill>
                 <a:latin typeface="Arial"/>
               </a:rPr>
-              <a:t>Mean absolute error in mg/dL, averaged equally over participants: an average error, not an accuracy percentage. Each group is a different model and a different test — do not compare across groups. Serving ranges (target 80 %) covered 74.2 % / 74.0 %: under-coverage. Pending rows are filled only from verified, locked summaries.</a:t>
+              <a:t>Mean absolute error in mg/dL, averaged equally over participants: an average error, not an accuracy percentage. Each group is a different model and a different test — do not compare across groups. Serving ranges (target 80 %) covered 74.2 % / 74.0 %: under-coverage. Research rows are read from each study's locked summary.</a:t>
             </a:r>
           </a:p>
         </p:txBody>
@@ -6969,7 +6969,7 @@
                 </a:solidFill>
                 <a:latin typeface="Arial"/>
               </a:rPr>
-              <a:t>Research, 21–22 October: constrained LightGBM (D-053)</a:t>
+              <a:t>Research: peak-aware selection (D-053), a near miss</a:t>
             </a:r>
           </a:p>
         </p:txBody>
@@ -7063,7 +7063,7 @@
                 </a:solidFill>
                 <a:latin typeface="Arial"/>
               </a:rPr>
-              <a:t>•  D-053 · gt-constrained-2026-10-21 — Constrained LightGBM fusion: peak-aware selection with the patient correction, each person held out once, against a freshly refitted serving recipe. Result and release-gate outcome: pending (inserted only from the locked, verified summary).</a:t>
+              <a:t>•  Declared before any formal fit; inside each held-out fold, model settings, a training weight on future readings above 180 and the patient correction were chosen on development people only, with a guard on high-reading error. 1,490 fresh fits, 0 failures.</a:t>
             </a:r>
           </a:p>
           <a:p>
@@ -7079,7 +7079,7 @@
                 </a:solidFill>
                 <a:latin typeface="Arial"/>
               </a:rPr>
-              <a:t>•  The protocol was declared before its own run. It reuses previously inspected participants, so its result is internal validation.</a:t>
+              <a:t>•  60 min, against the serving recipe refitted in the same folds: 22.00 vs 23.20 mg/dL, -1.19 [-2.09, -0.39], lower for 11 of 14 people; 30 min -0.50 [-0.77, -0.24].</a:t>
             </a:r>
           </a:p>
           <a:p>
@@ -7095,7 +7095,55 @@
                 </a:solidFill>
                 <a:latin typeface="Arial"/>
               </a:rPr>
-              <a:t>•  Nothing from it reaches the app unless every declared release gate passes and the candidate passes serving parity and integration checks; otherwise the serving model is unchanged.</a:t>
+              <a:t>•  Primary gate not met: error on readings above 180 changed by +1.07 mg/dL against a declared limit of +1.0.</a:t>
+            </a:r>
+          </a:p>
+          <a:p>
+            <a:pPr>
+              <a:spcAft>
+                <a:spcPts val="1000"/>
+              </a:spcAft>
+            </a:pPr>
+            <a:r>
+              <a:rPr sz="1700">
+                <a:solidFill>
+                  <a:srgbClr val="0B1220"/>
+                </a:solidFill>
+                <a:latin typeface="Arial"/>
+              </a:rPr>
+              <a:t>•  Warning guardrails passed: 1.15 vs 1.20 false alarms per observed day; 21.9 % vs 16.4 % of onsets warned ≥ 30 min ahead. Exact-predictor 80 % ranges covered 79.4 % / 77.3 % (range guardrails passed).</a:t>
+            </a:r>
+          </a:p>
+          <a:p>
+            <a:pPr>
+              <a:spcAft>
+                <a:spcPts val="1000"/>
+              </a:spcAft>
+            </a:pPr>
+            <a:r>
+              <a:rPr sz="1700">
+                <a:solidFill>
+                  <a:srgbClr val="0B1220"/>
+                </a:solidFill>
+                <a:latin typeface="Arial"/>
+              </a:rPr>
+              <a:t>•  Not adopted: one declared gate failed, so the serving model is unchanged.</a:t>
+            </a:r>
+          </a:p>
+          <a:p>
+            <a:pPr>
+              <a:spcAft>
+                <a:spcPts val="1000"/>
+              </a:spcAft>
+            </a:pPr>
+            <a:r>
+              <a:rPr sz="1700">
+                <a:solidFill>
+                  <a:srgbClr val="0B1220"/>
+                </a:solidFill>
+                <a:latin typeface="Arial"/>
+              </a:rPr>
+              <a:t>•  Previously inspected people: internal validation. Absolute errors are not comparable with D-052's; only the matched comparison is.</a:t>
             </a:r>
           </a:p>
         </p:txBody>

</xml_diff>

<commit_message>
docs: accurate research-screen narration (D-053/D-054 on slides 22-23, not in the app list); warning notice (48.4 % of all onsets >= 30 min ahead) beside detection in README, model card and slides 18/25; range and D-053 limits in the model card; slide 28 separates serving and research sources; recording checklist with the 02:00 switch; deck and PDFs regenerated
</commit_message>
<xml_diff>
--- a/docs/submission/GlucoTwin_Presentation.pptx
+++ b/docs/submission/GlucoTwin_Presentation.pptx
@@ -5805,7 +5805,7 @@
                 </a:solidFill>
                 <a:latin typeface="Arial"/>
               </a:rPr>
-              <a:t>•  60-min warning (test, margin threshold -10 mg/dL chosen on validation by F1): 61/64 new onsets detected, precision 0.60, 40 false alarms (1.49 per observed patient-day; 2.28 per eligible day); forecast lead median 30 min (episode start 30 min).</a:t>
+              <a:t>•  60-min warning (test, margin threshold -10 mg/dL chosen on validation by F1): 61/64 new onsets detected, precision 0.60, 40 false alarms (1.49 per observed patient-day; 2.28 per eligible day); forecast lead median 30 min among detected onsets (episode start 30 min). Detection is not notice: 48.4 % of all onsets were warned at least 30 min ahead.</a:t>
             </a:r>
           </a:p>
           <a:p>
@@ -7849,7 +7849,7 @@
                 </a:solidFill>
                 <a:latin typeface="Arial"/>
               </a:rPr>
-              <a:t>•  Personalization: small gains (-0.18 mg/dL and -0.33 mg/dL). Warnings: 61/64 onsets detected with 40 false alarms (1.49 per observed patient-day) — the F1 threshold rule ignores review workload.</a:t>
+              <a:t>•  Personalization: small gains (-0.18 mg/dL and -0.33 mg/dL). Warnings: 61/64 onsets detected with 40 false alarms (1.49 per observed patient-day); 48.4 % of all onsets warned at least 30 min ahead — the F1 threshold rule ignores review workload.</a:t>
             </a:r>
           </a:p>
           <a:p>
@@ -8583,7 +8583,7 @@
                 </a:solidFill>
                 <a:latin typeface="Arial"/>
               </a:rPr>
-              <a:t>•  All results: experiment gt-primary-2026-10-13-fusion, artifacts/experiments/…/metrics.json; reports/evaluation_report.md.</a:t>
+              <a:t>•  Serving results: experiment gt-primary-2026-10-13-fusion, reports/evaluation_report.md. Research (not served): README §7, docs/judge_guide.md, reports/constrained_study.md, reports/foundation_baseline.md, reports/two_hour_external.md. Every selected claim: reports/evidence_manifest.md.</a:t>
             </a:r>
           </a:p>
         </p:txBody>

</xml_diff>

<commit_message>
deck: trimmed to 15 slides (slides 1-5 byte-identical; 28-slide technical deck kept as backup); research workbook with 273 claims mapped to saved sources, study ledger, gate calculations and verification scope; narration, outline, README, judge guide and team index updated; final verification matrix (pytest 221/2 skips, vitest 141, e2e 29 + 4 + 3, parity 15,440/15,440, manifest 23/23, workbook 27/27, 133 links)
</commit_message>
<xml_diff>
--- a/docs/submission/GlucoTwin_Presentation.pptx
+++ b/docs/submission/GlucoTwin_Presentation.pptx
@@ -20,19 +20,6 @@
     <p:sldId id="268" r:id="rId19"/>
     <p:sldId id="269" r:id="rId20"/>
     <p:sldId id="270" r:id="rId21"/>
-    <p:sldId id="271" r:id="rId22"/>
-    <p:sldId id="272" r:id="rId23"/>
-    <p:sldId id="273" r:id="rId24"/>
-    <p:sldId id="274" r:id="rId25"/>
-    <p:sldId id="275" r:id="rId26"/>
-    <p:sldId id="276" r:id="rId27"/>
-    <p:sldId id="277" r:id="rId28"/>
-    <p:sldId id="278" r:id="rId29"/>
-    <p:sldId id="279" r:id="rId30"/>
-    <p:sldId id="280" r:id="rId31"/>
-    <p:sldId id="281" r:id="rId32"/>
-    <p:sldId id="282" r:id="rId33"/>
-    <p:sldId id="283" r:id="rId34"/>
   </p:sldIdLst>
   <p:sldSz cx="12191695" cy="6858000" type="screen4x3"/>
   <p:notesSz cx="6858000" cy="9144000"/>
@@ -3345,7 +3332,7 @@
                 </a:solidFill>
                 <a:latin typeface="Arial"/>
               </a:rPr>
-              <a:t>Fusion: what the profile adds, and what it does not show</a:t>
+              <a:t>Safety guardrails built into the twin</a:t>
             </a:r>
           </a:p>
         </p:txBody>
@@ -3439,7 +3426,7 @@
                 </a:solidFill>
                 <a:latin typeface="Arial"/>
               </a:rPr>
-              <a:t>•  The brief asks for a model that ingests static EHR-like data and dynamic wearable data. The demo model (LightGBM, dyn-prof-v2) reads 8 baseline profile values and 38 glucose and wearable features in one model.</a:t>
+              <a:t>•  Abstains instead of guessing: no forecast with under 60 min of history or no new reading; marked Stale after 15 min; weak inputs flagged Degraded, with the reason.</a:t>
             </a:r>
           </a:p>
           <a:p>
@@ -3455,7 +3442,7 @@
                 </a:solidFill>
                 <a:latin typeface="Arial"/>
               </a:rPr>
-              <a:t>•  Same 14 people, later days (test): profile minus dynamic-only -0.25 mg/dL [-0.43, -0.04] at 30 min and -0.61 mg/dL [-1.15, -0.09] at 60 min (negative = profile better). Profile values are constant per person, so here they can act as an identity code.</a:t>
+              <a:t>•  No input is used before it was available; the fusion model abstains when a health-record value is missing.</a:t>
             </a:r>
           </a:p>
           <a:p>
@@ -3471,7 +3458,7 @@
                 </a:solidFill>
                 <a:latin typeface="Arial"/>
               </a:rPr>
-              <a:t>•  People held out entirely (nested experiment): +0.34 [-0.28, +0.89] mg/dL at 30 min and -0.75 [-2.19, +0.61] mg/dL at 60 min — no reliable benefit for new people.</a:t>
+              <a:t>•  Patient correction: only from observed outcomes, needs 6, capped at ±25 mg/dL, reset after a 3-hour gap.</a:t>
             </a:r>
           </a:p>
           <a:p>
@@ -3487,7 +3474,7 @@
                 </a:solidFill>
                 <a:latin typeface="Arial"/>
               </a:rPr>
-              <a:t>•  Selection: the v2 rule applied only to profile + wearable models — a constraint declared on 2026-10-13, after the test segment had been inspected. Test MAE 12.96 / 20.26 mg/dL vs 13.15 / 20.81 for the dynamic-only model (gt-primary-2026-10-11-v2): retrospective, same people.</a:t>
+              <a:t>•  Warnings stay Outcome pending until they can be judged, then match an onset or count as a false alarm.</a:t>
             </a:r>
           </a:p>
           <a:p>
@@ -3503,7 +3490,7 @@
                 </a:solidFill>
                 <a:latin typeface="Arial"/>
               </a:rPr>
-              <a:t>•  Warnings: margin re-derived by the same F1 rule (-10 vs -30 mg/dL): 1.49 vs 2.95 false alarms per observed day, 61/64 vs 64/64 onsets, forecast lead median 30 vs 55 min. A threshold trade-off, not evidence that the profile helps.</a:t>
+              <a:t>•  80 % prediction ranges shown with measured coverage; not a medical device, no treatment advice.</a:t>
             </a:r>
           </a:p>
           <a:p>
@@ -3519,7 +3506,7 @@
                 </a:solidFill>
                 <a:latin typeface="Arial"/>
               </a:rPr>
-              <a:t>•  Our claim: we selected a model that implements the required fusion; we have not established that profile features improve forecasting for unseen patients.</a:t>
+              <a:t>•  Opened tests are locked; the app reproduced all 15,440 saved test forecasts within 0.05 mg/dL.</a:t>
             </a:r>
           </a:p>
         </p:txBody>
@@ -3579,7 +3566,7 @@
                 </a:solidFill>
                 <a:latin typeface="Arial"/>
               </a:rPr>
-              <a:t>Clinician workflow: the twin workspace</a:t>
+              <a:t>Results at a glance: three kinds of evidence, kept apart</a:t>
             </a:r>
           </a:p>
         </p:txBody>
@@ -3635,586 +3622,6 @@
                 <a:latin typeface="Arial"/>
               </a:rPr>
               <a:t>11</a:t>
-            </a:r>
-          </a:p>
-        </p:txBody>
-      </p:sp>
-      <p:pic>
-        <p:nvPicPr>
-          <p:cNvPr id="5" name="Picture 4" descr="03-forecast-with-interval-recorded.png"/>
-          <p:cNvPicPr>
-            <a:picLocks noChangeAspect="1"/>
-          </p:cNvPicPr>
-          <p:nvPr/>
-        </p:nvPicPr>
-        <p:blipFill>
-          <a:blip r:embed="rId2"/>
-          <a:stretch>
-            <a:fillRect/>
-          </a:stretch>
-        </p:blipFill>
-        <p:spPr>
-          <a:xfrm>
-            <a:off x="2438247" y="1188720"/>
-            <a:ext cx="7315200" cy="4572000"/>
-          </a:xfrm>
-          <a:prstGeom prst="rect">
-            <a:avLst/>
-          </a:prstGeom>
-        </p:spPr>
-      </p:pic>
-      <p:sp>
-        <p:nvSpPr>
-          <p:cNvPr id="6" name="TextBox 5"/>
-          <p:cNvSpPr txBox="1"/>
-          <p:nvPr/>
-        </p:nvSpPr>
-        <p:spPr>
-          <a:xfrm>
-            <a:off x="548640" y="5897880"/>
-            <a:ext cx="11064240" cy="822960"/>
-          </a:xfrm>
-          <a:prstGeom prst="rect">
-            <a:avLst/>
-          </a:prstGeom>
-          <a:noFill/>
-        </p:spPr>
-        <p:txBody>
-          <a:bodyPr wrap="square">
-            <a:spAutoFit/>
-          </a:bodyPr>
-          <a:lstStyle/>
-          <a:p>
-            <a:r>
-              <a:rPr sz="1300" b="0">
-                <a:solidFill>
-                  <a:srgbClr val="0B1220"/>
-                </a:solidFill>
-                <a:latin typeface="Arial"/>
-              </a:rPr>
-              <a:t>Recorded-data replay in the final test period (later recordings of participants the model was trained on): current glucose, 30/60-minute forecasts with prediction ranges (target coverage 80 %), saved earlier forecasts, research warnings with outcomes, review status and the live safety guardrails.</a:t>
-            </a:r>
-          </a:p>
-        </p:txBody>
-      </p:sp>
-    </p:spTree>
-  </p:cSld>
-  <p:clrMapOvr>
-    <a:masterClrMapping/>
-  </p:clrMapOvr>
-</p:sld>
-</file>
-
-<file path=ppt/slides/slide12.xml><?xml version="1.0" encoding="utf-8"?>
-<p:sld xmlns:a="http://schemas.openxmlformats.org/drawingml/2006/main" xmlns:p="http://schemas.openxmlformats.org/presentationml/2006/main" xmlns:r="http://schemas.openxmlformats.org/officeDocument/2006/relationships">
-  <p:cSld>
-    <p:bg>
-      <p:bgPr>
-        <a:solidFill>
-          <a:srgbClr val="FFFFFF"/>
-        </a:solidFill>
-        <a:effectLst/>
-      </p:bgPr>
-    </p:bg>
-    <p:spTree>
-      <p:nvGrpSpPr>
-        <p:cNvPr id="1" name=""/>
-        <p:cNvGrpSpPr/>
-        <p:nvPr/>
-      </p:nvGrpSpPr>
-      <p:grpSpPr/>
-      <p:sp>
-        <p:nvSpPr>
-          <p:cNvPr id="2" name="TextBox 1"/>
-          <p:cNvSpPr txBox="1"/>
-          <p:nvPr/>
-        </p:nvSpPr>
-        <p:spPr>
-          <a:xfrm>
-            <a:off x="548640" y="320040"/>
-            <a:ext cx="11064240" cy="640080"/>
-          </a:xfrm>
-          <a:prstGeom prst="rect">
-            <a:avLst/>
-          </a:prstGeom>
-          <a:noFill/>
-        </p:spPr>
-        <p:txBody>
-          <a:bodyPr wrap="square">
-            <a:spAutoFit/>
-          </a:bodyPr>
-          <a:lstStyle/>
-          <a:p>
-            <a:r>
-              <a:rPr sz="3000" b="1">
-                <a:solidFill>
-                  <a:srgbClr val="0B1220"/>
-                </a:solidFill>
-                <a:latin typeface="Arial"/>
-              </a:rPr>
-              <a:t>Demonstration: evidence behind a forecast</a:t>
-            </a:r>
-          </a:p>
-        </p:txBody>
-      </p:sp>
-      <p:cxnSp>
-        <p:nvCxnSpPr>
-          <p:cNvPr id="3" name="Connector 2"/>
-          <p:cNvCxnSpPr/>
-          <p:nvPr/>
-        </p:nvCxnSpPr>
-        <p:spPr>
-          <a:xfrm>
-            <a:off x="548640" y="987552"/>
-            <a:ext cx="11091672" cy="0"/>
-          </a:xfrm>
-          <a:prstGeom prst="line">
-            <a:avLst/>
-          </a:prstGeom>
-          <a:ln w="9525">
-            <a:solidFill>
-              <a:srgbClr val="E3E8EF"/>
-            </a:solidFill>
-          </a:ln>
-        </p:spPr>
-      </p:cxnSp>
-      <p:sp>
-        <p:nvSpPr>
-          <p:cNvPr id="4" name="TextBox 3"/>
-          <p:cNvSpPr txBox="1"/>
-          <p:nvPr/>
-        </p:nvSpPr>
-        <p:spPr>
-          <a:xfrm>
-            <a:off x="11247120" y="6446520"/>
-            <a:ext cx="457200" cy="274320"/>
-          </a:xfrm>
-          <a:prstGeom prst="rect">
-            <a:avLst/>
-          </a:prstGeom>
-          <a:noFill/>
-        </p:spPr>
-        <p:txBody>
-          <a:bodyPr wrap="square">
-            <a:spAutoFit/>
-          </a:bodyPr>
-          <a:lstStyle/>
-          <a:p>
-            <a:r>
-              <a:rPr sz="1100" b="0">
-                <a:solidFill>
-                  <a:srgbClr val="0B1220"/>
-                </a:solidFill>
-                <a:latin typeface="Arial"/>
-              </a:rPr>
-              <a:t>12</a:t>
-            </a:r>
-          </a:p>
-        </p:txBody>
-      </p:sp>
-      <p:pic>
-        <p:nvPicPr>
-          <p:cNvPr id="5" name="Picture 4" descr="04-forecast-evidence-dialog.png"/>
-          <p:cNvPicPr>
-            <a:picLocks noChangeAspect="1"/>
-          </p:cNvPicPr>
-          <p:nvPr/>
-        </p:nvPicPr>
-        <p:blipFill>
-          <a:blip r:embed="rId2"/>
-          <a:stretch>
-            <a:fillRect/>
-          </a:stretch>
-        </p:blipFill>
-        <p:spPr>
-          <a:xfrm>
-            <a:off x="2438247" y="1188720"/>
-            <a:ext cx="7315200" cy="4572000"/>
-          </a:xfrm>
-          <a:prstGeom prst="rect">
-            <a:avLst/>
-          </a:prstGeom>
-        </p:spPr>
-      </p:pic>
-      <p:sp>
-        <p:nvSpPr>
-          <p:cNvPr id="6" name="TextBox 5"/>
-          <p:cNvSpPr txBox="1"/>
-          <p:nvPr/>
-        </p:nvSpPr>
-        <p:spPr>
-          <a:xfrm>
-            <a:off x="548640" y="5897880"/>
-            <a:ext cx="11064240" cy="822960"/>
-          </a:xfrm>
-          <a:prstGeom prst="rect">
-            <a:avLst/>
-          </a:prstGeom>
-          <a:noFill/>
-        </p:spPr>
-        <p:txBody>
-          <a:bodyPr wrap="square">
-            <a:spAutoFit/>
-          </a:bodyPr>
-          <a:lstStyle/>
-          <a:p>
-            <a:r>
-              <a:rPr sz="1300" b="0">
-                <a:solidFill>
-                  <a:srgbClr val="0B1220"/>
-                </a:solidFill>
-                <a:latin typeface="Arial"/>
-              </a:rPr>
-              <a:t>Each forecast is immutable and inspectable: information cutoff, model version, evaluation segment, population forecast vs patient correction, factual explanations.</a:t>
-            </a:r>
-          </a:p>
-        </p:txBody>
-      </p:sp>
-    </p:spTree>
-  </p:cSld>
-  <p:clrMapOvr>
-    <a:masterClrMapping/>
-  </p:clrMapOvr>
-</p:sld>
-</file>
-
-<file path=ppt/slides/slide13.xml><?xml version="1.0" encoding="utf-8"?>
-<p:sld xmlns:a="http://schemas.openxmlformats.org/drawingml/2006/main" xmlns:p="http://schemas.openxmlformats.org/presentationml/2006/main" xmlns:r="http://schemas.openxmlformats.org/officeDocument/2006/relationships">
-  <p:cSld>
-    <p:bg>
-      <p:bgPr>
-        <a:solidFill>
-          <a:srgbClr val="FFFFFF"/>
-        </a:solidFill>
-        <a:effectLst/>
-      </p:bgPr>
-    </p:bg>
-    <p:spTree>
-      <p:nvGrpSpPr>
-        <p:cNvPr id="1" name=""/>
-        <p:cNvGrpSpPr/>
-        <p:nvPr/>
-      </p:nvGrpSpPr>
-      <p:grpSpPr/>
-      <p:sp>
-        <p:nvSpPr>
-          <p:cNvPr id="2" name="TextBox 1"/>
-          <p:cNvSpPr txBox="1"/>
-          <p:nvPr/>
-        </p:nvSpPr>
-        <p:spPr>
-          <a:xfrm>
-            <a:off x="548640" y="320040"/>
-            <a:ext cx="11064240" cy="640080"/>
-          </a:xfrm>
-          <a:prstGeom prst="rect">
-            <a:avLst/>
-          </a:prstGeom>
-          <a:noFill/>
-        </p:spPr>
-        <p:txBody>
-          <a:bodyPr wrap="square">
-            <a:spAutoFit/>
-          </a:bodyPr>
-          <a:lstStyle/>
-          <a:p>
-            <a:r>
-              <a:rPr sz="3000" b="1">
-                <a:solidFill>
-                  <a:srgbClr val="0B1220"/>
-                </a:solidFill>
-                <a:latin typeface="Arial"/>
-              </a:rPr>
-              <a:t>Safety guardrails built into the twin</a:t>
-            </a:r>
-          </a:p>
-        </p:txBody>
-      </p:sp>
-      <p:cxnSp>
-        <p:nvCxnSpPr>
-          <p:cNvPr id="3" name="Connector 2"/>
-          <p:cNvCxnSpPr/>
-          <p:nvPr/>
-        </p:nvCxnSpPr>
-        <p:spPr>
-          <a:xfrm>
-            <a:off x="548640" y="987552"/>
-            <a:ext cx="11091672" cy="0"/>
-          </a:xfrm>
-          <a:prstGeom prst="line">
-            <a:avLst/>
-          </a:prstGeom>
-          <a:ln w="9525">
-            <a:solidFill>
-              <a:srgbClr val="E3E8EF"/>
-            </a:solidFill>
-          </a:ln>
-        </p:spPr>
-      </p:cxnSp>
-      <p:sp>
-        <p:nvSpPr>
-          <p:cNvPr id="4" name="TextBox 3"/>
-          <p:cNvSpPr txBox="1"/>
-          <p:nvPr/>
-        </p:nvSpPr>
-        <p:spPr>
-          <a:xfrm>
-            <a:off x="11247120" y="6446520"/>
-            <a:ext cx="457200" cy="274320"/>
-          </a:xfrm>
-          <a:prstGeom prst="rect">
-            <a:avLst/>
-          </a:prstGeom>
-          <a:noFill/>
-        </p:spPr>
-        <p:txBody>
-          <a:bodyPr wrap="square">
-            <a:spAutoFit/>
-          </a:bodyPr>
-          <a:lstStyle/>
-          <a:p>
-            <a:r>
-              <a:rPr sz="1100" b="0">
-                <a:solidFill>
-                  <a:srgbClr val="0B1220"/>
-                </a:solidFill>
-                <a:latin typeface="Arial"/>
-              </a:rPr>
-              <a:t>13</a:t>
-            </a:r>
-          </a:p>
-        </p:txBody>
-      </p:sp>
-      <p:sp>
-        <p:nvSpPr>
-          <p:cNvPr id="5" name="TextBox 4"/>
-          <p:cNvSpPr txBox="1"/>
-          <p:nvPr/>
-        </p:nvSpPr>
-        <p:spPr>
-          <a:xfrm>
-            <a:off x="548640" y="1234440"/>
-            <a:ext cx="11064240" cy="5120640"/>
-          </a:xfrm>
-          <a:prstGeom prst="rect">
-            <a:avLst/>
-          </a:prstGeom>
-          <a:noFill/>
-        </p:spPr>
-        <p:txBody>
-          <a:bodyPr wrap="square">
-            <a:spAutoFit/>
-          </a:bodyPr>
-          <a:lstStyle/>
-          <a:p>
-            <a:pPr>
-              <a:spcAft>
-                <a:spcPts val="1000"/>
-              </a:spcAft>
-            </a:pPr>
-            <a:r>
-              <a:rPr sz="1700">
-                <a:solidFill>
-                  <a:srgbClr val="0B1220"/>
-                </a:solidFill>
-                <a:latin typeface="Arial"/>
-              </a:rPr>
-              <a:t>•  Abstains instead of guessing: no forecast with under 60 min of history, a sparse last hour or no new reading; after 15 min without one the last forecast is marked Stale. Weak inputs (gaps, sensor-limit readings, missing wearable data) are flagged Degraded, with the reason.</a:t>
-            </a:r>
-          </a:p>
-          <a:p>
-            <a:pPr>
-              <a:spcAft>
-                <a:spcPts val="1000"/>
-              </a:spcAft>
-            </a:pPr>
-            <a:r>
-              <a:rPr sz="1700">
-                <a:solidFill>
-                  <a:srgbClr val="0B1220"/>
-                </a:solidFill>
-                <a:latin typeface="Arial"/>
-              </a:rPr>
-              <a:t>•  The fusion model abstains when a health-record value is missing or not yet available; no input is used before the time it became available (native CGM readings only).</a:t>
-            </a:r>
-          </a:p>
-          <a:p>
-            <a:pPr>
-              <a:spcAft>
-                <a:spcPts val="1000"/>
-              </a:spcAft>
-            </a:pPr>
-            <a:r>
-              <a:rPr sz="1700">
-                <a:solidFill>
-                  <a:srgbClr val="0B1220"/>
-                </a:solidFill>
-                <a:latin typeface="Arial"/>
-              </a:rPr>
-              <a:t>•  Personal correction bounded: learns only from forecasts whose outcome was observed, needs 6, capped at ±25 mg/dL, resets after a 3-hour gap.</a:t>
-            </a:r>
-          </a:p>
-          <a:p>
-            <a:pPr>
-              <a:spcAft>
-                <a:spcPts val="1000"/>
-              </a:spcAft>
-            </a:pPr>
-            <a:r>
-              <a:rPr sz="1700">
-                <a:solidFill>
-                  <a:srgbClr val="0B1220"/>
-                </a:solidFill>
-                <a:latin typeface="Arial"/>
-              </a:rPr>
-              <a:t>•  Every warning is a labelled research warning: Outcome pending until it can be judged, then matched to an onset, counted as a false alarm or marked unknown; firings within 30 min merge into one episode.</a:t>
-            </a:r>
-          </a:p>
-          <a:p>
-            <a:pPr>
-              <a:spcAft>
-                <a:spcPts val="1000"/>
-              </a:spcAft>
-            </a:pPr>
-            <a:r>
-              <a:rPr sz="1700">
-                <a:solidFill>
-                  <a:srgbClr val="0B1220"/>
-                </a:solidFill>
-                <a:latin typeface="Arial"/>
-              </a:rPr>
-              <a:t>•  Uncertainty and limits shown: 80 % prediction ranges with measured coverage; not a medical device, no treatment advice, replay only.</a:t>
-            </a:r>
-          </a:p>
-          <a:p>
-            <a:pPr>
-              <a:spcAft>
-                <a:spcPts val="1000"/>
-              </a:spcAft>
-            </a:pPr>
-            <a:r>
-              <a:rPr sz="1700">
-                <a:solidFill>
-                  <a:srgbClr val="0B1220"/>
-                </a:solidFill>
-                <a:latin typeface="Arial"/>
-              </a:rPr>
-              <a:t>•  Evaluation cannot be quietly re-run: opened tests are locked; research runs cannot change the demo model; the app reproduced all 15,440 saved test forecasts within 0.05 mg/dL.</a:t>
-            </a:r>
-          </a:p>
-        </p:txBody>
-      </p:sp>
-    </p:spTree>
-  </p:cSld>
-  <p:clrMapOvr>
-    <a:masterClrMapping/>
-  </p:clrMapOvr>
-</p:sld>
-</file>
-
-<file path=ppt/slides/slide14.xml><?xml version="1.0" encoding="utf-8"?>
-<p:sld xmlns:a="http://schemas.openxmlformats.org/drawingml/2006/main" xmlns:p="http://schemas.openxmlformats.org/presentationml/2006/main" xmlns:r="http://schemas.openxmlformats.org/officeDocument/2006/relationships">
-  <p:cSld>
-    <p:bg>
-      <p:bgPr>
-        <a:solidFill>
-          <a:srgbClr val="FFFFFF"/>
-        </a:solidFill>
-        <a:effectLst/>
-      </p:bgPr>
-    </p:bg>
-    <p:spTree>
-      <p:nvGrpSpPr>
-        <p:cNvPr id="1" name=""/>
-        <p:cNvGrpSpPr/>
-        <p:nvPr/>
-      </p:nvGrpSpPr>
-      <p:grpSpPr/>
-      <p:sp>
-        <p:nvSpPr>
-          <p:cNvPr id="2" name="TextBox 1"/>
-          <p:cNvSpPr txBox="1"/>
-          <p:nvPr/>
-        </p:nvSpPr>
-        <p:spPr>
-          <a:xfrm>
-            <a:off x="548640" y="320040"/>
-            <a:ext cx="11064240" cy="640080"/>
-          </a:xfrm>
-          <a:prstGeom prst="rect">
-            <a:avLst/>
-          </a:prstGeom>
-          <a:noFill/>
-        </p:spPr>
-        <p:txBody>
-          <a:bodyPr wrap="square">
-            <a:spAutoFit/>
-          </a:bodyPr>
-          <a:lstStyle/>
-          <a:p>
-            <a:r>
-              <a:rPr sz="3000" b="1">
-                <a:solidFill>
-                  <a:srgbClr val="0B1220"/>
-                </a:solidFill>
-                <a:latin typeface="Arial"/>
-              </a:rPr>
-              <a:t>Results at a glance: three kinds of evidence, kept apart</a:t>
-            </a:r>
-          </a:p>
-        </p:txBody>
-      </p:sp>
-      <p:cxnSp>
-        <p:nvCxnSpPr>
-          <p:cNvPr id="3" name="Connector 2"/>
-          <p:cNvCxnSpPr/>
-          <p:nvPr/>
-        </p:nvCxnSpPr>
-        <p:spPr>
-          <a:xfrm>
-            <a:off x="548640" y="987552"/>
-            <a:ext cx="11091672" cy="0"/>
-          </a:xfrm>
-          <a:prstGeom prst="line">
-            <a:avLst/>
-          </a:prstGeom>
-          <a:ln w="9525">
-            <a:solidFill>
-              <a:srgbClr val="E3E8EF"/>
-            </a:solidFill>
-          </a:ln>
-        </p:spPr>
-      </p:cxnSp>
-      <p:sp>
-        <p:nvSpPr>
-          <p:cNvPr id="4" name="TextBox 3"/>
-          <p:cNvSpPr txBox="1"/>
-          <p:nvPr/>
-        </p:nvSpPr>
-        <p:spPr>
-          <a:xfrm>
-            <a:off x="11247120" y="6446520"/>
-            <a:ext cx="457200" cy="274320"/>
-          </a:xfrm>
-          <a:prstGeom prst="rect">
-            <a:avLst/>
-          </a:prstGeom>
-          <a:noFill/>
-        </p:spPr>
-        <p:txBody>
-          <a:bodyPr wrap="square">
-            <a:spAutoFit/>
-          </a:bodyPr>
-          <a:lstStyle/>
-          <a:p>
-            <a:r>
-              <a:rPr sz="1100" b="0">
-                <a:solidFill>
-                  <a:srgbClr val="0B1220"/>
-                </a:solidFill>
-                <a:latin typeface="Arial"/>
-              </a:rPr>
-              <a:t>14</a:t>
             </a:r>
           </a:p>
         </p:txBody>
@@ -4996,7 +4403,695 @@
                 </a:solidFill>
                 <a:latin typeface="Arial"/>
               </a:rPr>
-              <a:t>Mean absolute error in mg/dL, averaged equally over participants: an average error, not an accuracy percentage. Each group is a different model and a different test — do not compare across groups. Serving ranges (target 80 %) covered 74.2 % / 74.0 %: under-coverage. Research rows are read from each study's locked summary.</a:t>
+              <a:t>Mean absolute error in mg/dL (lower is better), averaged over participants. Each group is a different model and test — do not compare across groups. Serving ranges (target 80 %) covered 74.2 % / 74.0 %.</a:t>
+            </a:r>
+          </a:p>
+        </p:txBody>
+      </p:sp>
+    </p:spTree>
+  </p:cSld>
+  <p:clrMapOvr>
+    <a:masterClrMapping/>
+  </p:clrMapOvr>
+</p:sld>
+</file>
+
+<file path=ppt/slides/slide12.xml><?xml version="1.0" encoding="utf-8"?>
+<p:sld xmlns:a="http://schemas.openxmlformats.org/drawingml/2006/main" xmlns:p="http://schemas.openxmlformats.org/presentationml/2006/main" xmlns:r="http://schemas.openxmlformats.org/officeDocument/2006/relationships">
+  <p:cSld>
+    <p:bg>
+      <p:bgPr>
+        <a:solidFill>
+          <a:srgbClr val="FFFFFF"/>
+        </a:solidFill>
+        <a:effectLst/>
+      </p:bgPr>
+    </p:bg>
+    <p:spTree>
+      <p:nvGrpSpPr>
+        <p:cNvPr id="1" name=""/>
+        <p:cNvGrpSpPr/>
+        <p:nvPr/>
+      </p:nvGrpSpPr>
+      <p:grpSpPr/>
+      <p:sp>
+        <p:nvSpPr>
+          <p:cNvPr id="2" name="TextBox 1"/>
+          <p:cNvSpPr txBox="1"/>
+          <p:nvPr/>
+        </p:nvSpPr>
+        <p:spPr>
+          <a:xfrm>
+            <a:off x="548640" y="128016"/>
+            <a:ext cx="11064240" cy="274320"/>
+          </a:xfrm>
+          <a:prstGeom prst="rect">
+            <a:avLst/>
+          </a:prstGeom>
+          <a:noFill/>
+        </p:spPr>
+        <p:txBody>
+          <a:bodyPr wrap="square">
+            <a:spAutoFit/>
+          </a:bodyPr>
+          <a:lstStyle/>
+          <a:p>
+            <a:r>
+              <a:rPr sz="1100" b="1">
+                <a:solidFill>
+                  <a:srgbClr val="2563EB"/>
+                </a:solidFill>
+                <a:latin typeface="Arial"/>
+              </a:rPr>
+              <a:t>RESEARCH · 14 previously inspected people · internal comparison · CGM only · not served</a:t>
+            </a:r>
+          </a:p>
+        </p:txBody>
+      </p:sp>
+      <p:sp>
+        <p:nvSpPr>
+          <p:cNvPr id="3" name="TextBox 2"/>
+          <p:cNvSpPr txBox="1"/>
+          <p:nvPr/>
+        </p:nvSpPr>
+        <p:spPr>
+          <a:xfrm>
+            <a:off x="548640" y="384048"/>
+            <a:ext cx="11064240" cy="640080"/>
+          </a:xfrm>
+          <a:prstGeom prst="rect">
+            <a:avLst/>
+          </a:prstGeom>
+          <a:noFill/>
+        </p:spPr>
+        <p:txBody>
+          <a:bodyPr wrap="square">
+            <a:spAutoFit/>
+          </a:bodyPr>
+          <a:lstStyle/>
+          <a:p>
+            <a:r>
+              <a:rPr sz="3000" b="1">
+                <a:solidFill>
+                  <a:srgbClr val="0B1220"/>
+                </a:solidFill>
+                <a:latin typeface="Arial"/>
+              </a:rPr>
+              <a:t>Research: a zero-shot foundation-model baseline (D-054)</a:t>
+            </a:r>
+          </a:p>
+        </p:txBody>
+      </p:sp>
+      <p:cxnSp>
+        <p:nvCxnSpPr>
+          <p:cNvPr id="4" name="Connector 3"/>
+          <p:cNvCxnSpPr/>
+          <p:nvPr/>
+        </p:nvCxnSpPr>
+        <p:spPr>
+          <a:xfrm>
+            <a:off x="548640" y="987552"/>
+            <a:ext cx="11091672" cy="0"/>
+          </a:xfrm>
+          <a:prstGeom prst="line">
+            <a:avLst/>
+          </a:prstGeom>
+          <a:ln w="9525">
+            <a:solidFill>
+              <a:srgbClr val="E3E8EF"/>
+            </a:solidFill>
+          </a:ln>
+        </p:spPr>
+      </p:cxnSp>
+      <p:sp>
+        <p:nvSpPr>
+          <p:cNvPr id="5" name="TextBox 4"/>
+          <p:cNvSpPr txBox="1"/>
+          <p:nvPr/>
+        </p:nvSpPr>
+        <p:spPr>
+          <a:xfrm>
+            <a:off x="11247120" y="6446520"/>
+            <a:ext cx="457200" cy="274320"/>
+          </a:xfrm>
+          <a:prstGeom prst="rect">
+            <a:avLst/>
+          </a:prstGeom>
+          <a:noFill/>
+        </p:spPr>
+        <p:txBody>
+          <a:bodyPr wrap="square">
+            <a:spAutoFit/>
+          </a:bodyPr>
+          <a:lstStyle/>
+          <a:p>
+            <a:r>
+              <a:rPr sz="1100" b="0">
+                <a:solidFill>
+                  <a:srgbClr val="0B1220"/>
+                </a:solidFill>
+                <a:latin typeface="Arial"/>
+              </a:rPr>
+              <a:t>12</a:t>
+            </a:r>
+          </a:p>
+        </p:txBody>
+      </p:sp>
+      <p:sp>
+        <p:nvSpPr>
+          <p:cNvPr id="6" name="TextBox 5"/>
+          <p:cNvSpPr txBox="1"/>
+          <p:nvPr/>
+        </p:nvSpPr>
+        <p:spPr>
+          <a:xfrm>
+            <a:off x="548640" y="1234440"/>
+            <a:ext cx="11064240" cy="5120640"/>
+          </a:xfrm>
+          <a:prstGeom prst="rect">
+            <a:avLst/>
+          </a:prstGeom>
+          <a:noFill/>
+        </p:spPr>
+        <p:txBody>
+          <a:bodyPr wrap="square">
+            <a:spAutoFit/>
+          </a:bodyPr>
+          <a:lstStyle/>
+          <a:p>
+            <a:pPr>
+              <a:spcAft>
+                <a:spcPts val="1000"/>
+              </a:spcAft>
+            </a:pPr>
+            <a:r>
+              <a:rPr sz="1700">
+                <a:solidFill>
+                  <a:srgbClr val="0B1220"/>
+                </a:solidFill>
+                <a:latin typeface="Arial"/>
+              </a:rPr>
+              <a:t>•  amazon/chronos-bolt-tiny (8.7 M parameters, apache-2.0), zero-shot on CGM only. Not fine-tuned, not a fusion model, not served.</a:t>
+            </a:r>
+          </a:p>
+          <a:p>
+            <a:pPr>
+              <a:spcAft>
+                <a:spcPts val="1000"/>
+              </a:spcAft>
+            </a:pPr>
+            <a:r>
+              <a:rPr sz="1700">
+                <a:solidFill>
+                  <a:srgbClr val="0B1220"/>
+                </a:solidFill>
+                <a:latin typeface="Arial"/>
+              </a:rPr>
+              <a:t>•  Vs carrying the last reading forward: -0.79 [-1.01, -0.59] mg/dL at 30 min, -1.54 [-1.81, -1.30] at 60 min — lower for 14 of 14 people.</a:t>
+            </a:r>
+          </a:p>
+          <a:p>
+            <a:pPr>
+              <a:spcAft>
+                <a:spcPts val="1000"/>
+              </a:spcAft>
+            </a:pPr>
+            <a:r>
+              <a:rPr sz="1700">
+                <a:solidFill>
+                  <a:srgbClr val="0B1220"/>
+                </a:solidFill>
+                <a:latin typeface="Arial"/>
+              </a:rPr>
+              <a:t>•  Vs our serving recipe refitted per held-out person: +0.42 [-0.70, +1.47] mg/dL at 60 min (22.92 vs 22.50) — not better; worse above 180 mg/dL.</a:t>
+            </a:r>
+          </a:p>
+          <a:p>
+            <a:pPr>
+              <a:spcAft>
+                <a:spcPts val="1000"/>
+              </a:spcAft>
+            </a:pPr>
+            <a:r>
+              <a:rPr sz="1700">
+                <a:solidFill>
+                  <a:srgbClr val="0B1220"/>
+                </a:solidFill>
+                <a:latin typeface="Arial"/>
+              </a:rPr>
+              <a:t>•  Same 14 previously inspected people: an internal comparison. Its pretraining data may include public CGM recordings.</a:t>
+            </a:r>
+          </a:p>
+        </p:txBody>
+      </p:sp>
+    </p:spTree>
+  </p:cSld>
+  <p:clrMapOvr>
+    <a:masterClrMapping/>
+  </p:clrMapOvr>
+</p:sld>
+</file>
+
+<file path=ppt/slides/slide13.xml><?xml version="1.0" encoding="utf-8"?>
+<p:sld xmlns:a="http://schemas.openxmlformats.org/drawingml/2006/main" xmlns:p="http://schemas.openxmlformats.org/presentationml/2006/main" xmlns:r="http://schemas.openxmlformats.org/officeDocument/2006/relationships">
+  <p:cSld>
+    <p:bg>
+      <p:bgPr>
+        <a:solidFill>
+          <a:srgbClr val="FFFFFF"/>
+        </a:solidFill>
+        <a:effectLst/>
+      </p:bgPr>
+    </p:bg>
+    <p:spTree>
+      <p:nvGrpSpPr>
+        <p:cNvPr id="1" name=""/>
+        <p:cNvGrpSpPr/>
+        <p:nvPr/>
+      </p:nvGrpSpPr>
+      <p:grpSpPr/>
+      <p:sp>
+        <p:nvSpPr>
+          <p:cNvPr id="2" name="TextBox 1"/>
+          <p:cNvSpPr txBox="1"/>
+          <p:nvPr/>
+        </p:nvSpPr>
+        <p:spPr>
+          <a:xfrm>
+            <a:off x="548640" y="320040"/>
+            <a:ext cx="11064240" cy="640080"/>
+          </a:xfrm>
+          <a:prstGeom prst="rect">
+            <a:avLst/>
+          </a:prstGeom>
+          <a:noFill/>
+        </p:spPr>
+        <p:txBody>
+          <a:bodyPr wrap="square">
+            <a:spAutoFit/>
+          </a:bodyPr>
+          <a:lstStyle/>
+          <a:p>
+            <a:r>
+              <a:rPr sz="3000" b="1">
+                <a:solidFill>
+                  <a:srgbClr val="0B1220"/>
+                </a:solidFill>
+                <a:latin typeface="Arial"/>
+              </a:rPr>
+              <a:t>Project outcomes</a:t>
+            </a:r>
+          </a:p>
+        </p:txBody>
+      </p:sp>
+      <p:cxnSp>
+        <p:nvCxnSpPr>
+          <p:cNvPr id="3" name="Connector 2"/>
+          <p:cNvCxnSpPr/>
+          <p:nvPr/>
+        </p:nvCxnSpPr>
+        <p:spPr>
+          <a:xfrm>
+            <a:off x="548640" y="987552"/>
+            <a:ext cx="11091672" cy="0"/>
+          </a:xfrm>
+          <a:prstGeom prst="line">
+            <a:avLst/>
+          </a:prstGeom>
+          <a:ln w="9525">
+            <a:solidFill>
+              <a:srgbClr val="E3E8EF"/>
+            </a:solidFill>
+          </a:ln>
+        </p:spPr>
+      </p:cxnSp>
+      <p:sp>
+        <p:nvSpPr>
+          <p:cNvPr id="4" name="TextBox 3"/>
+          <p:cNvSpPr txBox="1"/>
+          <p:nvPr/>
+        </p:nvSpPr>
+        <p:spPr>
+          <a:xfrm>
+            <a:off x="11247120" y="6446520"/>
+            <a:ext cx="457200" cy="274320"/>
+          </a:xfrm>
+          <a:prstGeom prst="rect">
+            <a:avLst/>
+          </a:prstGeom>
+          <a:noFill/>
+        </p:spPr>
+        <p:txBody>
+          <a:bodyPr wrap="square">
+            <a:spAutoFit/>
+          </a:bodyPr>
+          <a:lstStyle/>
+          <a:p>
+            <a:r>
+              <a:rPr sz="1100" b="0">
+                <a:solidFill>
+                  <a:srgbClr val="0B1220"/>
+                </a:solidFill>
+                <a:latin typeface="Arial"/>
+              </a:rPr>
+              <a:t>13</a:t>
+            </a:r>
+          </a:p>
+        </p:txBody>
+      </p:sp>
+      <p:sp>
+        <p:nvSpPr>
+          <p:cNvPr id="5" name="TextBox 4"/>
+          <p:cNvSpPr txBox="1"/>
+          <p:nvPr/>
+        </p:nvSpPr>
+        <p:spPr>
+          <a:xfrm>
+            <a:off x="548640" y="1234440"/>
+            <a:ext cx="11064240" cy="5120640"/>
+          </a:xfrm>
+          <a:prstGeom prst="rect">
+            <a:avLst/>
+          </a:prstGeom>
+          <a:noFill/>
+        </p:spPr>
+        <p:txBody>
+          <a:bodyPr wrap="square">
+            <a:spAutoFit/>
+          </a:bodyPr>
+          <a:lstStyle/>
+          <a:p>
+            <a:pPr>
+              <a:spcAft>
+                <a:spcPts val="1000"/>
+              </a:spcAft>
+            </a:pPr>
+            <a:r>
+              <a:rPr sz="1700">
+                <a:solidFill>
+                  <a:srgbClr val="0B1220"/>
+                </a:solidFill>
+                <a:latin typeface="Arial"/>
+              </a:rPr>
+              <a:t>•  Built: a working glucose twin — replay API, immutable forecasts, warnings with outcomes — and a clinician workspace.</a:t>
+            </a:r>
+          </a:p>
+          <a:p>
+            <a:pPr>
+              <a:spcAft>
+                <a:spcPts val="1000"/>
+              </a:spcAft>
+            </a:pPr>
+            <a:r>
+              <a:rPr sz="1700">
+                <a:solidFill>
+                  <a:srgbClr val="0B1220"/>
+                </a:solidFill>
+                <a:latin typeface="Arial"/>
+              </a:rPr>
+              <a:t>•  Found: the published 1-minute CGM values are interpolated; we use only native 5-minute readings.</a:t>
+            </a:r>
+          </a:p>
+          <a:p>
+            <a:pPr>
+              <a:spcAft>
+                <a:spcPts val="1000"/>
+              </a:spcAft>
+            </a:pPr>
+            <a:r>
+              <a:rPr sz="1700">
+                <a:solidFill>
+                  <a:srgbClr val="0B1220"/>
+                </a:solidFill>
+                <a:latin typeface="Arial"/>
+              </a:rPr>
+              <a:t>•  Later recordings of the same 14 people: MAE 12.96 / 20.26 mg/dL vs persistence 14.84 / 23.23; better for 14/14 people at 30 min and 13/14 at 60 min.</a:t>
+            </a:r>
+          </a:p>
+          <a:p>
+            <a:pPr>
+              <a:spcAft>
+                <a:spcPts val="1000"/>
+              </a:spcAft>
+            </a:pPr>
+            <a:r>
+              <a:rPr sz="1700">
+                <a:solidFill>
+                  <a:srgbClr val="0B1220"/>
+                </a:solidFill>
+                <a:latin typeface="Arial"/>
+              </a:rPr>
+              <a:t>•  Warnings: 61/64 onsets detected, 1.49 false alarms per observed patient-day; 48.4 % of all onsets warned ≥ 30 min ahead.</a:t>
+            </a:r>
+          </a:p>
+          <a:p>
+            <a:pPr>
+              <a:spcAft>
+                <a:spcPts val="1000"/>
+              </a:spcAft>
+            </a:pPr>
+            <a:r>
+              <a:rPr sz="1700">
+                <a:solidFill>
+                  <a:srgbClr val="0B1220"/>
+                </a:solidFill>
+                <a:latin typeface="Arial"/>
+              </a:rPr>
+              <a:t>•  Reproducible: synthetic mode needs no download; results regenerate from versioned configs.</a:t>
+            </a:r>
+          </a:p>
+        </p:txBody>
+      </p:sp>
+    </p:spTree>
+  </p:cSld>
+  <p:clrMapOvr>
+    <a:masterClrMapping/>
+  </p:clrMapOvr>
+</p:sld>
+</file>
+
+<file path=ppt/slides/slide14.xml><?xml version="1.0" encoding="utf-8"?>
+<p:sld xmlns:a="http://schemas.openxmlformats.org/drawingml/2006/main" xmlns:p="http://schemas.openxmlformats.org/presentationml/2006/main" xmlns:r="http://schemas.openxmlformats.org/officeDocument/2006/relationships">
+  <p:cSld>
+    <p:bg>
+      <p:bgPr>
+        <a:solidFill>
+          <a:srgbClr val="FFFFFF"/>
+        </a:solidFill>
+        <a:effectLst/>
+      </p:bgPr>
+    </p:bg>
+    <p:spTree>
+      <p:nvGrpSpPr>
+        <p:cNvPr id="1" name=""/>
+        <p:cNvGrpSpPr/>
+        <p:nvPr/>
+      </p:nvGrpSpPr>
+      <p:grpSpPr/>
+      <p:sp>
+        <p:nvSpPr>
+          <p:cNvPr id="2" name="TextBox 1"/>
+          <p:cNvSpPr txBox="1"/>
+          <p:nvPr/>
+        </p:nvSpPr>
+        <p:spPr>
+          <a:xfrm>
+            <a:off x="548640" y="320040"/>
+            <a:ext cx="11064240" cy="640080"/>
+          </a:xfrm>
+          <a:prstGeom prst="rect">
+            <a:avLst/>
+          </a:prstGeom>
+          <a:noFill/>
+        </p:spPr>
+        <p:txBody>
+          <a:bodyPr wrap="square">
+            <a:spAutoFit/>
+          </a:bodyPr>
+          <a:lstStyle/>
+          <a:p>
+            <a:r>
+              <a:rPr sz="3000" b="1">
+                <a:solidFill>
+                  <a:srgbClr val="0B1220"/>
+                </a:solidFill>
+                <a:latin typeface="Arial"/>
+              </a:rPr>
+              <a:t>Limitations</a:t>
+            </a:r>
+          </a:p>
+        </p:txBody>
+      </p:sp>
+      <p:cxnSp>
+        <p:nvCxnSpPr>
+          <p:cNvPr id="3" name="Connector 2"/>
+          <p:cNvCxnSpPr/>
+          <p:nvPr/>
+        </p:nvCxnSpPr>
+        <p:spPr>
+          <a:xfrm>
+            <a:off x="548640" y="987552"/>
+            <a:ext cx="11091672" cy="0"/>
+          </a:xfrm>
+          <a:prstGeom prst="line">
+            <a:avLst/>
+          </a:prstGeom>
+          <a:ln w="9525">
+            <a:solidFill>
+              <a:srgbClr val="E3E8EF"/>
+            </a:solidFill>
+          </a:ln>
+        </p:spPr>
+      </p:cxnSp>
+      <p:sp>
+        <p:nvSpPr>
+          <p:cNvPr id="4" name="TextBox 3"/>
+          <p:cNvSpPr txBox="1"/>
+          <p:nvPr/>
+        </p:nvSpPr>
+        <p:spPr>
+          <a:xfrm>
+            <a:off x="11247120" y="6446520"/>
+            <a:ext cx="457200" cy="274320"/>
+          </a:xfrm>
+          <a:prstGeom prst="rect">
+            <a:avLst/>
+          </a:prstGeom>
+          <a:noFill/>
+        </p:spPr>
+        <p:txBody>
+          <a:bodyPr wrap="square">
+            <a:spAutoFit/>
+          </a:bodyPr>
+          <a:lstStyle/>
+          <a:p>
+            <a:r>
+              <a:rPr sz="1100" b="0">
+                <a:solidFill>
+                  <a:srgbClr val="0B1220"/>
+                </a:solidFill>
+                <a:latin typeface="Arial"/>
+              </a:rPr>
+              <a:t>14</a:t>
+            </a:r>
+          </a:p>
+        </p:txBody>
+      </p:sp>
+      <p:sp>
+        <p:nvSpPr>
+          <p:cNvPr id="5" name="TextBox 4"/>
+          <p:cNvSpPr txBox="1"/>
+          <p:nvPr/>
+        </p:nvSpPr>
+        <p:spPr>
+          <a:xfrm>
+            <a:off x="548640" y="1234440"/>
+            <a:ext cx="11064240" cy="5120640"/>
+          </a:xfrm>
+          <a:prstGeom prst="rect">
+            <a:avLst/>
+          </a:prstGeom>
+          <a:noFill/>
+        </p:spPr>
+        <p:txBody>
+          <a:bodyPr wrap="square">
+            <a:spAutoFit/>
+          </a:bodyPr>
+          <a:lstStyle/>
+          <a:p>
+            <a:pPr>
+              <a:spcAft>
+                <a:spcPts val="1000"/>
+              </a:spcAft>
+            </a:pPr>
+            <a:r>
+              <a:rPr sz="1700">
+                <a:solidFill>
+                  <a:srgbClr val="0B1220"/>
+                </a:solidFill>
+                <a:latin typeface="Arial"/>
+              </a:rPr>
+              <a:t>•  14 participants from one US site; no Indian participants.</a:t>
+            </a:r>
+          </a:p>
+          <a:p>
+            <a:pPr>
+              <a:spcAft>
+                <a:spcPts val="1000"/>
+              </a:spcAft>
+            </a:pPr>
+            <a:r>
+              <a:rPr sz="1700">
+                <a:solidFill>
+                  <a:srgbClr val="0B1220"/>
+                </a:solidFill>
+                <a:latin typeface="Arial"/>
+              </a:rPr>
+              <a:t>•  Blinded CGMs replayed with assumed zero latency; medication and meal timing unknown.</a:t>
+            </a:r>
+          </a:p>
+          <a:p>
+            <a:pPr>
+              <a:spcAft>
+                <a:spcPts val="1000"/>
+              </a:spcAft>
+            </a:pPr>
+            <a:r>
+              <a:rPr sz="1700">
+                <a:solidFill>
+                  <a:srgbClr val="0B1220"/>
+                </a:solidFill>
+                <a:latin typeface="Arial"/>
+              </a:rPr>
+              <a:t>•  Profile values are constant per person; no benefit shown for people held out entirely.</a:t>
+            </a:r>
+          </a:p>
+          <a:p>
+            <a:pPr>
+              <a:spcAft>
+                <a:spcPts val="1000"/>
+              </a:spcAft>
+            </a:pPr>
+            <a:r>
+              <a:rPr sz="1700">
+                <a:solidFill>
+                  <a:srgbClr val="0B1220"/>
+                </a:solidFill>
+                <a:latin typeface="Arial"/>
+              </a:rPr>
+              <a:t>•  Ranges under-cover (74.2 % / 74.0 % vs 80 % target); the warning threshold ignores review workload.</a:t>
+            </a:r>
+          </a:p>
+          <a:p>
+            <a:pPr>
+              <a:spcAft>
+                <a:spcPts val="1000"/>
+              </a:spcAft>
+            </a:pPr>
+            <a:r>
+              <a:rPr sz="1700">
+                <a:solidFill>
+                  <a:srgbClr val="0B1220"/>
+                </a:solidFill>
+                <a:latin typeface="Arial"/>
+              </a:rPr>
+              <a:t>•  Retrospective replay only — no clinical, workflow or safety study.</a:t>
+            </a:r>
+          </a:p>
+          <a:p>
+            <a:pPr>
+              <a:spcAft>
+                <a:spcPts val="1000"/>
+              </a:spcAft>
+            </a:pPr>
+            <a:r>
+              <a:rPr sz="1700">
+                <a:solidFill>
+                  <a:srgbClr val="0B1220"/>
+                </a:solidFill>
+                <a:latin typeface="Arial"/>
+              </a:rPr>
+              <a:t>•  Next: a prospective, consented Indian cohort and a full-fusion evaluation on new people.</a:t>
             </a:r>
           </a:p>
         </p:txBody>
@@ -5035,8 +5130,8 @@
         </p:nvSpPr>
         <p:spPr>
           <a:xfrm>
-            <a:off x="548640" y="128016"/>
-            <a:ext cx="11064240" cy="274320"/>
+            <a:off x="548640" y="320040"/>
+            <a:ext cx="11064240" cy="640080"/>
           </a:xfrm>
           <a:prstGeom prst="rect">
             <a:avLst/>
@@ -5050,54 +5145,20 @@
           <a:lstStyle/>
           <a:p>
             <a:r>
-              <a:rPr sz="1100" b="1">
-                <a:solidFill>
-                  <a:srgbClr val="2563EB"/>
-                </a:solidFill>
-                <a:latin typeface="Arial"/>
-              </a:rPr>
-              <a:t>SERVING MODEL · later recordings of the same 14 participants it was trained on — not new people</a:t>
-            </a:r>
-          </a:p>
-        </p:txBody>
-      </p:sp>
-      <p:sp>
-        <p:nvSpPr>
-          <p:cNvPr id="3" name="TextBox 2"/>
-          <p:cNvSpPr txBox="1"/>
-          <p:nvPr/>
-        </p:nvSpPr>
-        <p:spPr>
-          <a:xfrm>
-            <a:off x="548640" y="384048"/>
-            <a:ext cx="11064240" cy="640080"/>
-          </a:xfrm>
-          <a:prstGeom prst="rect">
-            <a:avLst/>
-          </a:prstGeom>
-          <a:noFill/>
-        </p:spPr>
-        <p:txBody>
-          <a:bodyPr wrap="square">
-            <a:spAutoFit/>
-          </a:bodyPr>
-          <a:lstStyle/>
-          <a:p>
-            <a:r>
               <a:rPr sz="3000" b="1">
                 <a:solidFill>
                   <a:srgbClr val="0B1220"/>
                 </a:solidFill>
                 <a:latin typeface="Arial"/>
               </a:rPr>
-              <a:t>Measured evaluation: forecast accuracy (later days)</a:t>
+              <a:t>Team, links, reproducibility and licenses</a:t>
             </a:r>
           </a:p>
         </p:txBody>
       </p:sp>
       <p:cxnSp>
         <p:nvCxnSpPr>
-          <p:cNvPr id="4" name="Connector 3"/>
+          <p:cNvPr id="3" name="Connector 2"/>
           <p:cNvCxnSpPr/>
           <p:nvPr/>
         </p:nvCxnSpPr>
@@ -5118,7 +5179,7 @@
       </p:cxnSp>
       <p:sp>
         <p:nvSpPr>
-          <p:cNvPr id="5" name="TextBox 4"/>
+          <p:cNvPr id="4" name="TextBox 3"/>
           <p:cNvSpPr txBox="1"/>
           <p:nvPr/>
         </p:nvSpPr>
@@ -5150,630 +5211,9 @@
           </a:p>
         </p:txBody>
       </p:sp>
-      <p:pic>
-        <p:nvPicPr>
-          <p:cNvPr id="6" name="Picture 5" descr="fig_mae_test.png"/>
-          <p:cNvPicPr>
-            <a:picLocks noChangeAspect="1"/>
-          </p:cNvPicPr>
-          <p:nvPr/>
-        </p:nvPicPr>
-        <p:blipFill>
-          <a:blip r:embed="rId2"/>
-          <a:stretch>
-            <a:fillRect/>
-          </a:stretch>
-        </p:blipFill>
-        <p:spPr>
-          <a:xfrm>
-            <a:off x="548640" y="1188720"/>
-            <a:ext cx="11064240" cy="3964640"/>
-          </a:xfrm>
-          <a:prstGeom prst="rect">
-            <a:avLst/>
-          </a:prstGeom>
-        </p:spPr>
-      </p:pic>
-      <p:sp>
-        <p:nvSpPr>
-          <p:cNvPr id="7" name="TextBox 6"/>
-          <p:cNvSpPr txBox="1"/>
-          <p:nvPr/>
-        </p:nvSpPr>
-        <p:spPr>
-          <a:xfrm>
-            <a:off x="548640" y="5897880"/>
-            <a:ext cx="11064240" cy="822960"/>
-          </a:xfrm>
-          <a:prstGeom prst="rect">
-            <a:avLst/>
-          </a:prstGeom>
-          <a:noFill/>
-        </p:spPr>
-        <p:txBody>
-          <a:bodyPr wrap="square">
-            <a:spAutoFit/>
-          </a:bodyPr>
-          <a:lstStyle/>
-          <a:p>
-            <a:r>
-              <a:rPr sz="1300" b="0">
-                <a:solidFill>
-                  <a:srgbClr val="0B1220"/>
-                </a:solidFill>
-                <a:latin typeface="Arial"/>
-              </a:rPr>
-              <a:t>Later recordings of the same 14 participants the model was trained on — not new patients. Serving − persistence: -1.88 mg/dL [-2.53, -1.32] at 30 min, -2.96 mg/dL [-4.34, -1.77] at 60 min. Test origins 7,730 (≈ 644 h); forecasts issued for 99.9 % of origins with a target.</a:t>
-            </a:r>
-          </a:p>
-        </p:txBody>
-      </p:sp>
-    </p:spTree>
-  </p:cSld>
-  <p:clrMapOvr>
-    <a:masterClrMapping/>
-  </p:clrMapOvr>
-</p:sld>
-</file>
-
-<file path=ppt/slides/slide16.xml><?xml version="1.0" encoding="utf-8"?>
-<p:sld xmlns:a="http://schemas.openxmlformats.org/drawingml/2006/main" xmlns:p="http://schemas.openxmlformats.org/presentationml/2006/main" xmlns:r="http://schemas.openxmlformats.org/officeDocument/2006/relationships">
-  <p:cSld>
-    <p:bg>
-      <p:bgPr>
-        <a:solidFill>
-          <a:srgbClr val="FFFFFF"/>
-        </a:solidFill>
-        <a:effectLst/>
-      </p:bgPr>
-    </p:bg>
-    <p:spTree>
-      <p:nvGrpSpPr>
-        <p:cNvPr id="1" name=""/>
-        <p:cNvGrpSpPr/>
-        <p:nvPr/>
-      </p:nvGrpSpPr>
-      <p:grpSpPr/>
-      <p:sp>
-        <p:nvSpPr>
-          <p:cNvPr id="2" name="TextBox 1"/>
-          <p:cNvSpPr txBox="1"/>
-          <p:nvPr/>
-        </p:nvSpPr>
-        <p:spPr>
-          <a:xfrm>
-            <a:off x="548640" y="128016"/>
-            <a:ext cx="11064240" cy="274320"/>
-          </a:xfrm>
-          <a:prstGeom prst="rect">
-            <a:avLst/>
-          </a:prstGeom>
-          <a:noFill/>
-        </p:spPr>
-        <p:txBody>
-          <a:bodyPr wrap="square">
-            <a:spAutoFit/>
-          </a:bodyPr>
-          <a:lstStyle/>
-          <a:p>
-            <a:r>
-              <a:rPr sz="1100" b="1">
-                <a:solidFill>
-                  <a:srgbClr val="2563EB"/>
-                </a:solidFill>
-                <a:latin typeface="Arial"/>
-              </a:rPr>
-              <a:t>SERVING MODEL · later recordings of the same 14 participants it was trained on — not new people</a:t>
-            </a:r>
-          </a:p>
-        </p:txBody>
-      </p:sp>
-      <p:sp>
-        <p:nvSpPr>
-          <p:cNvPr id="3" name="TextBox 2"/>
-          <p:cNvSpPr txBox="1"/>
-          <p:nvPr/>
-        </p:nvSpPr>
-        <p:spPr>
-          <a:xfrm>
-            <a:off x="548640" y="384048"/>
-            <a:ext cx="11064240" cy="640080"/>
-          </a:xfrm>
-          <a:prstGeom prst="rect">
-            <a:avLst/>
-          </a:prstGeom>
-          <a:noFill/>
-        </p:spPr>
-        <p:txBody>
-          <a:bodyPr wrap="square">
-            <a:spAutoFit/>
-          </a:bodyPr>
-          <a:lstStyle/>
-          <a:p>
-            <a:r>
-              <a:rPr sz="3000" b="1">
-                <a:solidFill>
-                  <a:srgbClr val="0B1220"/>
-                </a:solidFill>
-                <a:latin typeface="Arial"/>
-              </a:rPr>
-              <a:t>Measured evaluation: does personalization help?</a:t>
-            </a:r>
-          </a:p>
-        </p:txBody>
-      </p:sp>
-      <p:cxnSp>
-        <p:nvCxnSpPr>
-          <p:cNvPr id="4" name="Connector 3"/>
-          <p:cNvCxnSpPr/>
-          <p:nvPr/>
-        </p:nvCxnSpPr>
-        <p:spPr>
-          <a:xfrm>
-            <a:off x="548640" y="987552"/>
-            <a:ext cx="11091672" cy="0"/>
-          </a:xfrm>
-          <a:prstGeom prst="line">
-            <a:avLst/>
-          </a:prstGeom>
-          <a:ln w="9525">
-            <a:solidFill>
-              <a:srgbClr val="E3E8EF"/>
-            </a:solidFill>
-          </a:ln>
-        </p:spPr>
-      </p:cxnSp>
       <p:sp>
         <p:nvSpPr>
           <p:cNvPr id="5" name="TextBox 4"/>
-          <p:cNvSpPr txBox="1"/>
-          <p:nvPr/>
-        </p:nvSpPr>
-        <p:spPr>
-          <a:xfrm>
-            <a:off x="11247120" y="6446520"/>
-            <a:ext cx="457200" cy="274320"/>
-          </a:xfrm>
-          <a:prstGeom prst="rect">
-            <a:avLst/>
-          </a:prstGeom>
-          <a:noFill/>
-        </p:spPr>
-        <p:txBody>
-          <a:bodyPr wrap="square">
-            <a:spAutoFit/>
-          </a:bodyPr>
-          <a:lstStyle/>
-          <a:p>
-            <a:r>
-              <a:rPr sz="1100" b="0">
-                <a:solidFill>
-                  <a:srgbClr val="0B1220"/>
-                </a:solidFill>
-                <a:latin typeface="Arial"/>
-              </a:rPr>
-              <a:t>16</a:t>
-            </a:r>
-          </a:p>
-        </p:txBody>
-      </p:sp>
-      <p:pic>
-        <p:nvPicPr>
-          <p:cNvPr id="6" name="Picture 5" descr="fig_paired_differences.png"/>
-          <p:cNvPicPr>
-            <a:picLocks noChangeAspect="1"/>
-          </p:cNvPicPr>
-          <p:nvPr/>
-        </p:nvPicPr>
-        <p:blipFill>
-          <a:blip r:embed="rId2"/>
-          <a:stretch>
-            <a:fillRect/>
-          </a:stretch>
-        </p:blipFill>
-        <p:spPr>
-          <a:xfrm>
-            <a:off x="548640" y="1188720"/>
-            <a:ext cx="11064240" cy="3201781"/>
-          </a:xfrm>
-          <a:prstGeom prst="rect">
-            <a:avLst/>
-          </a:prstGeom>
-        </p:spPr>
-      </p:pic>
-      <p:sp>
-        <p:nvSpPr>
-          <p:cNvPr id="7" name="TextBox 6"/>
-          <p:cNvSpPr txBox="1"/>
-          <p:nvPr/>
-        </p:nvSpPr>
-        <p:spPr>
-          <a:xfrm>
-            <a:off x="548640" y="5897880"/>
-            <a:ext cx="11064240" cy="822960"/>
-          </a:xfrm>
-          <a:prstGeom prst="rect">
-            <a:avLst/>
-          </a:prstGeom>
-          <a:noFill/>
-        </p:spPr>
-        <p:txBody>
-          <a:bodyPr wrap="square">
-            <a:spAutoFit/>
-          </a:bodyPr>
-          <a:lstStyle/>
-          <a:p>
-            <a:r>
-              <a:rPr sz="1300" b="0">
-                <a:solidFill>
-                  <a:srgbClr val="0B1220"/>
-                </a:solidFill>
-                <a:latin typeface="Arial"/>
-              </a:rPr>
-              <a:t>Adaptation (LightGBM): -0.18 mg/dL [-0.35, -0.01] at 30 min, -0.33 mg/dL [-0.68, 0.02] at 60 min — small; population 13.14 / 20.59, frozen state 13.19 / 20.65, adaptive 12.96 / 20.26 mg/dL. New-participant cold start: 14.66/24.26 → 13.81/22.12 mg/dL with adaptation.</a:t>
-            </a:r>
-          </a:p>
-        </p:txBody>
-      </p:sp>
-    </p:spTree>
-  </p:cSld>
-  <p:clrMapOvr>
-    <a:masterClrMapping/>
-  </p:clrMapOvr>
-</p:sld>
-</file>
-
-<file path=ppt/slides/slide17.xml><?xml version="1.0" encoding="utf-8"?>
-<p:sld xmlns:a="http://schemas.openxmlformats.org/drawingml/2006/main" xmlns:p="http://schemas.openxmlformats.org/presentationml/2006/main" xmlns:r="http://schemas.openxmlformats.org/officeDocument/2006/relationships">
-  <p:cSld>
-    <p:bg>
-      <p:bgPr>
-        <a:solidFill>
-          <a:srgbClr val="FFFFFF"/>
-        </a:solidFill>
-        <a:effectLst/>
-      </p:bgPr>
-    </p:bg>
-    <p:spTree>
-      <p:nvGrpSpPr>
-        <p:cNvPr id="1" name=""/>
-        <p:cNvGrpSpPr/>
-        <p:nvPr/>
-      </p:nvGrpSpPr>
-      <p:grpSpPr/>
-      <p:sp>
-        <p:nvSpPr>
-          <p:cNvPr id="2" name="TextBox 1"/>
-          <p:cNvSpPr txBox="1"/>
-          <p:nvPr/>
-        </p:nvSpPr>
-        <p:spPr>
-          <a:xfrm>
-            <a:off x="548640" y="128016"/>
-            <a:ext cx="11064240" cy="274320"/>
-          </a:xfrm>
-          <a:prstGeom prst="rect">
-            <a:avLst/>
-          </a:prstGeom>
-          <a:noFill/>
-        </p:spPr>
-        <p:txBody>
-          <a:bodyPr wrap="square">
-            <a:spAutoFit/>
-          </a:bodyPr>
-          <a:lstStyle/>
-          <a:p>
-            <a:r>
-              <a:rPr sz="1100" b="1">
-                <a:solidFill>
-                  <a:srgbClr val="2563EB"/>
-                </a:solidFill>
-                <a:latin typeface="Arial"/>
-              </a:rPr>
-              <a:t>SERVING MODEL · later recordings of the same 14 participants it was trained on — not new people</a:t>
-            </a:r>
-          </a:p>
-        </p:txBody>
-      </p:sp>
-      <p:sp>
-        <p:nvSpPr>
-          <p:cNvPr id="3" name="TextBox 2"/>
-          <p:cNvSpPr txBox="1"/>
-          <p:nvPr/>
-        </p:nvSpPr>
-        <p:spPr>
-          <a:xfrm>
-            <a:off x="548640" y="384048"/>
-            <a:ext cx="11064240" cy="640080"/>
-          </a:xfrm>
-          <a:prstGeom prst="rect">
-            <a:avLst/>
-          </a:prstGeom>
-          <a:noFill/>
-        </p:spPr>
-        <p:txBody>
-          <a:bodyPr wrap="square">
-            <a:spAutoFit/>
-          </a:bodyPr>
-          <a:lstStyle/>
-          <a:p>
-            <a:r>
-              <a:rPr sz="3000" b="1">
-                <a:solidFill>
-                  <a:srgbClr val="0B1220"/>
-                </a:solidFill>
-                <a:latin typeface="Arial"/>
-              </a:rPr>
-              <a:t>Measured evaluation: every participant</a:t>
-            </a:r>
-          </a:p>
-        </p:txBody>
-      </p:sp>
-      <p:cxnSp>
-        <p:nvCxnSpPr>
-          <p:cNvPr id="4" name="Connector 3"/>
-          <p:cNvCxnSpPr/>
-          <p:nvPr/>
-        </p:nvCxnSpPr>
-        <p:spPr>
-          <a:xfrm>
-            <a:off x="548640" y="987552"/>
-            <a:ext cx="11091672" cy="0"/>
-          </a:xfrm>
-          <a:prstGeom prst="line">
-            <a:avLst/>
-          </a:prstGeom>
-          <a:ln w="9525">
-            <a:solidFill>
-              <a:srgbClr val="E3E8EF"/>
-            </a:solidFill>
-          </a:ln>
-        </p:spPr>
-      </p:cxnSp>
-      <p:sp>
-        <p:nvSpPr>
-          <p:cNvPr id="5" name="TextBox 4"/>
-          <p:cNvSpPr txBox="1"/>
-          <p:nvPr/>
-        </p:nvSpPr>
-        <p:spPr>
-          <a:xfrm>
-            <a:off x="11247120" y="6446520"/>
-            <a:ext cx="457200" cy="274320"/>
-          </a:xfrm>
-          <a:prstGeom prst="rect">
-            <a:avLst/>
-          </a:prstGeom>
-          <a:noFill/>
-        </p:spPr>
-        <p:txBody>
-          <a:bodyPr wrap="square">
-            <a:spAutoFit/>
-          </a:bodyPr>
-          <a:lstStyle/>
-          <a:p>
-            <a:r>
-              <a:rPr sz="1100" b="0">
-                <a:solidFill>
-                  <a:srgbClr val="0B1220"/>
-                </a:solidFill>
-                <a:latin typeface="Arial"/>
-              </a:rPr>
-              <a:t>17</a:t>
-            </a:r>
-          </a:p>
-        </p:txBody>
-      </p:sp>
-      <p:pic>
-        <p:nvPicPr>
-          <p:cNvPr id="6" name="Picture 5" descr="fig_per_participant.png"/>
-          <p:cNvPicPr>
-            <a:picLocks noChangeAspect="1"/>
-          </p:cNvPicPr>
-          <p:nvPr/>
-        </p:nvPicPr>
-        <p:blipFill>
-          <a:blip r:embed="rId2"/>
-          <a:stretch>
-            <a:fillRect/>
-          </a:stretch>
-        </p:blipFill>
-        <p:spPr>
-          <a:xfrm>
-            <a:off x="926817" y="1188720"/>
-            <a:ext cx="10338061" cy="4572000"/>
-          </a:xfrm>
-          <a:prstGeom prst="rect">
-            <a:avLst/>
-          </a:prstGeom>
-        </p:spPr>
-      </p:pic>
-      <p:sp>
-        <p:nvSpPr>
-          <p:cNvPr id="7" name="TextBox 6"/>
-          <p:cNvSpPr txBox="1"/>
-          <p:nvPr/>
-        </p:nvSpPr>
-        <p:spPr>
-          <a:xfrm>
-            <a:off x="548640" y="5897880"/>
-            <a:ext cx="11064240" cy="822960"/>
-          </a:xfrm>
-          <a:prstGeom prst="rect">
-            <a:avLst/>
-          </a:prstGeom>
-          <a:noFill/>
-        </p:spPr>
-        <p:txBody>
-          <a:bodyPr wrap="square">
-            <a:spAutoFit/>
-          </a:bodyPr>
-          <a:lstStyle/>
-          <a:p>
-            <a:r>
-              <a:rPr sz="1300" b="0">
-                <a:solidFill>
-                  <a:srgbClr val="0B1220"/>
-                </a:solidFill>
-                <a:latin typeface="Arial"/>
-              </a:rPr>
-              <a:t>Per-participant test MAE, persistence vs the serving pipeline. Gains are uneven: large for some participants, none for a few at 60 minutes. Fourteen people cannot establish population-level performance.</a:t>
-            </a:r>
-          </a:p>
-        </p:txBody>
-      </p:sp>
-    </p:spTree>
-  </p:cSld>
-  <p:clrMapOvr>
-    <a:masterClrMapping/>
-  </p:clrMapOvr>
-</p:sld>
-</file>
-
-<file path=ppt/slides/slide18.xml><?xml version="1.0" encoding="utf-8"?>
-<p:sld xmlns:a="http://schemas.openxmlformats.org/drawingml/2006/main" xmlns:p="http://schemas.openxmlformats.org/presentationml/2006/main" xmlns:r="http://schemas.openxmlformats.org/officeDocument/2006/relationships">
-  <p:cSld>
-    <p:bg>
-      <p:bgPr>
-        <a:solidFill>
-          <a:srgbClr val="FFFFFF"/>
-        </a:solidFill>
-        <a:effectLst/>
-      </p:bgPr>
-    </p:bg>
-    <p:spTree>
-      <p:nvGrpSpPr>
-        <p:cNvPr id="1" name=""/>
-        <p:cNvGrpSpPr/>
-        <p:nvPr/>
-      </p:nvGrpSpPr>
-      <p:grpSpPr/>
-      <p:sp>
-        <p:nvSpPr>
-          <p:cNvPr id="2" name="TextBox 1"/>
-          <p:cNvSpPr txBox="1"/>
-          <p:nvPr/>
-        </p:nvSpPr>
-        <p:spPr>
-          <a:xfrm>
-            <a:off x="548640" y="128016"/>
-            <a:ext cx="11064240" cy="274320"/>
-          </a:xfrm>
-          <a:prstGeom prst="rect">
-            <a:avLst/>
-          </a:prstGeom>
-          <a:noFill/>
-        </p:spPr>
-        <p:txBody>
-          <a:bodyPr wrap="square">
-            <a:spAutoFit/>
-          </a:bodyPr>
-          <a:lstStyle/>
-          <a:p>
-            <a:r>
-              <a:rPr sz="1100" b="1">
-                <a:solidFill>
-                  <a:srgbClr val="2563EB"/>
-                </a:solidFill>
-                <a:latin typeface="Arial"/>
-              </a:rPr>
-              <a:t>SERVING MODEL · later recordings of the same 14 participants it was trained on — not new people</a:t>
-            </a:r>
-          </a:p>
-        </p:txBody>
-      </p:sp>
-      <p:sp>
-        <p:nvSpPr>
-          <p:cNvPr id="3" name="TextBox 2"/>
-          <p:cNvSpPr txBox="1"/>
-          <p:nvPr/>
-        </p:nvSpPr>
-        <p:spPr>
-          <a:xfrm>
-            <a:off x="548640" y="384048"/>
-            <a:ext cx="11064240" cy="640080"/>
-          </a:xfrm>
-          <a:prstGeom prst="rect">
-            <a:avLst/>
-          </a:prstGeom>
-          <a:noFill/>
-        </p:spPr>
-        <p:txBody>
-          <a:bodyPr wrap="square">
-            <a:spAutoFit/>
-          </a:bodyPr>
-          <a:lstStyle/>
-          <a:p>
-            <a:r>
-              <a:rPr sz="3000" b="1">
-                <a:solidFill>
-                  <a:srgbClr val="0B1220"/>
-                </a:solidFill>
-                <a:latin typeface="Arial"/>
-              </a:rPr>
-              <a:t>Measured evaluation: early warning and uncertainty</a:t>
-            </a:r>
-          </a:p>
-        </p:txBody>
-      </p:sp>
-      <p:cxnSp>
-        <p:nvCxnSpPr>
-          <p:cNvPr id="4" name="Connector 3"/>
-          <p:cNvCxnSpPr/>
-          <p:nvPr/>
-        </p:nvCxnSpPr>
-        <p:spPr>
-          <a:xfrm>
-            <a:off x="548640" y="987552"/>
-            <a:ext cx="11091672" cy="0"/>
-          </a:xfrm>
-          <a:prstGeom prst="line">
-            <a:avLst/>
-          </a:prstGeom>
-          <a:ln w="9525">
-            <a:solidFill>
-              <a:srgbClr val="E3E8EF"/>
-            </a:solidFill>
-          </a:ln>
-        </p:spPr>
-      </p:cxnSp>
-      <p:sp>
-        <p:nvSpPr>
-          <p:cNvPr id="5" name="TextBox 4"/>
-          <p:cNvSpPr txBox="1"/>
-          <p:nvPr/>
-        </p:nvSpPr>
-        <p:spPr>
-          <a:xfrm>
-            <a:off x="11247120" y="6446520"/>
-            <a:ext cx="457200" cy="274320"/>
-          </a:xfrm>
-          <a:prstGeom prst="rect">
-            <a:avLst/>
-          </a:prstGeom>
-          <a:noFill/>
-        </p:spPr>
-        <p:txBody>
-          <a:bodyPr wrap="square">
-            <a:spAutoFit/>
-          </a:bodyPr>
-          <a:lstStyle/>
-          <a:p>
-            <a:r>
-              <a:rPr sz="1100" b="0">
-                <a:solidFill>
-                  <a:srgbClr val="0B1220"/>
-                </a:solidFill>
-                <a:latin typeface="Arial"/>
-              </a:rPr>
-              <a:t>18</a:t>
-            </a:r>
-          </a:p>
-        </p:txBody>
-      </p:sp>
-      <p:sp>
-        <p:nvSpPr>
-          <p:cNvPr id="6" name="TextBox 5"/>
           <p:cNvSpPr txBox="1"/>
           <p:nvPr/>
         </p:nvSpPr>
@@ -5805,7 +5245,7 @@
                 </a:solidFill>
                 <a:latin typeface="Arial"/>
               </a:rPr>
-              <a:t>•  60-min warning (test, margin threshold -10 mg/dL chosen on validation by F1): 61/64 new onsets detected, precision 0.60, 40 false alarms (1.49 per observed patient-day; 2.28 per eligible day); forecast lead median 30 min among detected onsets (episode start 30 min). Detection is not notice: 48.4 % of all onsets were warned at least 30 min ahead.</a:t>
+              <a:t>•  Team Kryptonite — Avinash Gehi (team leader) · Hardik Hinduja. Vivekanand Education Society's Institute of Technology (VESIT), Mumbai.</a:t>
             </a:r>
           </a:p>
           <a:p>
@@ -5821,7 +5261,7 @@
                 </a:solidFill>
                 <a:latin typeface="Arial"/>
               </a:rPr>
-              <a:t>•  Same procedure on persistence (fires at glucose ≥ 150): 63/64 detected, 70 false alarms (2.61 per observed patient-day; 4.00 per eligible day).</a:t>
+              <a:t>•  Code: public GitHub link — added after the team publishes the repository — MIT license (code only). Quick start: make setup · make synthetic · make dev.</a:t>
             </a:r>
           </a:p>
           <a:p>
@@ -5837,7 +5277,7 @@
                 </a:solidFill>
                 <a:latin typeface="Arial"/>
               </a:rPr>
-              <a:t>•  Prediction ranges (target coverage 80 %) covered 74.2 % (30 min) and 74.0 % (60 min) on test, 60–82 % and 51–88 % per participant — under-covered; no guarantee claimed.</a:t>
+              <a:t>•  Demo video: unlisted YouTube link — added after recording and upload.</a:t>
             </a:r>
           </a:p>
           <a:p>
@@ -5853,181 +5293,9 @@
                 </a:solidFill>
                 <a:latin typeface="Arial"/>
               </a:rPr>
-              <a:t>•  Optimistic meal logging: 19.07 vs 20.59 mg/dL at 60 min — timely meal data would likely help most.</a:t>
-            </a:r>
-          </a:p>
-        </p:txBody>
-      </p:sp>
-    </p:spTree>
-  </p:cSld>
-  <p:clrMapOvr>
-    <a:masterClrMapping/>
-  </p:clrMapOvr>
-</p:sld>
-</file>
-
-<file path=ppt/slides/slide19.xml><?xml version="1.0" encoding="utf-8"?>
-<p:sld xmlns:a="http://schemas.openxmlformats.org/drawingml/2006/main" xmlns:p="http://schemas.openxmlformats.org/presentationml/2006/main" xmlns:r="http://schemas.openxmlformats.org/officeDocument/2006/relationships">
-  <p:cSld>
-    <p:bg>
-      <p:bgPr>
-        <a:solidFill>
-          <a:srgbClr val="FFFFFF"/>
-        </a:solidFill>
-        <a:effectLst/>
-      </p:bgPr>
-    </p:bg>
-    <p:spTree>
-      <p:nvGrpSpPr>
-        <p:cNvPr id="1" name=""/>
-        <p:cNvGrpSpPr/>
-        <p:nvPr/>
-      </p:nvGrpSpPr>
-      <p:grpSpPr/>
-      <p:sp>
-        <p:nvSpPr>
-          <p:cNvPr id="2" name="TextBox 1"/>
-          <p:cNvSpPr txBox="1"/>
-          <p:nvPr/>
-        </p:nvSpPr>
-        <p:spPr>
-          <a:xfrm>
-            <a:off x="548640" y="128016"/>
-            <a:ext cx="11064240" cy="274320"/>
-          </a:xfrm>
-          <a:prstGeom prst="rect">
-            <a:avLst/>
-          </a:prstGeom>
-          <a:noFill/>
-        </p:spPr>
-        <p:txBody>
-          <a:bodyPr wrap="square">
-            <a:spAutoFit/>
-          </a:bodyPr>
-          <a:lstStyle/>
-          <a:p>
-            <a:r>
-              <a:rPr sz="1100" b="1">
-                <a:solidFill>
-                  <a:srgbClr val="2563EB"/>
-                </a:solidFill>
-                <a:latin typeface="Arial"/>
-              </a:rPr>
-              <a:t>RESEARCH · each participant held out entirely · internal validation · not the serving model</a:t>
-            </a:r>
-          </a:p>
-        </p:txBody>
-      </p:sp>
-      <p:sp>
-        <p:nvSpPr>
-          <p:cNvPr id="3" name="TextBox 2"/>
-          <p:cNvSpPr txBox="1"/>
-          <p:nvPr/>
-        </p:nvSpPr>
-        <p:spPr>
-          <a:xfrm>
-            <a:off x="548640" y="384048"/>
-            <a:ext cx="11064240" cy="640080"/>
-          </a:xfrm>
-          <a:prstGeom prst="rect">
-            <a:avLst/>
-          </a:prstGeom>
-          <a:noFill/>
-        </p:spPr>
-        <p:txBody>
-          <a:bodyPr wrap="square">
-            <a:spAutoFit/>
-          </a:bodyPr>
-          <a:lstStyle/>
-          <a:p>
-            <a:r>
-              <a:rPr sz="3000" b="1">
-                <a:solidFill>
-                  <a:srgbClr val="0B1220"/>
-                </a:solidFill>
-                <a:latin typeface="Arial"/>
-              </a:rPr>
-              <a:t>Research: people held out entirely</a:t>
-            </a:r>
-          </a:p>
-        </p:txBody>
-      </p:sp>
-      <p:cxnSp>
-        <p:nvCxnSpPr>
-          <p:cNvPr id="4" name="Connector 3"/>
-          <p:cNvCxnSpPr/>
-          <p:nvPr/>
-        </p:nvCxnSpPr>
-        <p:spPr>
-          <a:xfrm>
-            <a:off x="548640" y="987552"/>
-            <a:ext cx="11091672" cy="0"/>
-          </a:xfrm>
-          <a:prstGeom prst="line">
-            <a:avLst/>
-          </a:prstGeom>
-          <a:ln w="9525">
-            <a:solidFill>
-              <a:srgbClr val="E3E8EF"/>
-            </a:solidFill>
-          </a:ln>
-        </p:spPr>
-      </p:cxnSp>
-      <p:sp>
-        <p:nvSpPr>
-          <p:cNvPr id="5" name="TextBox 4"/>
-          <p:cNvSpPr txBox="1"/>
-          <p:nvPr/>
-        </p:nvSpPr>
-        <p:spPr>
-          <a:xfrm>
-            <a:off x="11247120" y="6446520"/>
-            <a:ext cx="457200" cy="274320"/>
-          </a:xfrm>
-          <a:prstGeom prst="rect">
-            <a:avLst/>
-          </a:prstGeom>
-          <a:noFill/>
-        </p:spPr>
-        <p:txBody>
-          <a:bodyPr wrap="square">
-            <a:spAutoFit/>
-          </a:bodyPr>
-          <a:lstStyle/>
-          <a:p>
-            <a:r>
-              <a:rPr sz="1100" b="0">
-                <a:solidFill>
-                  <a:srgbClr val="0B1220"/>
-                </a:solidFill>
-                <a:latin typeface="Arial"/>
-              </a:rPr>
-              <a:t>19</a:t>
-            </a:r>
-          </a:p>
-        </p:txBody>
-      </p:sp>
-      <p:sp>
-        <p:nvSpPr>
-          <p:cNvPr id="6" name="TextBox 5"/>
-          <p:cNvSpPr txBox="1"/>
-          <p:nvPr/>
-        </p:nvSpPr>
-        <p:spPr>
-          <a:xfrm>
-            <a:off x="548640" y="1234440"/>
-            <a:ext cx="11064240" cy="5120640"/>
-          </a:xfrm>
-          <a:prstGeom prst="rect">
-            <a:avLst/>
-          </a:prstGeom>
-          <a:noFill/>
-        </p:spPr>
-        <p:txBody>
-          <a:bodyPr wrap="square">
-            <a:spAutoFit/>
-          </a:bodyPr>
-          <a:lstStyle/>
+              <a:t>•  Data: CGMacros 1.0.0 (PhysioNet, doi:10.13026/3z8q-x658, CC BY-NC-SA 4.0); ShanghaiT2DM (figshare, doi:10.6084/m9.figshare.21600933.v5, CC BY 4.0).</a:t>
+            </a:r>
+          </a:p>
           <a:p>
             <a:pPr>
               <a:spcAft>
@@ -6041,71 +5309,7 @@
                 </a:solidFill>
                 <a:latin typeface="Arial"/>
               </a:rPr>
-              <a:t>•  Models kept separate: the v2 recipe (LightGBM, dynamic streams only; the demo model when this experiment was declared) and a Ridge five-minute candidate on CGM-only features. Neither is the serving model.</a:t>
-            </a:r>
-          </a:p>
-          <a:p>
-            <a:pPr>
-              <a:spcAft>
-                <a:spcPts val="1000"/>
-              </a:spcAft>
-            </a:pPr>
-            <a:r>
-              <a:rPr sz="1700">
-                <a:solidFill>
-                  <a:srgbClr val="0B1220"/>
-                </a:solidFill>
-                <a:latin typeface="Arial"/>
-              </a:rPr>
-              <a:t>•  145 participants imported; 14 evaluated here (five participant folds, each person held out once, protocol frozen before fitting, D-032).</a:t>
-            </a:r>
-          </a:p>
-          <a:p>
-            <a:pPr>
-              <a:spcAft>
-                <a:spcPts val="1000"/>
-              </a:spcAft>
-            </a:pPr>
-            <a:r>
-              <a:rPr sz="1700">
-                <a:solidFill>
-                  <a:srgbClr val="0B1220"/>
-                </a:solidFill>
-                <a:latin typeface="Arial"/>
-              </a:rPr>
-              <a:t>•  Held-out people, 30 / 60 min: candidate 13.88 / 22.30 vs v2 recipe refit 14.52 / 24.25 vs persistence 15.34 / 24.47 mg/dL — but worse on large highs (+2.71 [+0.28, +5.11] mg/dL at 60 min when the target exceeded 180).</a:t>
-            </a:r>
-          </a:p>
-          <a:p>
-            <a:pPr>
-              <a:spcAft>
-                <a:spcPts val="1000"/>
-              </a:spcAft>
-            </a:pPr>
-            <a:r>
-              <a:rPr sz="1700">
-                <a:solidFill>
-                  <a:srgbClr val="0B1220"/>
-                </a:solidFill>
-                <a:latin typeface="Arial"/>
-              </a:rPr>
-              <a:t>•  Warnings chosen for ≤ 2 false alarms per day: 301/329 onsets at 1.31 false alarms per observed day (v2 recipe: 329/329 at 2.80).</a:t>
-            </a:r>
-          </a:p>
-          <a:p>
-            <a:pPr>
-              <a:spcAft>
-                <a:spcPts val="1000"/>
-              </a:spcAft>
-            </a:pPr>
-            <a:r>
-              <a:rPr sz="1700">
-                <a:solidFill>
-                  <a:srgbClr val="0B1220"/>
-                </a:solidFill>
-                <a:latin typeface="Arial"/>
-              </a:rPr>
-              <a:t>•  Not promoted, and not eligible as the demo model: the Ridge candidate reads CGM only. CGMacros was already inspected, so its folds are internal validation; the next protocol also bounds high-glucose error, missed onsets and false warnings (declared, not run).</a:t>
+              <a:t>•  Evidence: docs/judge_guide.md · reports/evidence_manifest.md · docs/submission/GlucoTwin_Research_Workbook.xlsx.</a:t>
             </a:r>
           </a:p>
         </p:txBody>
@@ -6324,2266 +5528,6 @@
                 <a:latin typeface="Arial"/>
               </a:rPr>
               <a:t>•  Our target: forecast glucose 30 and 60 minutes ahead and warn of a NEW sustained episode &gt; 180 mg/dL (≥ 15 min), for Type 2 diabetes.</a:t>
-            </a:r>
-          </a:p>
-        </p:txBody>
-      </p:sp>
-    </p:spTree>
-  </p:cSld>
-  <p:clrMapOvr>
-    <a:masterClrMapping/>
-  </p:clrMapOvr>
-</p:sld>
-</file>
-
-<file path=ppt/slides/slide20.xml><?xml version="1.0" encoding="utf-8"?>
-<p:sld xmlns:a="http://schemas.openxmlformats.org/drawingml/2006/main" xmlns:p="http://schemas.openxmlformats.org/presentationml/2006/main" xmlns:r="http://schemas.openxmlformats.org/officeDocument/2006/relationships">
-  <p:cSld>
-    <p:bg>
-      <p:bgPr>
-        <a:solidFill>
-          <a:srgbClr val="FFFFFF"/>
-        </a:solidFill>
-        <a:effectLst/>
-      </p:bgPr>
-    </p:bg>
-    <p:spTree>
-      <p:nvGrpSpPr>
-        <p:cNvPr id="1" name=""/>
-        <p:cNvGrpSpPr/>
-        <p:nvPr/>
-      </p:nvGrpSpPr>
-      <p:grpSpPr/>
-      <p:sp>
-        <p:nvSpPr>
-          <p:cNvPr id="2" name="TextBox 1"/>
-          <p:cNvSpPr txBox="1"/>
-          <p:nvPr/>
-        </p:nvSpPr>
-        <p:spPr>
-          <a:xfrm>
-            <a:off x="548640" y="128016"/>
-            <a:ext cx="11064240" cy="274320"/>
-          </a:xfrm>
-          <a:prstGeom prst="rect">
-            <a:avLst/>
-          </a:prstGeom>
-          <a:noFill/>
-        </p:spPr>
-        <p:txBody>
-          <a:bodyPr wrap="square">
-            <a:spAutoFit/>
-          </a:bodyPr>
-          <a:lstStyle/>
-          <a:p>
-            <a:r>
-              <a:rPr sz="1100" b="1">
-                <a:solidFill>
-                  <a:srgbClr val="2563EB"/>
-                </a:solidFill>
-                <a:latin typeface="Arial"/>
-              </a:rPr>
-              <a:t>RESEARCH · each participant held out entirely · internal validation · not the serving model</a:t>
-            </a:r>
-          </a:p>
-        </p:txBody>
-      </p:sp>
-      <p:sp>
-        <p:nvSpPr>
-          <p:cNvPr id="3" name="TextBox 2"/>
-          <p:cNvSpPr txBox="1"/>
-          <p:nvPr/>
-        </p:nvSpPr>
-        <p:spPr>
-          <a:xfrm>
-            <a:off x="548640" y="384048"/>
-            <a:ext cx="11064240" cy="640080"/>
-          </a:xfrm>
-          <a:prstGeom prst="rect">
-            <a:avLst/>
-          </a:prstGeom>
-          <a:noFill/>
-        </p:spPr>
-        <p:txBody>
-          <a:bodyPr wrap="square">
-            <a:spAutoFit/>
-          </a:bodyPr>
-          <a:lstStyle/>
-          <a:p>
-            <a:r>
-              <a:rPr sz="3000" b="1">
-                <a:solidFill>
-                  <a:srgbClr val="0B1220"/>
-                </a:solidFill>
-                <a:latin typeface="Arial"/>
-              </a:rPr>
-              <a:t>Research: warning two hours ahead</a:t>
-            </a:r>
-          </a:p>
-        </p:txBody>
-      </p:sp>
-      <p:cxnSp>
-        <p:nvCxnSpPr>
-          <p:cNvPr id="4" name="Connector 3"/>
-          <p:cNvCxnSpPr/>
-          <p:nvPr/>
-        </p:nvCxnSpPr>
-        <p:spPr>
-          <a:xfrm>
-            <a:off x="548640" y="987552"/>
-            <a:ext cx="11091672" cy="0"/>
-          </a:xfrm>
-          <a:prstGeom prst="line">
-            <a:avLst/>
-          </a:prstGeom>
-          <a:ln w="9525">
-            <a:solidFill>
-              <a:srgbClr val="E3E8EF"/>
-            </a:solidFill>
-          </a:ln>
-        </p:spPr>
-      </p:cxnSp>
-      <p:sp>
-        <p:nvSpPr>
-          <p:cNvPr id="5" name="TextBox 4"/>
-          <p:cNvSpPr txBox="1"/>
-          <p:nvPr/>
-        </p:nvSpPr>
-        <p:spPr>
-          <a:xfrm>
-            <a:off x="11247120" y="6446520"/>
-            <a:ext cx="457200" cy="274320"/>
-          </a:xfrm>
-          <a:prstGeom prst="rect">
-            <a:avLst/>
-          </a:prstGeom>
-          <a:noFill/>
-        </p:spPr>
-        <p:txBody>
-          <a:bodyPr wrap="square">
-            <a:spAutoFit/>
-          </a:bodyPr>
-          <a:lstStyle/>
-          <a:p>
-            <a:r>
-              <a:rPr sz="1100" b="0">
-                <a:solidFill>
-                  <a:srgbClr val="0B1220"/>
-                </a:solidFill>
-                <a:latin typeface="Arial"/>
-              </a:rPr>
-              <a:t>20</a:t>
-            </a:r>
-          </a:p>
-        </p:txBody>
-      </p:sp>
-      <p:sp>
-        <p:nvSpPr>
-          <p:cNvPr id="6" name="TextBox 5"/>
-          <p:cNvSpPr txBox="1"/>
-          <p:nvPr/>
-        </p:nvSpPr>
-        <p:spPr>
-          <a:xfrm>
-            <a:off x="548640" y="1234440"/>
-            <a:ext cx="11064240" cy="5120640"/>
-          </a:xfrm>
-          <a:prstGeom prst="rect">
-            <a:avLst/>
-          </a:prstGeom>
-          <a:noFill/>
-        </p:spPr>
-        <p:txBody>
-          <a:bodyPr wrap="square">
-            <a:spAutoFit/>
-          </a:bodyPr>
-          <a:lstStyle/>
-          <a:p>
-            <a:pPr>
-              <a:spcAft>
-                <a:spcPts val="1000"/>
-              </a:spcAft>
-            </a:pPr>
-            <a:r>
-              <a:rPr sz="1700">
-                <a:solidFill>
-                  <a:srgbClr val="0B1220"/>
-                </a:solidFill>
-                <a:latin typeface="Arial"/>
-              </a:rPr>
-              <a:t>•  The brief's example is a spike predicted 2 hours ahead. Declared before any fit (decision D-043): the people-held-out procedure above, same folds, plus a 120-minute horizon. 14 people, each held out once; not the demo model, nothing promoted.</a:t>
-            </a:r>
-          </a:p>
-          <a:p>
-            <a:pPr>
-              <a:spcAft>
-                <a:spcPts val="1000"/>
-              </a:spcAft>
-            </a:pPr>
-            <a:r>
-              <a:rPr sz="1700">
-                <a:solidFill>
-                  <a:srgbClr val="0B1220"/>
-                </a:solidFill>
-                <a:latin typeface="Arial"/>
-              </a:rPr>
-              <a:t>•  Forecast error at 120 min: 30.6 mg/dL vs persistence 35.9 (-5.25 [-6.44, -4.05] mg/dL); at 60 min 22.3 vs 24.5.</a:t>
-            </a:r>
-          </a:p>
-          <a:p>
-            <a:pPr>
-              <a:spcAft>
-                <a:spcPts val="1000"/>
-              </a:spcAft>
-            </a:pPr>
-            <a:r>
-              <a:rPr sz="1700">
-                <a:solidFill>
-                  <a:srgbClr val="0B1220"/>
-                </a:solidFill>
-                <a:latin typeface="Arial"/>
-              </a:rPr>
-              <a:t>•  120-min warning: 315/329 onsets warned, 1.62 false alarms per observed day, median forecast lead 15 min. For comparison, 60-min warning: 313/329 onsets warned, 1.48 false alarms per observed day, median forecast lead 10 min.</a:t>
-            </a:r>
-          </a:p>
-          <a:p>
-            <a:pPr>
-              <a:spcAft>
-                <a:spcPts val="1000"/>
-              </a:spcAft>
-            </a:pPr>
-            <a:r>
-              <a:rPr sz="1700">
-                <a:solidFill>
-                  <a:srgbClr val="0B1220"/>
-                </a:solidFill>
-                <a:latin typeface="Arial"/>
-              </a:rPr>
-              <a:t>•  Profile (EHR-like) inputs at 120 min, LightGBM with minus without: -0.86 [-2.60, +1.02] mg/dL (no reliable benefit on people held out).</a:t>
-            </a:r>
-          </a:p>
-          <a:p>
-            <a:pPr>
-              <a:spcAft>
-                <a:spcPts val="1000"/>
-              </a:spcAft>
-            </a:pPr>
-            <a:r>
-              <a:rPr sz="1700">
-                <a:solidFill>
-                  <a:srgbClr val="0B1220"/>
-                </a:solidFill>
-                <a:latin typeface="Arial"/>
-              </a:rPr>
-              <a:t>•  Thresholds chosen on development folds only (≤ 2 false alarms per observed day); each test fold opened once. The 14 people were inspected in earlier experiments, so this is internal validation.</a:t>
-            </a:r>
-          </a:p>
-        </p:txBody>
-      </p:sp>
-    </p:spTree>
-  </p:cSld>
-  <p:clrMapOvr>
-    <a:masterClrMapping/>
-  </p:clrMapOvr>
-</p:sld>
-</file>
-
-<file path=ppt/slides/slide21.xml><?xml version="1.0" encoding="utf-8"?>
-<p:sld xmlns:a="http://schemas.openxmlformats.org/drawingml/2006/main" xmlns:p="http://schemas.openxmlformats.org/presentationml/2006/main" xmlns:r="http://schemas.openxmlformats.org/officeDocument/2006/relationships">
-  <p:cSld>
-    <p:bg>
-      <p:bgPr>
-        <a:solidFill>
-          <a:srgbClr val="FFFFFF"/>
-        </a:solidFill>
-        <a:effectLst/>
-      </p:bgPr>
-    </p:bg>
-    <p:spTree>
-      <p:nvGrpSpPr>
-        <p:cNvPr id="1" name=""/>
-        <p:cNvGrpSpPr/>
-        <p:nvPr/>
-      </p:nvGrpSpPr>
-      <p:grpSpPr/>
-      <p:sp>
-        <p:nvSpPr>
-          <p:cNvPr id="2" name="TextBox 1"/>
-          <p:cNvSpPr txBox="1"/>
-          <p:nvPr/>
-        </p:nvSpPr>
-        <p:spPr>
-          <a:xfrm>
-            <a:off x="548640" y="128016"/>
-            <a:ext cx="11064240" cy="274320"/>
-          </a:xfrm>
-          <a:prstGeom prst="rect">
-            <a:avLst/>
-          </a:prstGeom>
-          <a:noFill/>
-        </p:spPr>
-        <p:txBody>
-          <a:bodyPr wrap="square">
-            <a:spAutoFit/>
-          </a:bodyPr>
-          <a:lstStyle/>
-          <a:p>
-            <a:r>
-              <a:rPr sz="1100" b="1">
-                <a:solidFill>
-                  <a:srgbClr val="2563EB"/>
-                </a:solidFill>
-                <a:latin typeface="Arial"/>
-              </a:rPr>
-              <a:t>RESEARCH · each participant held out entirely · internal validation · not the serving model</a:t>
-            </a:r>
-          </a:p>
-        </p:txBody>
-      </p:sp>
-      <p:sp>
-        <p:nvSpPr>
-          <p:cNvPr id="3" name="TextBox 2"/>
-          <p:cNvSpPr txBox="1"/>
-          <p:nvPr/>
-        </p:nvSpPr>
-        <p:spPr>
-          <a:xfrm>
-            <a:off x="548640" y="384048"/>
-            <a:ext cx="11064240" cy="640080"/>
-          </a:xfrm>
-          <a:prstGeom prst="rect">
-            <a:avLst/>
-          </a:prstGeom>
-          <a:noFill/>
-        </p:spPr>
-        <p:txBody>
-          <a:bodyPr wrap="square">
-            <a:spAutoFit/>
-          </a:bodyPr>
-          <a:lstStyle/>
-          <a:p>
-            <a:r>
-              <a:rPr sz="3000" b="1">
-                <a:solidFill>
-                  <a:srgbClr val="0B1220"/>
-                </a:solidFill>
-                <a:latin typeface="Arial"/>
-              </a:rPr>
-              <a:t>Research: what we fixed, and what we could not</a:t>
-            </a:r>
-          </a:p>
-        </p:txBody>
-      </p:sp>
-      <p:cxnSp>
-        <p:nvCxnSpPr>
-          <p:cNvPr id="4" name="Connector 3"/>
-          <p:cNvCxnSpPr/>
-          <p:nvPr/>
-        </p:nvCxnSpPr>
-        <p:spPr>
-          <a:xfrm>
-            <a:off x="548640" y="987552"/>
-            <a:ext cx="11091672" cy="0"/>
-          </a:xfrm>
-          <a:prstGeom prst="line">
-            <a:avLst/>
-          </a:prstGeom>
-          <a:ln w="9525">
-            <a:solidFill>
-              <a:srgbClr val="E3E8EF"/>
-            </a:solidFill>
-          </a:ln>
-        </p:spPr>
-      </p:cxnSp>
-      <p:sp>
-        <p:nvSpPr>
-          <p:cNvPr id="5" name="TextBox 4"/>
-          <p:cNvSpPr txBox="1"/>
-          <p:nvPr/>
-        </p:nvSpPr>
-        <p:spPr>
-          <a:xfrm>
-            <a:off x="11247120" y="6446520"/>
-            <a:ext cx="457200" cy="274320"/>
-          </a:xfrm>
-          <a:prstGeom prst="rect">
-            <a:avLst/>
-          </a:prstGeom>
-          <a:noFill/>
-        </p:spPr>
-        <p:txBody>
-          <a:bodyPr wrap="square">
-            <a:spAutoFit/>
-          </a:bodyPr>
-          <a:lstStyle/>
-          <a:p>
-            <a:r>
-              <a:rPr sz="1100" b="0">
-                <a:solidFill>
-                  <a:srgbClr val="0B1220"/>
-                </a:solidFill>
-                <a:latin typeface="Arial"/>
-              </a:rPr>
-              <a:t>21</a:t>
-            </a:r>
-          </a:p>
-        </p:txBody>
-      </p:sp>
-      <p:sp>
-        <p:nvSpPr>
-          <p:cNvPr id="6" name="TextBox 5"/>
-          <p:cNvSpPr txBox="1"/>
-          <p:nvPr/>
-        </p:nvSpPr>
-        <p:spPr>
-          <a:xfrm>
-            <a:off x="548640" y="1234440"/>
-            <a:ext cx="11064240" cy="5120640"/>
-          </a:xfrm>
-          <a:prstGeom prst="rect">
-            <a:avLst/>
-          </a:prstGeom>
-          <a:noFill/>
-        </p:spPr>
-        <p:txBody>
-          <a:bodyPr wrap="square">
-            <a:spAutoFit/>
-          </a:bodyPr>
-          <a:lstStyle/>
-          <a:p>
-            <a:pPr>
-              <a:spcAft>
-                <a:spcPts val="1000"/>
-              </a:spcAft>
-            </a:pPr>
-            <a:r>
-              <a:rPr sz="1550">
-                <a:solidFill>
-                  <a:srgbClr val="0B1220"/>
-                </a:solidFill>
-                <a:latin typeface="Arial"/>
-              </a:rPr>
-              <a:t>•  We declared each study before its own run. Later studies reused previously inspected participants, so those results are internal validation.</a:t>
-            </a:r>
-          </a:p>
-          <a:p>
-            <a:pPr>
-              <a:spcAft>
-                <a:spcPts val="1000"/>
-              </a:spcAft>
-            </a:pPr>
-            <a:r>
-              <a:rPr sz="1550">
-                <a:solidFill>
-                  <a:srgbClr val="0B1220"/>
-                </a:solidFill>
-                <a:latin typeface="Arial"/>
-              </a:rPr>
-              <a:t>•  Fixed — prediction ranges: calibrating on all development people instead of 2 per fold raised two-hour coverage from 76.5 % to 79.8 % (target 80 %; 60 min 78.2 → 79.5 %), ranges 7 mg/dL wider.</a:t>
-            </a:r>
-          </a:p>
-          <a:p>
-            <a:pPr>
-              <a:spcAft>
-                <a:spcPts val="1000"/>
-              </a:spcAft>
-            </a:pPr>
-            <a:r>
-              <a:rPr sz="1550">
-                <a:solidFill>
-                  <a:srgbClr val="0B1220"/>
-                </a:solidFill>
-                <a:latin typeface="Arial"/>
-              </a:rPr>
-              <a:t>•  Not shown — earlier warning: 126 vs 123 of 329 onsets warned ≥ 30 min ahead (+0.9 points [-5.5, +6.6]) at the same workload; median lead still 15 min.</a:t>
-            </a:r>
-          </a:p>
-          <a:p>
-            <a:pPr>
-              <a:spcAft>
-                <a:spcPts val="1000"/>
-              </a:spcAft>
-            </a:pPr>
-            <a:r>
-              <a:rPr sz="1550">
-                <a:solidFill>
-                  <a:srgbClr val="0B1220"/>
-                </a:solidFill>
-                <a:latin typeface="Arial"/>
-              </a:rPr>
-              <a:t>•  Not shown — health record as a new person's starting correction: -0.53 [-1.57, +0.58] mg/dL at 120 min, -0.93 [-2.74, +0.48] in the first 24 hours; the intervals cross zero, so no benefit is claimed.</a:t>
-            </a:r>
-          </a:p>
-          <a:p>
-            <a:pPr>
-              <a:spcAft>
-                <a:spcPts val="1000"/>
-              </a:spcAft>
-            </a:pPr>
-            <a:r>
-              <a:rPr sz="1550">
-                <a:solidFill>
-                  <a:srgbClr val="0B1220"/>
-                </a:solidFill>
-                <a:latin typeface="Arial"/>
-              </a:rPr>
-              <a:t>•  Not adopted — a LightGBM–CatBoost blend (D-048): +0.02 mg/dL at 60 min on development people against a 0.5 target; held-out folds never opened.</a:t>
-            </a:r>
-          </a:p>
-          <a:p>
-            <a:pPr>
-              <a:spcAft>
-                <a:spcPts val="1000"/>
-              </a:spcAft>
-            </a:pPr>
-            <a:r>
-              <a:rPr sz="1550">
-                <a:solidFill>
-                  <a:srgbClr val="0B1220"/>
-                </a:solidFill>
-                <a:latin typeface="Arial"/>
-              </a:rPr>
-              <a:t>•  Not adopted — fixed and tuned retraining (D-049, D-051): best 60-min gain +0.41 mg/dL (fixed), -0.37 [-0.63, -0.06] with tuning, below the declared 0.5 bar.</a:t>
-            </a:r>
-          </a:p>
-          <a:p>
-            <a:pPr>
-              <a:spcAft>
-                <a:spcPts val="1000"/>
-              </a:spcAft>
-            </a:pPr>
-            <a:r>
-              <a:rPr sz="1550">
-                <a:solidFill>
-                  <a:srgbClr val="0B1220"/>
-                </a:solidFill>
-                <a:latin typeface="Arial"/>
-              </a:rPr>
-              <a:t>•  Not adopted — joint selection (D-052, 1,570 fresh fits): -0.88 [-1.75, -0.13] mg/dL at 60 min vs the refitted serving recipe, but +1.70 on peaks above 180 and +0.60 false alarms/day — gates not met.</a:t>
-            </a:r>
-          </a:p>
-          <a:p>
-            <a:pPr>
-              <a:spcAft>
-                <a:spcPts val="1000"/>
-              </a:spcAft>
-            </a:pPr>
-            <a:r>
-              <a:rPr sz="1550">
-                <a:solidFill>
-                  <a:srgbClr val="0B1220"/>
-                </a:solidFill>
-                <a:latin typeface="Arial"/>
-              </a:rPr>
-              <a:t>•  The demo model's ranges are already pooled over all 14 people; its under-coverage most likely comes from drift between time segments, so this fix is not applied to it.</a:t>
-            </a:r>
-          </a:p>
-        </p:txBody>
-      </p:sp>
-    </p:spTree>
-  </p:cSld>
-  <p:clrMapOvr>
-    <a:masterClrMapping/>
-  </p:clrMapOvr>
-</p:sld>
-</file>
-
-<file path=ppt/slides/slide22.xml><?xml version="1.0" encoding="utf-8"?>
-<p:sld xmlns:a="http://schemas.openxmlformats.org/drawingml/2006/main" xmlns:p="http://schemas.openxmlformats.org/presentationml/2006/main" xmlns:r="http://schemas.openxmlformats.org/officeDocument/2006/relationships">
-  <p:cSld>
-    <p:bg>
-      <p:bgPr>
-        <a:solidFill>
-          <a:srgbClr val="FFFFFF"/>
-        </a:solidFill>
-        <a:effectLst/>
-      </p:bgPr>
-    </p:bg>
-    <p:spTree>
-      <p:nvGrpSpPr>
-        <p:cNvPr id="1" name=""/>
-        <p:cNvGrpSpPr/>
-        <p:nvPr/>
-      </p:nvGrpSpPr>
-      <p:grpSpPr/>
-      <p:sp>
-        <p:nvSpPr>
-          <p:cNvPr id="2" name="TextBox 1"/>
-          <p:cNvSpPr txBox="1"/>
-          <p:nvPr/>
-        </p:nvSpPr>
-        <p:spPr>
-          <a:xfrm>
-            <a:off x="548640" y="128016"/>
-            <a:ext cx="11064240" cy="274320"/>
-          </a:xfrm>
-          <a:prstGeom prst="rect">
-            <a:avLst/>
-          </a:prstGeom>
-          <a:noFill/>
-        </p:spPr>
-        <p:txBody>
-          <a:bodyPr wrap="square">
-            <a:spAutoFit/>
-          </a:bodyPr>
-          <a:lstStyle/>
-          <a:p>
-            <a:r>
-              <a:rPr sz="1100" b="1">
-                <a:solidFill>
-                  <a:srgbClr val="2563EB"/>
-                </a:solidFill>
-                <a:latin typeface="Arial"/>
-              </a:rPr>
-              <a:t>RESEARCH · each participant held out entirely · internal validation · not the serving model</a:t>
-            </a:r>
-          </a:p>
-        </p:txBody>
-      </p:sp>
-      <p:sp>
-        <p:nvSpPr>
-          <p:cNvPr id="3" name="TextBox 2"/>
-          <p:cNvSpPr txBox="1"/>
-          <p:nvPr/>
-        </p:nvSpPr>
-        <p:spPr>
-          <a:xfrm>
-            <a:off x="548640" y="384048"/>
-            <a:ext cx="11064240" cy="640080"/>
-          </a:xfrm>
-          <a:prstGeom prst="rect">
-            <a:avLst/>
-          </a:prstGeom>
-          <a:noFill/>
-        </p:spPr>
-        <p:txBody>
-          <a:bodyPr wrap="square">
-            <a:spAutoFit/>
-          </a:bodyPr>
-          <a:lstStyle/>
-          <a:p>
-            <a:r>
-              <a:rPr sz="3000" b="1">
-                <a:solidFill>
-                  <a:srgbClr val="0B1220"/>
-                </a:solidFill>
-                <a:latin typeface="Arial"/>
-              </a:rPr>
-              <a:t>Research: peak-aware selection (D-053), a near miss</a:t>
-            </a:r>
-          </a:p>
-        </p:txBody>
-      </p:sp>
-      <p:cxnSp>
-        <p:nvCxnSpPr>
-          <p:cNvPr id="4" name="Connector 3"/>
-          <p:cNvCxnSpPr/>
-          <p:nvPr/>
-        </p:nvCxnSpPr>
-        <p:spPr>
-          <a:xfrm>
-            <a:off x="548640" y="987552"/>
-            <a:ext cx="11091672" cy="0"/>
-          </a:xfrm>
-          <a:prstGeom prst="line">
-            <a:avLst/>
-          </a:prstGeom>
-          <a:ln w="9525">
-            <a:solidFill>
-              <a:srgbClr val="E3E8EF"/>
-            </a:solidFill>
-          </a:ln>
-        </p:spPr>
-      </p:cxnSp>
-      <p:sp>
-        <p:nvSpPr>
-          <p:cNvPr id="5" name="TextBox 4"/>
-          <p:cNvSpPr txBox="1"/>
-          <p:nvPr/>
-        </p:nvSpPr>
-        <p:spPr>
-          <a:xfrm>
-            <a:off x="11247120" y="6446520"/>
-            <a:ext cx="457200" cy="274320"/>
-          </a:xfrm>
-          <a:prstGeom prst="rect">
-            <a:avLst/>
-          </a:prstGeom>
-          <a:noFill/>
-        </p:spPr>
-        <p:txBody>
-          <a:bodyPr wrap="square">
-            <a:spAutoFit/>
-          </a:bodyPr>
-          <a:lstStyle/>
-          <a:p>
-            <a:r>
-              <a:rPr sz="1100" b="0">
-                <a:solidFill>
-                  <a:srgbClr val="0B1220"/>
-                </a:solidFill>
-                <a:latin typeface="Arial"/>
-              </a:rPr>
-              <a:t>22</a:t>
-            </a:r>
-          </a:p>
-        </p:txBody>
-      </p:sp>
-      <p:sp>
-        <p:nvSpPr>
-          <p:cNvPr id="6" name="TextBox 5"/>
-          <p:cNvSpPr txBox="1"/>
-          <p:nvPr/>
-        </p:nvSpPr>
-        <p:spPr>
-          <a:xfrm>
-            <a:off x="548640" y="1234440"/>
-            <a:ext cx="11064240" cy="5120640"/>
-          </a:xfrm>
-          <a:prstGeom prst="rect">
-            <a:avLst/>
-          </a:prstGeom>
-          <a:noFill/>
-        </p:spPr>
-        <p:txBody>
-          <a:bodyPr wrap="square">
-            <a:spAutoFit/>
-          </a:bodyPr>
-          <a:lstStyle/>
-          <a:p>
-            <a:pPr>
-              <a:spcAft>
-                <a:spcPts val="1000"/>
-              </a:spcAft>
-            </a:pPr>
-            <a:r>
-              <a:rPr sz="1700">
-                <a:solidFill>
-                  <a:srgbClr val="0B1220"/>
-                </a:solidFill>
-                <a:latin typeface="Arial"/>
-              </a:rPr>
-              <a:t>•  Declared before any formal fit; inside each held-out fold, model settings, a training weight on future readings above 180 and the patient correction were chosen on development people only, with a guard on high-reading error. 1,490 fresh fits, 0 failures.</a:t>
-            </a:r>
-          </a:p>
-          <a:p>
-            <a:pPr>
-              <a:spcAft>
-                <a:spcPts val="1000"/>
-              </a:spcAft>
-            </a:pPr>
-            <a:r>
-              <a:rPr sz="1700">
-                <a:solidFill>
-                  <a:srgbClr val="0B1220"/>
-                </a:solidFill>
-                <a:latin typeface="Arial"/>
-              </a:rPr>
-              <a:t>•  60 min, against the serving recipe refitted in the same folds: 22.00 vs 23.20 mg/dL, -1.19 [-2.09, -0.39], lower for 11 of 14 people; 30 min -0.50 [-0.77, -0.24].</a:t>
-            </a:r>
-          </a:p>
-          <a:p>
-            <a:pPr>
-              <a:spcAft>
-                <a:spcPts val="1000"/>
-              </a:spcAft>
-            </a:pPr>
-            <a:r>
-              <a:rPr sz="1700">
-                <a:solidFill>
-                  <a:srgbClr val="0B1220"/>
-                </a:solidFill>
-                <a:latin typeface="Arial"/>
-              </a:rPr>
-              <a:t>•  Primary gate not met: error on readings above 180 changed by +1.07 mg/dL against a declared limit of +1.0.</a:t>
-            </a:r>
-          </a:p>
-          <a:p>
-            <a:pPr>
-              <a:spcAft>
-                <a:spcPts val="1000"/>
-              </a:spcAft>
-            </a:pPr>
-            <a:r>
-              <a:rPr sz="1700">
-                <a:solidFill>
-                  <a:srgbClr val="0B1220"/>
-                </a:solidFill>
-                <a:latin typeface="Arial"/>
-              </a:rPr>
-              <a:t>•  Warning guardrails passed: 1.15 vs 1.20 false alarms per observed day; 21.9 % vs 16.4 % of onsets warned ≥ 30 min ahead. Exact-predictor 80 % ranges covered 79.4 % / 77.3 % (range guardrails passed).</a:t>
-            </a:r>
-          </a:p>
-          <a:p>
-            <a:pPr>
-              <a:spcAft>
-                <a:spcPts val="1000"/>
-              </a:spcAft>
-            </a:pPr>
-            <a:r>
-              <a:rPr sz="1700">
-                <a:solidFill>
-                  <a:srgbClr val="0B1220"/>
-                </a:solidFill>
-                <a:latin typeface="Arial"/>
-              </a:rPr>
-              <a:t>•  Not adopted: one declared gate failed, so the serving model is unchanged.</a:t>
-            </a:r>
-          </a:p>
-          <a:p>
-            <a:pPr>
-              <a:spcAft>
-                <a:spcPts val="1000"/>
-              </a:spcAft>
-            </a:pPr>
-            <a:r>
-              <a:rPr sz="1700">
-                <a:solidFill>
-                  <a:srgbClr val="0B1220"/>
-                </a:solidFill>
-                <a:latin typeface="Arial"/>
-              </a:rPr>
-              <a:t>•  Previously inspected people: internal validation. Absolute errors are not comparable with D-052's; only the matched comparison is.</a:t>
-            </a:r>
-          </a:p>
-        </p:txBody>
-      </p:sp>
-    </p:spTree>
-  </p:cSld>
-  <p:clrMapOvr>
-    <a:masterClrMapping/>
-  </p:clrMapOvr>
-</p:sld>
-</file>
-
-<file path=ppt/slides/slide23.xml><?xml version="1.0" encoding="utf-8"?>
-<p:sld xmlns:a="http://schemas.openxmlformats.org/drawingml/2006/main" xmlns:p="http://schemas.openxmlformats.org/presentationml/2006/main" xmlns:r="http://schemas.openxmlformats.org/officeDocument/2006/relationships">
-  <p:cSld>
-    <p:bg>
-      <p:bgPr>
-        <a:solidFill>
-          <a:srgbClr val="FFFFFF"/>
-        </a:solidFill>
-        <a:effectLst/>
-      </p:bgPr>
-    </p:bg>
-    <p:spTree>
-      <p:nvGrpSpPr>
-        <p:cNvPr id="1" name=""/>
-        <p:cNvGrpSpPr/>
-        <p:nvPr/>
-      </p:nvGrpSpPr>
-      <p:grpSpPr/>
-      <p:sp>
-        <p:nvSpPr>
-          <p:cNvPr id="2" name="TextBox 1"/>
-          <p:cNvSpPr txBox="1"/>
-          <p:nvPr/>
-        </p:nvSpPr>
-        <p:spPr>
-          <a:xfrm>
-            <a:off x="548640" y="128016"/>
-            <a:ext cx="11064240" cy="274320"/>
-          </a:xfrm>
-          <a:prstGeom prst="rect">
-            <a:avLst/>
-          </a:prstGeom>
-          <a:noFill/>
-        </p:spPr>
-        <p:txBody>
-          <a:bodyPr wrap="square">
-            <a:spAutoFit/>
-          </a:bodyPr>
-          <a:lstStyle/>
-          <a:p>
-            <a:r>
-              <a:rPr sz="1100" b="1">
-                <a:solidFill>
-                  <a:srgbClr val="2563EB"/>
-                </a:solidFill>
-                <a:latin typeface="Arial"/>
-              </a:rPr>
-              <a:t>RESEARCH · 14 previously inspected people · internal comparison · CGM only · not served</a:t>
-            </a:r>
-          </a:p>
-        </p:txBody>
-      </p:sp>
-      <p:sp>
-        <p:nvSpPr>
-          <p:cNvPr id="3" name="TextBox 2"/>
-          <p:cNvSpPr txBox="1"/>
-          <p:nvPr/>
-        </p:nvSpPr>
-        <p:spPr>
-          <a:xfrm>
-            <a:off x="548640" y="384048"/>
-            <a:ext cx="11064240" cy="640080"/>
-          </a:xfrm>
-          <a:prstGeom prst="rect">
-            <a:avLst/>
-          </a:prstGeom>
-          <a:noFill/>
-        </p:spPr>
-        <p:txBody>
-          <a:bodyPr wrap="square">
-            <a:spAutoFit/>
-          </a:bodyPr>
-          <a:lstStyle/>
-          <a:p>
-            <a:r>
-              <a:rPr sz="3000" b="1">
-                <a:solidFill>
-                  <a:srgbClr val="0B1220"/>
-                </a:solidFill>
-                <a:latin typeface="Arial"/>
-              </a:rPr>
-              <a:t>Research: a zero-shot foundation-model baseline (D-054)</a:t>
-            </a:r>
-          </a:p>
-        </p:txBody>
-      </p:sp>
-      <p:cxnSp>
-        <p:nvCxnSpPr>
-          <p:cNvPr id="4" name="Connector 3"/>
-          <p:cNvCxnSpPr/>
-          <p:nvPr/>
-        </p:nvCxnSpPr>
-        <p:spPr>
-          <a:xfrm>
-            <a:off x="548640" y="987552"/>
-            <a:ext cx="11091672" cy="0"/>
-          </a:xfrm>
-          <a:prstGeom prst="line">
-            <a:avLst/>
-          </a:prstGeom>
-          <a:ln w="9525">
-            <a:solidFill>
-              <a:srgbClr val="E3E8EF"/>
-            </a:solidFill>
-          </a:ln>
-        </p:spPr>
-      </p:cxnSp>
-      <p:sp>
-        <p:nvSpPr>
-          <p:cNvPr id="5" name="TextBox 4"/>
-          <p:cNvSpPr txBox="1"/>
-          <p:nvPr/>
-        </p:nvSpPr>
-        <p:spPr>
-          <a:xfrm>
-            <a:off x="11247120" y="6446520"/>
-            <a:ext cx="457200" cy="274320"/>
-          </a:xfrm>
-          <a:prstGeom prst="rect">
-            <a:avLst/>
-          </a:prstGeom>
-          <a:noFill/>
-        </p:spPr>
-        <p:txBody>
-          <a:bodyPr wrap="square">
-            <a:spAutoFit/>
-          </a:bodyPr>
-          <a:lstStyle/>
-          <a:p>
-            <a:r>
-              <a:rPr sz="1100" b="0">
-                <a:solidFill>
-                  <a:srgbClr val="0B1220"/>
-                </a:solidFill>
-                <a:latin typeface="Arial"/>
-              </a:rPr>
-              <a:t>23</a:t>
-            </a:r>
-          </a:p>
-        </p:txBody>
-      </p:sp>
-      <p:sp>
-        <p:nvSpPr>
-          <p:cNvPr id="6" name="TextBox 5"/>
-          <p:cNvSpPr txBox="1"/>
-          <p:nvPr/>
-        </p:nvSpPr>
-        <p:spPr>
-          <a:xfrm>
-            <a:off x="548640" y="1234440"/>
-            <a:ext cx="11064240" cy="5120640"/>
-          </a:xfrm>
-          <a:prstGeom prst="rect">
-            <a:avLst/>
-          </a:prstGeom>
-          <a:noFill/>
-        </p:spPr>
-        <p:txBody>
-          <a:bodyPr wrap="square">
-            <a:spAutoFit/>
-          </a:bodyPr>
-          <a:lstStyle/>
-          <a:p>
-            <a:pPr>
-              <a:spcAft>
-                <a:spcPts val="1000"/>
-              </a:spcAft>
-            </a:pPr>
-            <a:r>
-              <a:rPr sz="1700">
-                <a:solidFill>
-                  <a:srgbClr val="0B1220"/>
-                </a:solidFill>
-                <a:latin typeface="Arial"/>
-              </a:rPr>
-              <a:t>•  What: amazon/chronos-bolt-tiny (pinned revision, 8.7 M parameters, apache-2.0), zero-shot on CGM only: each forecast origin is its own series of past readings; median forecast fixed in advance. Not fine-tuned, not a fusion model, not served. Its public pretraining data may include CGM recordings.</a:t>
-            </a:r>
-          </a:p>
-          <a:p>
-            <a:pPr>
-              <a:spcAft>
-                <a:spcPts val="1000"/>
-              </a:spcAft>
-            </a:pPr>
-            <a:r>
-              <a:rPr sz="1700">
-                <a:solidFill>
-                  <a:srgbClr val="0B1220"/>
-                </a:solidFill>
-                <a:latin typeface="Arial"/>
-              </a:rPr>
-              <a:t>•  Against carrying the last reading forward, on identical origins: -0.79 [-1.01, -0.59] mg/dL at 30 min and -1.54 [-1.81, -1.30] at 60 min (macro MAE 22.92 vs 24.47; lower for 14 of 14 people).</a:t>
-            </a:r>
-          </a:p>
-          <a:p>
-            <a:pPr>
-              <a:spcAft>
-                <a:spcPts val="1000"/>
-              </a:spcAft>
-            </a:pPr>
-            <a:r>
-              <a:rPr sz="1700">
-                <a:solidFill>
-                  <a:srgbClr val="0B1220"/>
-                </a:solidFill>
-                <a:latin typeface="Arial"/>
-              </a:rPr>
-              <a:t>•  Against the serving recipe refitted with each person held out (saved from D-052): +0.42 [-0.70, +1.47] mg/dL at 60 min (22.92 vs 22.50) — not better, and clearly worse on readings above 180.</a:t>
-            </a:r>
-          </a:p>
-          <a:p>
-            <a:pPr>
-              <a:spcAft>
-                <a:spcPts val="1000"/>
-              </a:spcAft>
-            </a:pPr>
-            <a:r>
-              <a:rPr sz="1700">
-                <a:solidFill>
-                  <a:srgbClr val="0B1220"/>
-                </a:solidFill>
-                <a:latin typeface="Arial"/>
-              </a:rPr>
-              <a:t>•  Declared secondary: the foundation forecast plus a freshly fitted LightGBM residual on the served inputs, -0.46 [-0.72, -0.21] mg/dL at 60 min against the same-code refit. Descriptive only; not a release candidate.</a:t>
-            </a:r>
-          </a:p>
-          <a:p>
-            <a:pPr>
-              <a:spcAft>
-                <a:spcPts val="1000"/>
-              </a:spcAft>
-            </a:pPr>
-            <a:r>
-              <a:rPr sz="1700">
-                <a:solidFill>
-                  <a:srgbClr val="0B1220"/>
-                </a:solidFill>
-                <a:latin typeface="Arial"/>
-              </a:rPr>
-              <a:t>•  Declared before any participant forecast; the 14 people were inspected in earlier experiments, so this is an internal comparison, not independent confirmation.</a:t>
-            </a:r>
-          </a:p>
-        </p:txBody>
-      </p:sp>
-    </p:spTree>
-  </p:cSld>
-  <p:clrMapOvr>
-    <a:masterClrMapping/>
-  </p:clrMapOvr>
-</p:sld>
-</file>
-
-<file path=ppt/slides/slide24.xml><?xml version="1.0" encoding="utf-8"?>
-<p:sld xmlns:a="http://schemas.openxmlformats.org/drawingml/2006/main" xmlns:p="http://schemas.openxmlformats.org/presentationml/2006/main" xmlns:r="http://schemas.openxmlformats.org/officeDocument/2006/relationships">
-  <p:cSld>
-    <p:bg>
-      <p:bgPr>
-        <a:solidFill>
-          <a:srgbClr val="FFFFFF"/>
-        </a:solidFill>
-        <a:effectLst/>
-      </p:bgPr>
-    </p:bg>
-    <p:spTree>
-      <p:nvGrpSpPr>
-        <p:cNvPr id="1" name=""/>
-        <p:cNvGrpSpPr/>
-        <p:nvPr/>
-      </p:nvGrpSpPr>
-      <p:grpSpPr/>
-      <p:sp>
-        <p:nvSpPr>
-          <p:cNvPr id="2" name="TextBox 1"/>
-          <p:cNvSpPr txBox="1"/>
-          <p:nvPr/>
-        </p:nvSpPr>
-        <p:spPr>
-          <a:xfrm>
-            <a:off x="548640" y="128016"/>
-            <a:ext cx="11064240" cy="274320"/>
-          </a:xfrm>
-          <a:prstGeom prst="rect">
-            <a:avLst/>
-          </a:prstGeom>
-          <a:noFill/>
-        </p:spPr>
-        <p:txBody>
-          <a:bodyPr wrap="square">
-            <a:spAutoFit/>
-          </a:bodyPr>
-          <a:lstStyle/>
-          <a:p>
-            <a:r>
-              <a:rPr sz="1100" b="1">
-                <a:solidFill>
-                  <a:srgbClr val="2563EB"/>
-                </a:solidFill>
-                <a:latin typeface="Arial"/>
-              </a:rPr>
-              <a:t>RESEARCH · external cohort, CGM only · not the serving fusion model</a:t>
-            </a:r>
-          </a:p>
-        </p:txBody>
-      </p:sp>
-      <p:sp>
-        <p:nvSpPr>
-          <p:cNvPr id="3" name="TextBox 2"/>
-          <p:cNvSpPr txBox="1"/>
-          <p:nvPr/>
-        </p:nvSpPr>
-        <p:spPr>
-          <a:xfrm>
-            <a:off x="548640" y="384048"/>
-            <a:ext cx="11064240" cy="640080"/>
-          </a:xfrm>
-          <a:prstGeom prst="rect">
-            <a:avLst/>
-          </a:prstGeom>
-          <a:noFill/>
-        </p:spPr>
-        <p:txBody>
-          <a:bodyPr wrap="square">
-            <a:spAutoFit/>
-          </a:bodyPr>
-          <a:lstStyle/>
-          <a:p>
-            <a:r>
-              <a:rPr sz="3000" b="1">
-                <a:solidFill>
-                  <a:srgbClr val="0B1220"/>
-                </a:solidFill>
-                <a:latin typeface="Arial"/>
-              </a:rPr>
-              <a:t>External check: an independent Type 2 cohort</a:t>
-            </a:r>
-          </a:p>
-        </p:txBody>
-      </p:sp>
-      <p:cxnSp>
-        <p:nvCxnSpPr>
-          <p:cNvPr id="4" name="Connector 3"/>
-          <p:cNvCxnSpPr/>
-          <p:nvPr/>
-        </p:nvCxnSpPr>
-        <p:spPr>
-          <a:xfrm>
-            <a:off x="548640" y="987552"/>
-            <a:ext cx="11091672" cy="0"/>
-          </a:xfrm>
-          <a:prstGeom prst="line">
-            <a:avLst/>
-          </a:prstGeom>
-          <a:ln w="9525">
-            <a:solidFill>
-              <a:srgbClr val="E3E8EF"/>
-            </a:solidFill>
-          </a:ln>
-        </p:spPr>
-      </p:cxnSp>
-      <p:sp>
-        <p:nvSpPr>
-          <p:cNvPr id="5" name="TextBox 4"/>
-          <p:cNvSpPr txBox="1"/>
-          <p:nvPr/>
-        </p:nvSpPr>
-        <p:spPr>
-          <a:xfrm>
-            <a:off x="11247120" y="6446520"/>
-            <a:ext cx="457200" cy="274320"/>
-          </a:xfrm>
-          <a:prstGeom prst="rect">
-            <a:avLst/>
-          </a:prstGeom>
-          <a:noFill/>
-        </p:spPr>
-        <p:txBody>
-          <a:bodyPr wrap="square">
-            <a:spAutoFit/>
-          </a:bodyPr>
-          <a:lstStyle/>
-          <a:p>
-            <a:r>
-              <a:rPr sz="1100" b="0">
-                <a:solidFill>
-                  <a:srgbClr val="0B1220"/>
-                </a:solidFill>
-                <a:latin typeface="Arial"/>
-              </a:rPr>
-              <a:t>24</a:t>
-            </a:r>
-          </a:p>
-        </p:txBody>
-      </p:sp>
-      <p:sp>
-        <p:nvSpPr>
-          <p:cNvPr id="6" name="TextBox 5"/>
-          <p:cNvSpPr txBox="1"/>
-          <p:nvPr/>
-        </p:nvSpPr>
-        <p:spPr>
-          <a:xfrm>
-            <a:off x="548640" y="1234440"/>
-            <a:ext cx="11064240" cy="5120640"/>
-          </a:xfrm>
-          <a:prstGeom prst="rect">
-            <a:avLst/>
-          </a:prstGeom>
-          <a:noFill/>
-        </p:spPr>
-        <p:txBody>
-          <a:bodyPr wrap="square">
-            <a:spAutoFit/>
-          </a:bodyPr>
-          <a:lstStyle/>
-          <a:p>
-            <a:pPr>
-              <a:spcAft>
-                <a:spcPts val="1000"/>
-              </a:spcAft>
-            </a:pPr>
-            <a:r>
-              <a:rPr sz="1700">
-                <a:solidFill>
-                  <a:srgbClr val="0B1220"/>
-                </a:solidFill>
-                <a:latin typeface="Arial"/>
-              </a:rPr>
-              <a:t>•  Who: 98 adults with Type 2 diabetes in ShanghaiT2DM (China, FreeStyle Libre H, 15-minute readings), never trained on. No wearable or dated labs, so this checks the forecasting core only, not the fusion.</a:t>
-            </a:r>
-          </a:p>
-          <a:p>
-            <a:pPr>
-              <a:spcAft>
-                <a:spcPts val="1000"/>
-              </a:spcAft>
-            </a:pPr>
-            <a:r>
-              <a:rPr sz="1700">
-                <a:solidFill>
-                  <a:srgbClr val="0B1220"/>
-                </a:solidFill>
-                <a:latin typeface="Arial"/>
-              </a:rPr>
-              <a:t>•  What: a separate 15-minute LightGBM on CGM-only features, developed on CGMacros. It is not the serving fusion model and not the Ridge candidate.</a:t>
-            </a:r>
-          </a:p>
-          <a:p>
-            <a:pPr>
-              <a:spcAft>
-                <a:spcPts val="1000"/>
-              </a:spcAft>
-            </a:pPr>
-            <a:r>
-              <a:rPr sz="1700">
-                <a:solidFill>
-                  <a:srgbClr val="0B1220"/>
-                </a:solidFill>
-                <a:latin typeface="Arial"/>
-              </a:rPr>
-              <a:t>•  30 / 60 minutes (D-032, the cohort's first opening): -0.99 [-1.21, -0.77] mg/dL at 30 min (clear) and -0.34 [-0.76, +0.10] mg/dL at 60 min (inconclusive), versus carrying the last reading forward.</a:t>
-            </a:r>
-          </a:p>
-          <a:p>
-            <a:pPr>
-              <a:spcAft>
-                <a:spcPts val="1000"/>
-              </a:spcAft>
-            </a:pPr>
-            <a:r>
-              <a:rPr sz="1700">
-                <a:solidFill>
-                  <a:srgbClr val="0B1220"/>
-                </a:solidFill>
-                <a:latin typeface="Arial"/>
-              </a:rPr>
-              <a:t>•  Two hours ahead (D-045, declared before any fit; its first 120-minute assessment and the cohort's second opening): 29.6 vs persistence 31.7 mg/dL at 120 min (-2.12 [-2.67, -1.53]), better for 78 of 98 people.</a:t>
-            </a:r>
-          </a:p>
-          <a:p>
-            <a:pPr>
-              <a:spcAft>
-                <a:spcPts val="1000"/>
-              </a:spcAft>
-            </a:pPr>
-            <a:r>
-              <a:rPr sz="1700">
-                <a:solidFill>
-                  <a:srgbClr val="0B1220"/>
-                </a:solidFill>
-                <a:latin typeface="Arial"/>
-              </a:rPr>
-              <a:t>•  Nothing was chosen on this cohort; other frozen pipelines were reported but not adopted, because choosing on it would turn it into a tuning set.</a:t>
-            </a:r>
-          </a:p>
-        </p:txBody>
-      </p:sp>
-    </p:spTree>
-  </p:cSld>
-  <p:clrMapOvr>
-    <a:masterClrMapping/>
-  </p:clrMapOvr>
-</p:sld>
-</file>
-
-<file path=ppt/slides/slide25.xml><?xml version="1.0" encoding="utf-8"?>
-<p:sld xmlns:a="http://schemas.openxmlformats.org/drawingml/2006/main" xmlns:p="http://schemas.openxmlformats.org/presentationml/2006/main" xmlns:r="http://schemas.openxmlformats.org/officeDocument/2006/relationships">
-  <p:cSld>
-    <p:bg>
-      <p:bgPr>
-        <a:solidFill>
-          <a:srgbClr val="FFFFFF"/>
-        </a:solidFill>
-        <a:effectLst/>
-      </p:bgPr>
-    </p:bg>
-    <p:spTree>
-      <p:nvGrpSpPr>
-        <p:cNvPr id="1" name=""/>
-        <p:cNvGrpSpPr/>
-        <p:nvPr/>
-      </p:nvGrpSpPr>
-      <p:grpSpPr/>
-      <p:sp>
-        <p:nvSpPr>
-          <p:cNvPr id="2" name="TextBox 1"/>
-          <p:cNvSpPr txBox="1"/>
-          <p:nvPr/>
-        </p:nvSpPr>
-        <p:spPr>
-          <a:xfrm>
-            <a:off x="548640" y="320040"/>
-            <a:ext cx="11064240" cy="640080"/>
-          </a:xfrm>
-          <a:prstGeom prst="rect">
-            <a:avLst/>
-          </a:prstGeom>
-          <a:noFill/>
-        </p:spPr>
-        <p:txBody>
-          <a:bodyPr wrap="square">
-            <a:spAutoFit/>
-          </a:bodyPr>
-          <a:lstStyle/>
-          <a:p>
-            <a:r>
-              <a:rPr sz="3000" b="1">
-                <a:solidFill>
-                  <a:srgbClr val="0B1220"/>
-                </a:solidFill>
-                <a:latin typeface="Arial"/>
-              </a:rPr>
-              <a:t>Project outcomes</a:t>
-            </a:r>
-          </a:p>
-        </p:txBody>
-      </p:sp>
-      <p:cxnSp>
-        <p:nvCxnSpPr>
-          <p:cNvPr id="3" name="Connector 2"/>
-          <p:cNvCxnSpPr/>
-          <p:nvPr/>
-        </p:nvCxnSpPr>
-        <p:spPr>
-          <a:xfrm>
-            <a:off x="548640" y="987552"/>
-            <a:ext cx="11091672" cy="0"/>
-          </a:xfrm>
-          <a:prstGeom prst="line">
-            <a:avLst/>
-          </a:prstGeom>
-          <a:ln w="9525">
-            <a:solidFill>
-              <a:srgbClr val="E3E8EF"/>
-            </a:solidFill>
-          </a:ln>
-        </p:spPr>
-      </p:cxnSp>
-      <p:sp>
-        <p:nvSpPr>
-          <p:cNvPr id="4" name="TextBox 3"/>
-          <p:cNvSpPr txBox="1"/>
-          <p:nvPr/>
-        </p:nvSpPr>
-        <p:spPr>
-          <a:xfrm>
-            <a:off x="11247120" y="6446520"/>
-            <a:ext cx="457200" cy="274320"/>
-          </a:xfrm>
-          <a:prstGeom prst="rect">
-            <a:avLst/>
-          </a:prstGeom>
-          <a:noFill/>
-        </p:spPr>
-        <p:txBody>
-          <a:bodyPr wrap="square">
-            <a:spAutoFit/>
-          </a:bodyPr>
-          <a:lstStyle/>
-          <a:p>
-            <a:r>
-              <a:rPr sz="1100" b="0">
-                <a:solidFill>
-                  <a:srgbClr val="0B1220"/>
-                </a:solidFill>
-                <a:latin typeface="Arial"/>
-              </a:rPr>
-              <a:t>25</a:t>
-            </a:r>
-          </a:p>
-        </p:txBody>
-      </p:sp>
-      <p:sp>
-        <p:nvSpPr>
-          <p:cNvPr id="5" name="TextBox 4"/>
-          <p:cNvSpPr txBox="1"/>
-          <p:nvPr/>
-        </p:nvSpPr>
-        <p:spPr>
-          <a:xfrm>
-            <a:off x="548640" y="1234440"/>
-            <a:ext cx="11064240" cy="5120640"/>
-          </a:xfrm>
-          <a:prstGeom prst="rect">
-            <a:avLst/>
-          </a:prstGeom>
-          <a:noFill/>
-        </p:spPr>
-        <p:txBody>
-          <a:bodyPr wrap="square">
-            <a:spAutoFit/>
-          </a:bodyPr>
-          <a:lstStyle/>
-          <a:p>
-            <a:pPr>
-              <a:spcAft>
-                <a:spcPts val="1000"/>
-              </a:spcAft>
-            </a:pPr>
-            <a:r>
-              <a:rPr sz="1700">
-                <a:solidFill>
-                  <a:srgbClr val="0B1220"/>
-                </a:solidFill>
-                <a:latin typeface="Arial"/>
-              </a:rPr>
-              <a:t>•  Built: a working personalized glucose twin — replay API with a backend-owned clock, immutable forecasts, research warnings with outcomes — and a clinician workspace (landing page, Overview, Participants, Replay sessions, Model evidence, Data quality).</a:t>
-            </a:r>
-          </a:p>
-          <a:p>
-            <a:pPr>
-              <a:spcAft>
-                <a:spcPts val="1000"/>
-              </a:spcAft>
-            </a:pPr>
-            <a:r>
-              <a:rPr sz="1700">
-                <a:solidFill>
-                  <a:srgbClr val="0B1220"/>
-                </a:solidFill>
-                <a:latin typeface="Arial"/>
-              </a:rPr>
-              <a:t>•  Found and corrected a data-provenance problem: the published 1-minute CGM values are interpolated; only native 5-minute readings are used.</a:t>
-            </a:r>
-          </a:p>
-          <a:p>
-            <a:pPr>
-              <a:spcAft>
-                <a:spcPts val="1000"/>
-              </a:spcAft>
-            </a:pPr>
-            <a:r>
-              <a:rPr sz="1700">
-                <a:solidFill>
-                  <a:srgbClr val="0B1220"/>
-                </a:solidFill>
-                <a:latin typeface="Arial"/>
-              </a:rPr>
-              <a:t>•  Measured on later recordings of the same participants (retrospective): 14/14 participants improved over persistence at 30 min and 13/14 at 60 min; MAE 12.96 / 20.26 mg/dL vs 14.84 / 23.23.</a:t>
-            </a:r>
-          </a:p>
-          <a:p>
-            <a:pPr>
-              <a:spcAft>
-                <a:spcPts val="1000"/>
-              </a:spcAft>
-            </a:pPr>
-            <a:r>
-              <a:rPr sz="1700">
-                <a:solidFill>
-                  <a:srgbClr val="0B1220"/>
-                </a:solidFill>
-                <a:latin typeface="Arial"/>
-              </a:rPr>
-              <a:t>•  Personalization: small gains (-0.18 mg/dL and -0.33 mg/dL). Warnings: 61/64 onsets detected with 40 false alarms (1.49 per observed patient-day); 48.4 % of all onsets warned at least 30 min ahead — the F1 threshold rule ignores review workload.</a:t>
-            </a:r>
-          </a:p>
-          <a:p>
-            <a:pPr>
-              <a:spcAft>
-                <a:spcPts val="1000"/>
-              </a:spcAft>
-            </a:pPr>
-            <a:r>
-              <a:rPr sz="1700">
-                <a:solidFill>
-                  <a:srgbClr val="0B1220"/>
-                </a:solidFill>
-                <a:latin typeface="Arial"/>
-              </a:rPr>
-              <a:t>•  Corrected after an independent review (activity-window defect, online warning double-credit; gt-primary-2026-10-11-v1 preserved), then re-run with the fusion constraint (gt-primary-2026-10-13-fusion); the dynamic-only model of gt-primary-2026-10-11-v2 stays registered for rollback.</a:t>
-            </a:r>
-          </a:p>
-          <a:p>
-            <a:pPr>
-              <a:spcAft>
-                <a:spcPts val="1000"/>
-              </a:spcAft>
-            </a:pPr>
-            <a:r>
-              <a:rPr sz="1700">
-                <a:solidFill>
-                  <a:srgbClr val="0B1220"/>
-                </a:solidFill>
-                <a:latin typeface="Arial"/>
-              </a:rPr>
-              <a:t>•  Reproducible: synthetic mode needs no download; recorded-data results regenerate from versioned configs; a fresh copy passes the automated backend, frontend and browser tests.</a:t>
-            </a:r>
-          </a:p>
-        </p:txBody>
-      </p:sp>
-    </p:spTree>
-  </p:cSld>
-  <p:clrMapOvr>
-    <a:masterClrMapping/>
-  </p:clrMapOvr>
-</p:sld>
-</file>
-
-<file path=ppt/slides/slide26.xml><?xml version="1.0" encoding="utf-8"?>
-<p:sld xmlns:a="http://schemas.openxmlformats.org/drawingml/2006/main" xmlns:p="http://schemas.openxmlformats.org/presentationml/2006/main" xmlns:r="http://schemas.openxmlformats.org/officeDocument/2006/relationships">
-  <p:cSld>
-    <p:bg>
-      <p:bgPr>
-        <a:solidFill>
-          <a:srgbClr val="FFFFFF"/>
-        </a:solidFill>
-        <a:effectLst/>
-      </p:bgPr>
-    </p:bg>
-    <p:spTree>
-      <p:nvGrpSpPr>
-        <p:cNvPr id="1" name=""/>
-        <p:cNvGrpSpPr/>
-        <p:nvPr/>
-      </p:nvGrpSpPr>
-      <p:grpSpPr/>
-      <p:sp>
-        <p:nvSpPr>
-          <p:cNvPr id="2" name="TextBox 1"/>
-          <p:cNvSpPr txBox="1"/>
-          <p:nvPr/>
-        </p:nvSpPr>
-        <p:spPr>
-          <a:xfrm>
-            <a:off x="548640" y="320040"/>
-            <a:ext cx="11064240" cy="640080"/>
-          </a:xfrm>
-          <a:prstGeom prst="rect">
-            <a:avLst/>
-          </a:prstGeom>
-          <a:noFill/>
-        </p:spPr>
-        <p:txBody>
-          <a:bodyPr wrap="square">
-            <a:spAutoFit/>
-          </a:bodyPr>
-          <a:lstStyle/>
-          <a:p>
-            <a:r>
-              <a:rPr sz="3000" b="1">
-                <a:solidFill>
-                  <a:srgbClr val="0B1220"/>
-                </a:solidFill>
-                <a:latin typeface="Arial"/>
-              </a:rPr>
-              <a:t>Limitations</a:t>
-            </a:r>
-          </a:p>
-        </p:txBody>
-      </p:sp>
-      <p:cxnSp>
-        <p:nvCxnSpPr>
-          <p:cNvPr id="3" name="Connector 2"/>
-          <p:cNvCxnSpPr/>
-          <p:nvPr/>
-        </p:nvCxnSpPr>
-        <p:spPr>
-          <a:xfrm>
-            <a:off x="548640" y="987552"/>
-            <a:ext cx="11091672" cy="0"/>
-          </a:xfrm>
-          <a:prstGeom prst="line">
-            <a:avLst/>
-          </a:prstGeom>
-          <a:ln w="9525">
-            <a:solidFill>
-              <a:srgbClr val="E3E8EF"/>
-            </a:solidFill>
-          </a:ln>
-        </p:spPr>
-      </p:cxnSp>
-      <p:sp>
-        <p:nvSpPr>
-          <p:cNvPr id="4" name="TextBox 3"/>
-          <p:cNvSpPr txBox="1"/>
-          <p:nvPr/>
-        </p:nvSpPr>
-        <p:spPr>
-          <a:xfrm>
-            <a:off x="11247120" y="6446520"/>
-            <a:ext cx="457200" cy="274320"/>
-          </a:xfrm>
-          <a:prstGeom prst="rect">
-            <a:avLst/>
-          </a:prstGeom>
-          <a:noFill/>
-        </p:spPr>
-        <p:txBody>
-          <a:bodyPr wrap="square">
-            <a:spAutoFit/>
-          </a:bodyPr>
-          <a:lstStyle/>
-          <a:p>
-            <a:r>
-              <a:rPr sz="1100" b="0">
-                <a:solidFill>
-                  <a:srgbClr val="0B1220"/>
-                </a:solidFill>
-                <a:latin typeface="Arial"/>
-              </a:rPr>
-              <a:t>26</a:t>
-            </a:r>
-          </a:p>
-        </p:txBody>
-      </p:sp>
-      <p:sp>
-        <p:nvSpPr>
-          <p:cNvPr id="5" name="TextBox 4"/>
-          <p:cNvSpPr txBox="1"/>
-          <p:nvPr/>
-        </p:nvSpPr>
-        <p:spPr>
-          <a:xfrm>
-            <a:off x="548640" y="1234440"/>
-            <a:ext cx="11064240" cy="5120640"/>
-          </a:xfrm>
-          <a:prstGeom prst="rect">
-            <a:avLst/>
-          </a:prstGeom>
-          <a:noFill/>
-        </p:spPr>
-        <p:txBody>
-          <a:bodyPr wrap="square">
-            <a:spAutoFit/>
-          </a:bodyPr>
-          <a:lstStyle/>
-          <a:p>
-            <a:pPr>
-              <a:spcAft>
-                <a:spcPts val="1000"/>
-              </a:spcAft>
-            </a:pPr>
-            <a:r>
-              <a:rPr sz="1550">
-                <a:solidFill>
-                  <a:srgbClr val="0B1220"/>
-                </a:solidFill>
-                <a:latin typeface="Arial"/>
-              </a:rPr>
-              <a:t>•  14 participants from one US site; overlapping windows are not independent patients.</a:t>
-            </a:r>
-          </a:p>
-          <a:p>
-            <a:pPr>
-              <a:spcAft>
-                <a:spcPts val="1000"/>
-              </a:spcAft>
-            </a:pPr>
-            <a:r>
-              <a:rPr sz="1550">
-                <a:solidFill>
-                  <a:srgbClr val="0B1220"/>
-                </a:solidFill>
-                <a:latin typeface="Arial"/>
-              </a:rPr>
-              <a:t>•  No Indian participants — nothing here establishes performance for patients in India.</a:t>
-            </a:r>
-          </a:p>
-          <a:p>
-            <a:pPr>
-              <a:spcAft>
-                <a:spcPts val="1000"/>
-              </a:spcAft>
-            </a:pPr>
-            <a:r>
-              <a:rPr sz="1550">
-                <a:solidFill>
-                  <a:srgbClr val="0B1220"/>
-                </a:solidFill>
-                <a:latin typeface="Arial"/>
-              </a:rPr>
-              <a:t>•  Blinded research CGMs replayed with assumed zero latency; native timestamps known to the minute.</a:t>
-            </a:r>
-          </a:p>
-          <a:p>
-            <a:pPr>
-              <a:spcAft>
-                <a:spcPts val="1000"/>
-              </a:spcAft>
-            </a:pPr>
-            <a:r>
-              <a:rPr sz="1550">
-                <a:solidFill>
-                  <a:srgbClr val="0B1220"/>
-                </a:solidFill>
-                <a:latin typeface="Arial"/>
-              </a:rPr>
-              <a:t>•  Medication and insulin use unknown; meal logging time undocumented.</a:t>
-            </a:r>
-          </a:p>
-          <a:p>
-            <a:pPr>
-              <a:spcAft>
-                <a:spcPts val="1000"/>
-              </a:spcAft>
-            </a:pPr>
-            <a:r>
-              <a:rPr sz="1550">
-                <a:solidFill>
-                  <a:srgbClr val="0B1220"/>
-                </a:solidFill>
-                <a:latin typeface="Arial"/>
-              </a:rPr>
-              <a:t>•  Profile fusion: profile values are constant per person, so with 14 people they can act as an identity code; no benefit was shown on people held out entirely.</a:t>
-            </a:r>
-          </a:p>
-          <a:p>
-            <a:pPr>
-              <a:spcAft>
-                <a:spcPts val="1000"/>
-              </a:spcAft>
-            </a:pPr>
-            <a:r>
-              <a:rPr sz="1550">
-                <a:solidFill>
-                  <a:srgbClr val="0B1220"/>
-                </a:solidFill>
-                <a:latin typeface="Arial"/>
-              </a:rPr>
-              <a:t>•  Prediction ranges under-cover; the warning score is uncalibrated and its threshold rule (F1) ignores review workload; 180 mg/dL is a research threshold, not triage.</a:t>
-            </a:r>
-          </a:p>
-          <a:p>
-            <a:pPr>
-              <a:spcAft>
-                <a:spcPts val="1000"/>
-              </a:spcAft>
-            </a:pPr>
-            <a:r>
-              <a:rPr sz="1550">
-                <a:solidFill>
-                  <a:srgbClr val="0B1220"/>
-                </a:solidFill>
-                <a:latin typeface="Arial"/>
-              </a:rPr>
-              <a:t>•  Retrospective replay only: no clinician workflow, outcome or safety study. The foundation-model baseline was zero-shot only; fine-tuning was not run.</a:t>
-            </a:r>
-          </a:p>
-          <a:p>
-            <a:pPr>
-              <a:spcAft>
-                <a:spcPts val="1000"/>
-              </a:spcAft>
-            </a:pPr>
-            <a:r>
-              <a:rPr sz="1550">
-                <a:solidFill>
-                  <a:srgbClr val="0B1220"/>
-                </a:solidFill>
-                <a:latin typeface="Arial"/>
-              </a:rPr>
-              <a:t>•  Scores depend on the dataset, prediction task and evaluation protocol; performance on simulated patients does not establish performance on real patients.</a:t>
-            </a:r>
-          </a:p>
-        </p:txBody>
-      </p:sp>
-    </p:spTree>
-  </p:cSld>
-  <p:clrMapOvr>
-    <a:masterClrMapping/>
-  </p:clrMapOvr>
-</p:sld>
-</file>
-
-<file path=ppt/slides/slide27.xml><?xml version="1.0" encoding="utf-8"?>
-<p:sld xmlns:a="http://schemas.openxmlformats.org/drawingml/2006/main" xmlns:p="http://schemas.openxmlformats.org/presentationml/2006/main" xmlns:r="http://schemas.openxmlformats.org/officeDocument/2006/relationships">
-  <p:cSld>
-    <p:bg>
-      <p:bgPr>
-        <a:solidFill>
-          <a:srgbClr val="FFFFFF"/>
-        </a:solidFill>
-        <a:effectLst/>
-      </p:bgPr>
-    </p:bg>
-    <p:spTree>
-      <p:nvGrpSpPr>
-        <p:cNvPr id="1" name=""/>
-        <p:cNvGrpSpPr/>
-        <p:nvPr/>
-      </p:nvGrpSpPr>
-      <p:grpSpPr/>
-      <p:sp>
-        <p:nvSpPr>
-          <p:cNvPr id="2" name="TextBox 1"/>
-          <p:cNvSpPr txBox="1"/>
-          <p:nvPr/>
-        </p:nvSpPr>
-        <p:spPr>
-          <a:xfrm>
-            <a:off x="548640" y="320040"/>
-            <a:ext cx="11064240" cy="640080"/>
-          </a:xfrm>
-          <a:prstGeom prst="rect">
-            <a:avLst/>
-          </a:prstGeom>
-          <a:noFill/>
-        </p:spPr>
-        <p:txBody>
-          <a:bodyPr wrap="square">
-            <a:spAutoFit/>
-          </a:bodyPr>
-          <a:lstStyle/>
-          <a:p>
-            <a:r>
-              <a:rPr sz="3000" b="1">
-                <a:solidFill>
-                  <a:srgbClr val="0B1220"/>
-                </a:solidFill>
-                <a:latin typeface="Arial"/>
-              </a:rPr>
-              <a:t>Next steps: evidence needed for Indian patients</a:t>
-            </a:r>
-          </a:p>
-        </p:txBody>
-      </p:sp>
-      <p:cxnSp>
-        <p:nvCxnSpPr>
-          <p:cNvPr id="3" name="Connector 2"/>
-          <p:cNvCxnSpPr/>
-          <p:nvPr/>
-        </p:nvCxnSpPr>
-        <p:spPr>
-          <a:xfrm>
-            <a:off x="548640" y="987552"/>
-            <a:ext cx="11091672" cy="0"/>
-          </a:xfrm>
-          <a:prstGeom prst="line">
-            <a:avLst/>
-          </a:prstGeom>
-          <a:ln w="9525">
-            <a:solidFill>
-              <a:srgbClr val="E3E8EF"/>
-            </a:solidFill>
-          </a:ln>
-        </p:spPr>
-      </p:cxnSp>
-      <p:sp>
-        <p:nvSpPr>
-          <p:cNvPr id="4" name="TextBox 3"/>
-          <p:cNvSpPr txBox="1"/>
-          <p:nvPr/>
-        </p:nvSpPr>
-        <p:spPr>
-          <a:xfrm>
-            <a:off x="11247120" y="6446520"/>
-            <a:ext cx="457200" cy="274320"/>
-          </a:xfrm>
-          <a:prstGeom prst="rect">
-            <a:avLst/>
-          </a:prstGeom>
-          <a:noFill/>
-        </p:spPr>
-        <p:txBody>
-          <a:bodyPr wrap="square">
-            <a:spAutoFit/>
-          </a:bodyPr>
-          <a:lstStyle/>
-          <a:p>
-            <a:r>
-              <a:rPr sz="1100" b="0">
-                <a:solidFill>
-                  <a:srgbClr val="0B1220"/>
-                </a:solidFill>
-                <a:latin typeface="Arial"/>
-              </a:rPr>
-              <a:t>27</a:t>
-            </a:r>
-          </a:p>
-        </p:txBody>
-      </p:sp>
-      <p:sp>
-        <p:nvSpPr>
-          <p:cNvPr id="5" name="TextBox 4"/>
-          <p:cNvSpPr txBox="1"/>
-          <p:nvPr/>
-        </p:nvSpPr>
-        <p:spPr>
-          <a:xfrm>
-            <a:off x="548640" y="1234440"/>
-            <a:ext cx="11064240" cy="5120640"/>
-          </a:xfrm>
-          <a:prstGeom prst="rect">
-            <a:avLst/>
-          </a:prstGeom>
-          <a:noFill/>
-        </p:spPr>
-        <p:txBody>
-          <a:bodyPr wrap="square">
-            <a:spAutoFit/>
-          </a:bodyPr>
-          <a:lstStyle/>
-          <a:p>
-            <a:pPr>
-              <a:spcAft>
-                <a:spcPts val="1000"/>
-              </a:spcAft>
-            </a:pPr>
-            <a:r>
-              <a:rPr sz="1700">
-                <a:solidFill>
-                  <a:srgbClr val="0B1220"/>
-                </a:solidFill>
-                <a:latin typeface="Arial"/>
-              </a:rPr>
-              <a:t>•  Prospective, consented Indian cohort with unblinded CGMs, recorded transmission latency, medications and meal logging times.</a:t>
-            </a:r>
-          </a:p>
-          <a:p>
-            <a:pPr>
-              <a:spcAft>
-                <a:spcPts val="1000"/>
-              </a:spcAft>
-            </a:pPr>
-            <a:r>
-              <a:rPr sz="1700">
-                <a:solidFill>
-                  <a:srgbClr val="0B1220"/>
-                </a:solidFill>
-                <a:latin typeface="Arial"/>
-              </a:rPr>
-              <a:t>•  Re-evaluate held-out participants (cold start) and per-site calibration; report subgroup performance.</a:t>
-            </a:r>
-          </a:p>
-          <a:p>
-            <a:pPr>
-              <a:spcAft>
-                <a:spcPts val="1000"/>
-              </a:spcAft>
-            </a:pPr>
-            <a:r>
-              <a:rPr sz="1700">
-                <a:solidFill>
-                  <a:srgbClr val="0B1220"/>
-                </a:solidFill>
-                <a:latin typeface="Arial"/>
-              </a:rPr>
-              <a:t>•  AI-READI five-minute CGM and wearable data (access not yet requested; steps listed) for a larger new-person evaluation under the declared protocol gt-nested-2026-10-12-v2.</a:t>
-            </a:r>
-          </a:p>
-          <a:p>
-            <a:pPr>
-              <a:spcAft>
-                <a:spcPts val="1000"/>
-              </a:spcAft>
-            </a:pPr>
-            <a:r>
-              <a:rPr sz="1700">
-                <a:solidFill>
-                  <a:srgbClr val="0B1220"/>
-                </a:solidFill>
-                <a:latin typeface="Arial"/>
-              </a:rPr>
-              <a:t>•  Clinician usability study of the review workflow; regulatory and data-protection review (DPDP Act).</a:t>
-            </a:r>
-          </a:p>
-          <a:p>
-            <a:pPr>
-              <a:spcAft>
-                <a:spcPts val="1000"/>
-              </a:spcAft>
-            </a:pPr>
-            <a:r>
-              <a:rPr sz="1700">
-                <a:solidFill>
-                  <a:srgbClr val="0B1220"/>
-                </a:solidFill>
-                <a:latin typeface="Arial"/>
-              </a:rPr>
-              <a:t>•  Optional: fine-tune a time-series foundation model inside each training boundary and compare it under the same protocol (zero-shot only so far, D-054).</a:t>
-            </a:r>
-          </a:p>
-        </p:txBody>
-      </p:sp>
-    </p:spTree>
-  </p:cSld>
-  <p:clrMapOvr>
-    <a:masterClrMapping/>
-  </p:clrMapOvr>
-</p:sld>
-</file>
-
-<file path=ppt/slides/slide28.xml><?xml version="1.0" encoding="utf-8"?>
-<p:sld xmlns:a="http://schemas.openxmlformats.org/drawingml/2006/main" xmlns:p="http://schemas.openxmlformats.org/presentationml/2006/main" xmlns:r="http://schemas.openxmlformats.org/officeDocument/2006/relationships">
-  <p:cSld>
-    <p:bg>
-      <p:bgPr>
-        <a:solidFill>
-          <a:srgbClr val="FFFFFF"/>
-        </a:solidFill>
-        <a:effectLst/>
-      </p:bgPr>
-    </p:bg>
-    <p:spTree>
-      <p:nvGrpSpPr>
-        <p:cNvPr id="1" name=""/>
-        <p:cNvGrpSpPr/>
-        <p:nvPr/>
-      </p:nvGrpSpPr>
-      <p:grpSpPr/>
-      <p:sp>
-        <p:nvSpPr>
-          <p:cNvPr id="2" name="TextBox 1"/>
-          <p:cNvSpPr txBox="1"/>
-          <p:nvPr/>
-        </p:nvSpPr>
-        <p:spPr>
-          <a:xfrm>
-            <a:off x="548640" y="320040"/>
-            <a:ext cx="11064240" cy="640080"/>
-          </a:xfrm>
-          <a:prstGeom prst="rect">
-            <a:avLst/>
-          </a:prstGeom>
-          <a:noFill/>
-        </p:spPr>
-        <p:txBody>
-          <a:bodyPr wrap="square">
-            <a:spAutoFit/>
-          </a:bodyPr>
-          <a:lstStyle/>
-          <a:p>
-            <a:r>
-              <a:rPr sz="3000" b="1">
-                <a:solidFill>
-                  <a:srgbClr val="0B1220"/>
-                </a:solidFill>
-                <a:latin typeface="Arial"/>
-              </a:rPr>
-              <a:t>Team, links, reproducibility and licenses</a:t>
-            </a:r>
-          </a:p>
-        </p:txBody>
-      </p:sp>
-      <p:cxnSp>
-        <p:nvCxnSpPr>
-          <p:cNvPr id="3" name="Connector 2"/>
-          <p:cNvCxnSpPr/>
-          <p:nvPr/>
-        </p:nvCxnSpPr>
-        <p:spPr>
-          <a:xfrm>
-            <a:off x="548640" y="987552"/>
-            <a:ext cx="11091672" cy="0"/>
-          </a:xfrm>
-          <a:prstGeom prst="line">
-            <a:avLst/>
-          </a:prstGeom>
-          <a:ln w="9525">
-            <a:solidFill>
-              <a:srgbClr val="E3E8EF"/>
-            </a:solidFill>
-          </a:ln>
-        </p:spPr>
-      </p:cxnSp>
-      <p:sp>
-        <p:nvSpPr>
-          <p:cNvPr id="4" name="TextBox 3"/>
-          <p:cNvSpPr txBox="1"/>
-          <p:nvPr/>
-        </p:nvSpPr>
-        <p:spPr>
-          <a:xfrm>
-            <a:off x="11247120" y="6446520"/>
-            <a:ext cx="457200" cy="274320"/>
-          </a:xfrm>
-          <a:prstGeom prst="rect">
-            <a:avLst/>
-          </a:prstGeom>
-          <a:noFill/>
-        </p:spPr>
-        <p:txBody>
-          <a:bodyPr wrap="square">
-            <a:spAutoFit/>
-          </a:bodyPr>
-          <a:lstStyle/>
-          <a:p>
-            <a:r>
-              <a:rPr sz="1100" b="0">
-                <a:solidFill>
-                  <a:srgbClr val="0B1220"/>
-                </a:solidFill>
-                <a:latin typeface="Arial"/>
-              </a:rPr>
-              <a:t>28</a:t>
-            </a:r>
-          </a:p>
-        </p:txBody>
-      </p:sp>
-      <p:sp>
-        <p:nvSpPr>
-          <p:cNvPr id="5" name="TextBox 4"/>
-          <p:cNvSpPr txBox="1"/>
-          <p:nvPr/>
-        </p:nvSpPr>
-        <p:spPr>
-          <a:xfrm>
-            <a:off x="548640" y="1234440"/>
-            <a:ext cx="11064240" cy="5120640"/>
-          </a:xfrm>
-          <a:prstGeom prst="rect">
-            <a:avLst/>
-          </a:prstGeom>
-          <a:noFill/>
-        </p:spPr>
-        <p:txBody>
-          <a:bodyPr wrap="square">
-            <a:spAutoFit/>
-          </a:bodyPr>
-          <a:lstStyle/>
-          <a:p>
-            <a:pPr>
-              <a:spcAft>
-                <a:spcPts val="1000"/>
-              </a:spcAft>
-            </a:pPr>
-            <a:r>
-              <a:rPr sz="1700">
-                <a:solidFill>
-                  <a:srgbClr val="0B1220"/>
-                </a:solidFill>
-                <a:latin typeface="Arial"/>
-              </a:rPr>
-              <a:t>•  Team Kryptonite — Avinash Gehi (team leader) · Hardik Hinduja. Vivekanand Education Society's Institute of Technology (VESIT), Mumbai.</a:t>
-            </a:r>
-          </a:p>
-          <a:p>
-            <a:pPr>
-              <a:spcAft>
-                <a:spcPts val="1000"/>
-              </a:spcAft>
-            </a:pPr>
-            <a:r>
-              <a:rPr sz="1700">
-                <a:solidFill>
-                  <a:srgbClr val="0B1220"/>
-                </a:solidFill>
-                <a:latin typeface="Arial"/>
-              </a:rPr>
-              <a:t>•  Code: public GitHub link — added after the team publishes the repository — MIT license (code only). Quick start: make setup · make synthetic · make dev.</a:t>
-            </a:r>
-          </a:p>
-          <a:p>
-            <a:pPr>
-              <a:spcAft>
-                <a:spcPts val="1000"/>
-              </a:spcAft>
-            </a:pPr>
-            <a:r>
-              <a:rPr sz="1700">
-                <a:solidFill>
-                  <a:srgbClr val="0B1220"/>
-                </a:solidFill>
-                <a:latin typeface="Arial"/>
-              </a:rPr>
-              <a:t>•  Demo video (at least 20 minutes): unlisted YouTube link — added after recording and upload. Architecture: docs/submission/GlucoTwin_Architecture.pdf.</a:t>
-            </a:r>
-          </a:p>
-          <a:p>
-            <a:pPr>
-              <a:spcAft>
-                <a:spcPts val="1000"/>
-              </a:spcAft>
-            </a:pPr>
-            <a:r>
-              <a:rPr sz="1700">
-                <a:solidFill>
-                  <a:srgbClr val="0B1220"/>
-                </a:solidFill>
-                <a:latin typeface="Arial"/>
-              </a:rPr>
-              <a:t>•  Data: CGMacros 1.0.0, Gutierrez-Osuna, Kerr, Mortazavi, Das (2025), PhysioNet, doi:10.13026/3z8q-x658, CC BY-NC-SA 4.0; ShanghaiT2DM, Zhao, Zhu, Wang, Rao (2022), figshare, doi:10.6084/m9.figshare.21600933.v5, CC BY 4.0.</a:t>
-            </a:r>
-          </a:p>
-          <a:p>
-            <a:pPr>
-              <a:spcAft>
-                <a:spcPts val="1000"/>
-              </a:spcAft>
-            </a:pPr>
-            <a:r>
-              <a:rPr sz="1700">
-                <a:solidFill>
-                  <a:srgbClr val="0B1220"/>
-                </a:solidFill>
-                <a:latin typeface="Arial"/>
-              </a:rPr>
-              <a:t>•  Serving results: experiment gt-primary-2026-10-13-fusion, reports/evaluation_report.md. Research (not served): README §7, docs/judge_guide.md, reports/constrained_study.md, reports/foundation_baseline.md, reports/two_hour_external.md. Every selected claim: reports/evidence_manifest.md.</a:t>
             </a:r>
           </a:p>
         </p:txBody>
@@ -9415,7 +6359,7 @@
                 </a:solidFill>
                 <a:latin typeface="Arial"/>
               </a:rPr>
-              <a:t>•  Every record carries observed_at and available_at; a forecast at t uses only records with both ≤ t.</a:t>
+              <a:t>•  A forecast at time t uses only records observed and available by t.</a:t>
             </a:r>
           </a:p>
           <a:p>
@@ -9431,7 +6375,7 @@
                 </a:solidFill>
                 <a:latin typeface="Arial"/>
               </a:rPr>
-              <a:t>•  Meals excluded from the primary model (logging time unknown); tested separately as an optimistic sensitivity.</a:t>
+              <a:t>•  Meals left out of the main model (logging time unknown); tested separately.</a:t>
             </a:r>
           </a:p>
           <a:p>
@@ -9447,7 +6391,7 @@
                 </a:solidFill>
                 <a:latin typeface="Arial"/>
               </a:rPr>
-              <a:t>•  Protocol frozen before fitting; model, adaptation, intervals and alert threshold chosen on validation. Results shown (gt-primary-2026-10-13-fusion) re-run gt-primary-2026-10-11-v2's protocol with one change, declared after its test segment had been inspected: the serving model must read the baseline profile and the wearable streams.</a:t>
+              <a:t>•  Protocol frozen before fitting; choices made on validation. The fusion re-run (gt-primary-2026-10-13-fusion) was declared after gt-primary-2026-10-11-v2's test had been inspected.</a:t>
             </a:r>
           </a:p>
           <a:p>
@@ -9463,7 +6407,7 @@
                 </a:solidFill>
                 <a:latin typeface="Arial"/>
               </a:rPr>
-              <a:t>•  Adaptation uses a residual only after its target reading was available; missing future data is censored, never negative.</a:t>
+              <a:t>•  The patient correction learns only from forecasts whose outcome was already observed.</a:t>
             </a:r>
           </a:p>
         </p:txBody>
@@ -12509,7 +9453,7 @@
                 </a:solidFill>
                 <a:latin typeface="Arial"/>
               </a:rPr>
-              <a:t>•  Fusion: the serving model reads 38 dynamic features (CGM history, wearable heart rate and activity) and 8 static baseline profile values (age, sex, BMI, HbA1c, fasting glucose and insulin, triglycerides, HDL) in one model.</a:t>
+              <a:t>•  Fusion: 38 dynamic features (CGM, heart rate, activity) + 8 baseline profile values (age, sex, BMI, HbA1c, labs) in one model.</a:t>
             </a:r>
           </a:p>
           <a:p>
@@ -12525,7 +9469,7 @@
                 </a:solidFill>
                 <a:latin typeface="Arial"/>
               </a:rPr>
-              <a:t>•  Baselines: persistence, bounded linear trend, ridge regression.</a:t>
+              <a:t>•  Baselines: persistence, linear trend, ridge. Learners: LightGBM and CatBoost, same search budget.</a:t>
             </a:r>
           </a:p>
           <a:p>
@@ -12541,7 +9485,7 @@
                 </a:solidFill>
                 <a:latin typeface="Arial"/>
               </a:rPr>
-              <a:t>•  Direct per-horizon gradient-boosted trees: LightGBM (starting point) and CatBoost (challenger), equal 12-trial seeded searches, identical inputs and origins.</a:t>
+              <a:t>•  Patient correction: a bounded mean of this person's observed errors; model weights never refit.</a:t>
             </a:r>
           </a:p>
           <a:p>
@@ -12557,7 +9501,7 @@
                 </a:solidFill>
                 <a:latin typeface="Arial"/>
               </a:rPr>
-              <a:t>•  Patient adaptation (same policy for both families): shrunk, bounded, decaying mean of matured residuals vs the frozen population forecast; weights never refit.</a:t>
+              <a:t>•  80 % prediction ranges (split-conformal), calibrated for the exact serving pipeline.</a:t>
             </a:r>
           </a:p>
           <a:p>
@@ -12573,23 +9517,7 @@
                 </a:solidFill>
                 <a:latin typeface="Arial"/>
               </a:rPr>
-              <a:t>•  Prediction ranges: split-conformal, target coverage 80 %, calibrated on the calibration segment for the exact serving pipeline.</a:t>
-            </a:r>
-          </a:p>
-          <a:p>
-            <a:pPr>
-              <a:spcAft>
-                <a:spcPts val="1000"/>
-              </a:spcAft>
-            </a:pPr>
-            <a:r>
-              <a:rPr sz="1700">
-                <a:solidFill>
-                  <a:srgbClr val="0B1220"/>
-                </a:solidFill>
-                <a:latin typeface="Arial"/>
-              </a:rPr>
-              <a:t>•  Warning: max forecast within 60 min − 180 mg/dL — an uncalibrated score, never shown as a probability.</a:t>
+              <a:t>•  Warning score: highest forecast in the next 60 min minus 180 mg/dL — not a probability.</a:t>
             </a:r>
           </a:p>
         </p:txBody>
@@ -13576,7 +10504,7 @@
                 </a:solidFill>
                 <a:latin typeface="Arial"/>
               </a:rPr>
-              <a:t>Declared rule: lowest mean per-participant MAE over both horizons; candidates within 0.5 mg/dL tie → simpler family, then smaller feature set. Eligible for serving: dyn-prof-v2 only (profile + wearable), a constraint added on 2026-10-13 after the test segment had been inspected, to meet the fusion requirement. Selected: lightgbm:dyn-prof-v2 with patient adaptation. Without the constraint the same rule picks lightgbm:dyn-v2 (the earlier model, gt-primary-2026-10-11-v2).</a:t>
+              <a:t>Rule: lowest mean per-participant validation MAE over both horizons; within 0.5 mg/dL → simpler model. Only dyn-prof-v2 (profile + wearable) was eligible, to meet the fusion requirement — a constraint added on 2026-10-13, after the test segment had been inspected. Selected: lightgbm:dyn-prof-v2 with patient correction. Without the constraint the rule picks lightgbm:dyn-v2 (gt-primary-2026-10-11-v2).</a:t>
             </a:r>
           </a:p>
         </p:txBody>

</xml_diff>

<commit_message>
links: online copy of the research workbook (Google Sheets, opens signed out) on slide 15, README §11, judge guide and team folder
</commit_message>
<xml_diff>
--- a/docs/submission/GlucoTwin_Presentation.pptx
+++ b/docs/submission/GlucoTwin_Presentation.pptx
@@ -5310,6 +5310,22 @@
                 <a:latin typeface="Arial"/>
               </a:rPr>
               <a:t>•  Evidence: docs/judge_guide.md · reports/evidence_manifest.md · docs/submission/GlucoTwin_Research_Workbook.xlsx.</a:t>
+            </a:r>
+          </a:p>
+          <a:p>
+            <a:pPr>
+              <a:spcAft>
+                <a:spcPts val="1000"/>
+              </a:spcAft>
+            </a:pPr>
+            <a:r>
+              <a:rPr sz="1700">
+                <a:solidFill>
+                  <a:srgbClr val="0B1220"/>
+                </a:solidFill>
+                <a:latin typeface="Arial"/>
+              </a:rPr>
+              <a:t>•  Research workbook (every claim → its source): https://docs.google.com/spreadsheets/d/1u06FJSwKpWywDKrE9fGa2ZzivmY3eSLE/edit?usp=sharing</a:t>
             </a:r>
           </a:p>
         </p:txBody>

</xml_diff>

<commit_message>
links: unlisted demo video (19:21 on YouTube) and public repository URL in README §8 and checklist, slide 15, team folder, judge guide and submission config; deck, workbook and access audit regenerated
</commit_message>
<xml_diff>
--- a/docs/submission/GlucoTwin_Presentation.pptx
+++ b/docs/submission/GlucoTwin_Presentation.pptx
@@ -5261,7 +5261,7 @@
                 </a:solidFill>
                 <a:latin typeface="Arial"/>
               </a:rPr>
-              <a:t>•  Code: public GitHub link — added after the team publishes the repository — MIT license (code only). Quick start: make setup · make synthetic · make dev.</a:t>
+              <a:t>•  Code: https://github.com/Avi36005/DigitalTwin-Challenge-Kryptonite — MIT license (code only). Quick start: make setup · make synthetic · make dev.</a:t>
             </a:r>
           </a:p>
           <a:p>
@@ -5277,7 +5277,7 @@
                 </a:solidFill>
                 <a:latin typeface="Arial"/>
               </a:rPr>
-              <a:t>•  Demo video: unlisted YouTube link — added after recording and upload.</a:t>
+              <a:t>•  Demo video: https://youtu.be/SPaCWZINta0.</a:t>
             </a:r>
           </a:p>
           <a:p>

</xml_diff>